<commit_message>
Use Kev-4B curriculum with required optimized training kernels
</commit_message>
<xml_diff>
--- a/labs/lab-01-kev-pacman/slides/pacman-lab.pptx
+++ b/labs/lab-01-kev-pacman/slides/pacman-lab.pptx
@@ -1069,182 +1069,7 @@
             </a:pPr>
             <a:r>
               <a:rPr lang="zh-CN"/>
-              <a:t>The main lab follows Kev's published small-model recipe. Start with the pinned, already pretrained Qwen3.5-0.8B base, fresh rank-16 LoRA (alpha 32) and a fresh pointer head. Initial decision-v7 training belongs in prework. Class domain adaptation uses --init_from the learner's own initial checkpoint and Pac-Man labels. This is supervised imitation of player moves. Ghosts follow deterministic game code. Original base matrices remain frozen but LoRA changes the effective representation. The released model also has dates, documents/skills and calibration stages, which this exercise does not reproduce. Training and live browser timing still require a GPU preflight.</a:t>
-            </a:r>
-            <a:endParaRPr/>
-          </a:p>
-          <a:p>
-            <a:pPr indent="0" lvl="0" marL="0" rtl="0" algn="l">
-              <a:spcBef>
-                <a:spcPts val="0"/>
-              </a:spcBef>
-              <a:spcAft>
-                <a:spcPts val="0"/>
-              </a:spcAft>
-              <a:buNone/>
-            </a:pPr>
-            <a:r>
-              <a:rPr lang="zh-CN"/>
-              <a:t>Sources: https://github.com/jaredpalmer/kev/blob/84847f0a883d900f7de5b7a57eaa341ca7f9a6b4/docs/model-cards/kev-0.8b.md ; lab/notebooks/pacman_kev_lab.ipynb.</a:t>
-            </a:r>
-            <a:endParaRPr/>
-          </a:p>
-          <a:p>
-            <a:pPr indent="0" lvl="0" marL="0" rtl="0" algn="l">
-              <a:spcBef>
-                <a:spcPts val="0"/>
-              </a:spcBef>
-              <a:spcAft>
-                <a:spcPts val="0"/>
-              </a:spcAft>
-              <a:buNone/>
-            </a:pPr>
-            <a:r>
-              <a:t/>
-            </a:r>
-            <a:endParaRPr/>
-          </a:p>
-          <a:p>
-            <a:pPr indent="0" lvl="0" marL="0" rtl="0" algn="l">
-              <a:spcBef>
-                <a:spcPts val="0"/>
-              </a:spcBef>
-              <a:spcAft>
-                <a:spcPts val="0"/>
-              </a:spcAft>
-              <a:buNone/>
-            </a:pPr>
-            <a:r>
-              <a:rPr lang="zh-CN"/>
-              <a:t>Reference URLs checked October 2, 2026:</a:t>
-            </a:r>
-            <a:endParaRPr/>
-          </a:p>
-          <a:p>
-            <a:pPr indent="0" lvl="0" marL="0" rtl="0" algn="l">
-              <a:spcBef>
-                <a:spcPts val="0"/>
-              </a:spcBef>
-              <a:spcAft>
-                <a:spcPts val="0"/>
-              </a:spcAft>
-              <a:buNone/>
-            </a:pPr>
-            <a:r>
-              <a:rPr lang="zh-CN"/>
-              <a:t>https://github.com/jaredpalmer/kev/tree/84847f0a883d900f7de5b7a57eaa341ca7f9a6b4</a:t>
-            </a:r>
-            <a:endParaRPr/>
-          </a:p>
-          <a:p>
-            <a:pPr indent="0" lvl="0" marL="0" rtl="0" algn="l">
-              <a:spcBef>
-                <a:spcPts val="0"/>
-              </a:spcBef>
-              <a:spcAft>
-                <a:spcPts val="0"/>
-              </a:spcAft>
-              <a:buNone/>
-            </a:pPr>
-            <a:r>
-              <a:rPr lang="zh-CN"/>
-              <a:t>https://github.com/Contrastive-LM/CLM/tree/bb42c6c5bf914fd449bed2f6ca65be80602cb1f7</a:t>
-            </a:r>
-            <a:endParaRPr/>
-          </a:p>
-          <a:p>
-            <a:pPr indent="0" lvl="0" marL="0" rtl="0" algn="l">
-              <a:spcBef>
-                <a:spcPts val="0"/>
-              </a:spcBef>
-              <a:spcAft>
-                <a:spcPts val="0"/>
-              </a:spcAft>
-              <a:buNone/>
-            </a:pPr>
-            <a:r>
-              <a:rPr lang="zh-CN"/>
-              <a:t>https://github.com/Contrastive-LM/CLM/blob/bb42c6c5bf914fd449bed2f6ca65be80602cb1f7/src/clm/heads.py</a:t>
-            </a:r>
-            <a:endParaRPr/>
-          </a:p>
-          <a:p>
-            <a:pPr indent="0" lvl="0" marL="0" rtl="0" algn="l">
-              <a:spcBef>
-                <a:spcPts val="0"/>
-              </a:spcBef>
-              <a:spcAft>
-                <a:spcPts val="0"/>
-              </a:spcAft>
-              <a:buNone/>
-            </a:pPr>
-            <a:r>
-              <a:rPr lang="zh-CN"/>
-              <a:t>https://github.com/Contrastive-LM/CLM/blob/bb42c6c5bf914fd449bed2f6ca65be80602cb1f7/train/finetune.py</a:t>
-            </a:r>
-            <a:endParaRPr/>
-          </a:p>
-          <a:p>
-            <a:pPr indent="0" lvl="0" marL="0" rtl="0" algn="l">
-              <a:spcBef>
-                <a:spcPts val="0"/>
-              </a:spcBef>
-              <a:spcAft>
-                <a:spcPts val="0"/>
-              </a:spcAft>
-              <a:buNone/>
-            </a:pPr>
-            <a:r>
-              <a:rPr lang="zh-CN"/>
-              <a:t>https://github.com/jaredpalmer/kev/blob/84847f0a883d900f7de5b7a57eaa341ca7f9a6b4/kev/model.py</a:t>
-            </a:r>
-            <a:endParaRPr/>
-          </a:p>
-          <a:p>
-            <a:pPr indent="0" lvl="0" marL="0" rtl="0" algn="l">
-              <a:spcBef>
-                <a:spcPts val="0"/>
-              </a:spcBef>
-              <a:spcAft>
-                <a:spcPts val="0"/>
-              </a:spcAft>
-              <a:buNone/>
-            </a:pPr>
-            <a:r>
-              <a:rPr lang="zh-CN"/>
-              <a:t>https://huggingface.co/blog/ggml-org/decision-models-in-llamacpp</a:t>
-            </a:r>
-            <a:endParaRPr/>
-          </a:p>
-          <a:p>
-            <a:pPr indent="0" lvl="0" marL="0" rtl="0" algn="l">
-              <a:spcBef>
-                <a:spcPts val="0"/>
-              </a:spcBef>
-              <a:spcAft>
-                <a:spcPts val="0"/>
-              </a:spcAft>
-              <a:buNone/>
-            </a:pPr>
-            <a:r>
-              <a:rPr lang="zh-CN"/>
-              <a:t>https://github.com/ggml-org/llama.cpp/pull/29818</a:t>
-            </a:r>
-            <a:endParaRPr/>
-          </a:p>
-          <a:p>
-            <a:pPr indent="0" lvl="0" marL="0" rtl="0" algn="l">
-              <a:spcBef>
-                <a:spcPts val="0"/>
-              </a:spcBef>
-              <a:spcAft>
-                <a:spcPts val="0"/>
-              </a:spcAft>
-              <a:buNone/>
-            </a:pPr>
-            <a:r>
-              <a:rPr lang="zh-CN"/>
-              <a:t>CLM article: supplied Contrastive Language Models PDF, pages 6-8; https://contrastive-lm.notion.site/</a:t>
+              <a:t>The main lab uses Qwen/Qwen3.5-4B-Base@1001bb4d826a52d1f399e183466143f4da7b741b, fresh rank-16 LoRA (alpha 32) targeting all projections and a 256-dimensional pointer head. Follow the four general training stages in Kev-4B's released curriculum, each in a separate notebook cell and checkpoint. Stage 5 warm-starts the learner's skills checkpoint for Pac-Man imitation. The original base matrices remain fixed while LoRA changes effective features. Calibration is separate and is not fitted or copied from the release. A 0.8B adapter cannot initialize the 4B model. Sources: https://huggingface.co/jaredpalmer/kev-4b ; https://github.com/jaredpalmer/kev/blob/84847f0a883d900f7de5b7a57eaa341ca7f9a6b4/experiments/q35-4b-s23.json</a:t>
             </a:r>
             <a:endParaRPr/>
           </a:p>
@@ -1344,166 +1169,7 @@
             </a:pPr>
             <a:r>
               <a:rPr lang="zh-CN"/>
-              <a:t>Installation, verified training-data/base downloads and the full initial decision-v7 run are prework. This preserves the published two-epoch recipe while retaining a 90-minute class and mandatory 30-minute domain fine-tuning block. Class CP1 inspects the fresh-training checkpoint, configuration and parameter audit. CP3 allocates 5 minutes to inspect data/loss, up to 20 minutes to run adaptation, and 5 minutes to inspect/save. Classroom budgets are scheduling assumptions pending measured GPU preflight, not benchmark predictions.</a:t>
-            </a:r>
-            <a:endParaRPr/>
-          </a:p>
-          <a:p>
-            <a:pPr indent="0" lvl="0" marL="0" rtl="0" algn="l">
-              <a:spcBef>
-                <a:spcPts val="0"/>
-              </a:spcBef>
-              <a:spcAft>
-                <a:spcPts val="0"/>
-              </a:spcAft>
-              <a:buNone/>
-            </a:pPr>
-            <a:r>
-              <a:t/>
-            </a:r>
-            <a:endParaRPr/>
-          </a:p>
-          <a:p>
-            <a:pPr indent="0" lvl="0" marL="0" rtl="0" algn="l">
-              <a:spcBef>
-                <a:spcPts val="0"/>
-              </a:spcBef>
-              <a:spcAft>
-                <a:spcPts val="0"/>
-              </a:spcAft>
-              <a:buNone/>
-            </a:pPr>
-            <a:r>
-              <a:rPr lang="zh-CN"/>
-              <a:t>Reference URLs checked October 2, 2026:</a:t>
-            </a:r>
-            <a:endParaRPr/>
-          </a:p>
-          <a:p>
-            <a:pPr indent="0" lvl="0" marL="0" rtl="0" algn="l">
-              <a:spcBef>
-                <a:spcPts val="0"/>
-              </a:spcBef>
-              <a:spcAft>
-                <a:spcPts val="0"/>
-              </a:spcAft>
-              <a:buNone/>
-            </a:pPr>
-            <a:r>
-              <a:rPr lang="zh-CN"/>
-              <a:t>https://github.com/jaredpalmer/kev/tree/84847f0a883d900f7de5b7a57eaa341ca7f9a6b4</a:t>
-            </a:r>
-            <a:endParaRPr/>
-          </a:p>
-          <a:p>
-            <a:pPr indent="0" lvl="0" marL="0" rtl="0" algn="l">
-              <a:spcBef>
-                <a:spcPts val="0"/>
-              </a:spcBef>
-              <a:spcAft>
-                <a:spcPts val="0"/>
-              </a:spcAft>
-              <a:buNone/>
-            </a:pPr>
-            <a:r>
-              <a:rPr lang="zh-CN"/>
-              <a:t>https://github.com/Contrastive-LM/CLM/tree/bb42c6c5bf914fd449bed2f6ca65be80602cb1f7</a:t>
-            </a:r>
-            <a:endParaRPr/>
-          </a:p>
-          <a:p>
-            <a:pPr indent="0" lvl="0" marL="0" rtl="0" algn="l">
-              <a:spcBef>
-                <a:spcPts val="0"/>
-              </a:spcBef>
-              <a:spcAft>
-                <a:spcPts val="0"/>
-              </a:spcAft>
-              <a:buNone/>
-            </a:pPr>
-            <a:r>
-              <a:rPr lang="zh-CN"/>
-              <a:t>https://github.com/Contrastive-LM/CLM/blob/bb42c6c5bf914fd449bed2f6ca65be80602cb1f7/src/clm/heads.py</a:t>
-            </a:r>
-            <a:endParaRPr/>
-          </a:p>
-          <a:p>
-            <a:pPr indent="0" lvl="0" marL="0" rtl="0" algn="l">
-              <a:spcBef>
-                <a:spcPts val="0"/>
-              </a:spcBef>
-              <a:spcAft>
-                <a:spcPts val="0"/>
-              </a:spcAft>
-              <a:buNone/>
-            </a:pPr>
-            <a:r>
-              <a:rPr lang="zh-CN"/>
-              <a:t>https://github.com/Contrastive-LM/CLM/blob/bb42c6c5bf914fd449bed2f6ca65be80602cb1f7/train/finetune.py</a:t>
-            </a:r>
-            <a:endParaRPr/>
-          </a:p>
-          <a:p>
-            <a:pPr indent="0" lvl="0" marL="0" rtl="0" algn="l">
-              <a:spcBef>
-                <a:spcPts val="0"/>
-              </a:spcBef>
-              <a:spcAft>
-                <a:spcPts val="0"/>
-              </a:spcAft>
-              <a:buNone/>
-            </a:pPr>
-            <a:r>
-              <a:rPr lang="zh-CN"/>
-              <a:t>https://github.com/jaredpalmer/kev/blob/84847f0a883d900f7de5b7a57eaa341ca7f9a6b4/kev/model.py</a:t>
-            </a:r>
-            <a:endParaRPr/>
-          </a:p>
-          <a:p>
-            <a:pPr indent="0" lvl="0" marL="0" rtl="0" algn="l">
-              <a:spcBef>
-                <a:spcPts val="0"/>
-              </a:spcBef>
-              <a:spcAft>
-                <a:spcPts val="0"/>
-              </a:spcAft>
-              <a:buNone/>
-            </a:pPr>
-            <a:r>
-              <a:rPr lang="zh-CN"/>
-              <a:t>https://huggingface.co/blog/ggml-org/decision-models-in-llamacpp</a:t>
-            </a:r>
-            <a:endParaRPr/>
-          </a:p>
-          <a:p>
-            <a:pPr indent="0" lvl="0" marL="0" rtl="0" algn="l">
-              <a:spcBef>
-                <a:spcPts val="0"/>
-              </a:spcBef>
-              <a:spcAft>
-                <a:spcPts val="0"/>
-              </a:spcAft>
-              <a:buNone/>
-            </a:pPr>
-            <a:r>
-              <a:rPr lang="zh-CN"/>
-              <a:t>https://github.com/ggml-org/llama.cpp/pull/29818</a:t>
-            </a:r>
-            <a:endParaRPr/>
-          </a:p>
-          <a:p>
-            <a:pPr indent="0" lvl="0" marL="0" rtl="0" algn="l">
-              <a:spcBef>
-                <a:spcPts val="0"/>
-              </a:spcBef>
-              <a:spcAft>
-                <a:spcPts val="0"/>
-              </a:spcAft>
-              <a:buNone/>
-            </a:pPr>
-            <a:r>
-              <a:rPr lang="zh-CN"/>
-              <a:t>CLM article: supplied Contrastive Language Models PDF, pages 6-8; https://contrastive-lm.notion.site/</a:t>
+              <a:t>Installation, optimized-kernel verification, downloads and all four general decision stages are prework. Keep 90 minutes in class with a mandatory 30-minute Pac-Man fine-tuning block: inspect for 5 minutes, train within a 20-minute attempt cap, inspect/save for 5 minutes. These are scheduling budgets, not measured training durations. Check the separate initial, dates, documents and skills configurations and TensorBoard curves. Source: https://github.com/yxc20089/QPlusLearning/tree/main/labs/lab-01-kev-pacman</a:t>
             </a:r>
             <a:endParaRPr/>
           </a:p>
@@ -1603,182 +1269,7 @@
             </a:pPr>
             <a:r>
               <a:rPr lang="zh-CN"/>
-              <a:t>The teaching assumption is one RTX PRO 6000 Blackwell GPU in Colab. NVIDIA specifies 96 GB for the full Server Edition. Record actual device name and allocated memory instead of assuming the full physical card. Colab premium GPU availability varies, including on paid plans. Learners arrange access before class and record compute units consumed and elapsed time. cloud_runtime.py installs pinned Kev with uv --frozen into a separate Python 3.13 environment, tests CUDA forward/backward and BF16, and writes runtime-preflight.json. Initial training uses BF16 autocast over FP32 stored weights, with FP32 LoRA/head. Inference uses BF16. This is the verified reference implementation path without optional fused kernels/CUDA graphs; measure its timing rather than inheriting release serving benchmarks. The pinned CUDA 12.8 build does not support P100/Pascal. A separately timed T4 fallback needs a prepared initial checkpoint and FP32 domain adaptation. Live browser uses the Colab callback to loopback, without a public endpoint.</a:t>
-            </a:r>
-            <a:endParaRPr/>
-          </a:p>
-          <a:p>
-            <a:pPr indent="0" lvl="0" marL="0" rtl="0" algn="l">
-              <a:spcBef>
-                <a:spcPts val="0"/>
-              </a:spcBef>
-              <a:spcAft>
-                <a:spcPts val="0"/>
-              </a:spcAft>
-              <a:buNone/>
-            </a:pPr>
-            <a:r>
-              <a:rPr lang="zh-CN"/>
-              <a:t>Sources: https://research.google.com/colaboratory/faq.html ; https://www.nvidia.com/en-us/data-center/rtx-pro-6000-blackwell-server-edition/ ; https://pytorch.org/blog/pytorch-2-7/ ; https://dev-discuss.pytorch.org/t/cuda-toolkit-version-and-architecture-support-update-maxwell-and-pascal-architecture-support-removed-in-cuda-12-8-and-12-9-builds/3128 ; lab/cloud_runtime.py.</a:t>
-            </a:r>
-            <a:endParaRPr/>
-          </a:p>
-          <a:p>
-            <a:pPr indent="0" lvl="0" marL="0" rtl="0" algn="l">
-              <a:spcBef>
-                <a:spcPts val="0"/>
-              </a:spcBef>
-              <a:spcAft>
-                <a:spcPts val="0"/>
-              </a:spcAft>
-              <a:buNone/>
-            </a:pPr>
-            <a:r>
-              <a:t/>
-            </a:r>
-            <a:endParaRPr/>
-          </a:p>
-          <a:p>
-            <a:pPr indent="0" lvl="0" marL="0" rtl="0" algn="l">
-              <a:spcBef>
-                <a:spcPts val="0"/>
-              </a:spcBef>
-              <a:spcAft>
-                <a:spcPts val="0"/>
-              </a:spcAft>
-              <a:buNone/>
-            </a:pPr>
-            <a:r>
-              <a:rPr lang="zh-CN"/>
-              <a:t>Reference URLs checked October 2, 2026:</a:t>
-            </a:r>
-            <a:endParaRPr/>
-          </a:p>
-          <a:p>
-            <a:pPr indent="0" lvl="0" marL="0" rtl="0" algn="l">
-              <a:spcBef>
-                <a:spcPts val="0"/>
-              </a:spcBef>
-              <a:spcAft>
-                <a:spcPts val="0"/>
-              </a:spcAft>
-              <a:buNone/>
-            </a:pPr>
-            <a:r>
-              <a:rPr lang="zh-CN"/>
-              <a:t>https://github.com/jaredpalmer/kev/tree/84847f0a883d900f7de5b7a57eaa341ca7f9a6b4</a:t>
-            </a:r>
-            <a:endParaRPr/>
-          </a:p>
-          <a:p>
-            <a:pPr indent="0" lvl="0" marL="0" rtl="0" algn="l">
-              <a:spcBef>
-                <a:spcPts val="0"/>
-              </a:spcBef>
-              <a:spcAft>
-                <a:spcPts val="0"/>
-              </a:spcAft>
-              <a:buNone/>
-            </a:pPr>
-            <a:r>
-              <a:rPr lang="zh-CN"/>
-              <a:t>https://github.com/Contrastive-LM/CLM/tree/bb42c6c5bf914fd449bed2f6ca65be80602cb1f7</a:t>
-            </a:r>
-            <a:endParaRPr/>
-          </a:p>
-          <a:p>
-            <a:pPr indent="0" lvl="0" marL="0" rtl="0" algn="l">
-              <a:spcBef>
-                <a:spcPts val="0"/>
-              </a:spcBef>
-              <a:spcAft>
-                <a:spcPts val="0"/>
-              </a:spcAft>
-              <a:buNone/>
-            </a:pPr>
-            <a:r>
-              <a:rPr lang="zh-CN"/>
-              <a:t>https://github.com/Contrastive-LM/CLM/blob/bb42c6c5bf914fd449bed2f6ca65be80602cb1f7/src/clm/heads.py</a:t>
-            </a:r>
-            <a:endParaRPr/>
-          </a:p>
-          <a:p>
-            <a:pPr indent="0" lvl="0" marL="0" rtl="0" algn="l">
-              <a:spcBef>
-                <a:spcPts val="0"/>
-              </a:spcBef>
-              <a:spcAft>
-                <a:spcPts val="0"/>
-              </a:spcAft>
-              <a:buNone/>
-            </a:pPr>
-            <a:r>
-              <a:rPr lang="zh-CN"/>
-              <a:t>https://github.com/Contrastive-LM/CLM/blob/bb42c6c5bf914fd449bed2f6ca65be80602cb1f7/train/finetune.py</a:t>
-            </a:r>
-            <a:endParaRPr/>
-          </a:p>
-          <a:p>
-            <a:pPr indent="0" lvl="0" marL="0" rtl="0" algn="l">
-              <a:spcBef>
-                <a:spcPts val="0"/>
-              </a:spcBef>
-              <a:spcAft>
-                <a:spcPts val="0"/>
-              </a:spcAft>
-              <a:buNone/>
-            </a:pPr>
-            <a:r>
-              <a:rPr lang="zh-CN"/>
-              <a:t>https://github.com/jaredpalmer/kev/blob/84847f0a883d900f7de5b7a57eaa341ca7f9a6b4/kev/model.py</a:t>
-            </a:r>
-            <a:endParaRPr/>
-          </a:p>
-          <a:p>
-            <a:pPr indent="0" lvl="0" marL="0" rtl="0" algn="l">
-              <a:spcBef>
-                <a:spcPts val="0"/>
-              </a:spcBef>
-              <a:spcAft>
-                <a:spcPts val="0"/>
-              </a:spcAft>
-              <a:buNone/>
-            </a:pPr>
-            <a:r>
-              <a:rPr lang="zh-CN"/>
-              <a:t>https://huggingface.co/blog/ggml-org/decision-models-in-llamacpp</a:t>
-            </a:r>
-            <a:endParaRPr/>
-          </a:p>
-          <a:p>
-            <a:pPr indent="0" lvl="0" marL="0" rtl="0" algn="l">
-              <a:spcBef>
-                <a:spcPts val="0"/>
-              </a:spcBef>
-              <a:spcAft>
-                <a:spcPts val="0"/>
-              </a:spcAft>
-              <a:buNone/>
-            </a:pPr>
-            <a:r>
-              <a:rPr lang="zh-CN"/>
-              <a:t>https://github.com/ggml-org/llama.cpp/pull/29818</a:t>
-            </a:r>
-            <a:endParaRPr/>
-          </a:p>
-          <a:p>
-            <a:pPr indent="0" lvl="0" marL="0" rtl="0" algn="l">
-              <a:spcBef>
-                <a:spcPts val="0"/>
-              </a:spcBef>
-              <a:spcAft>
-                <a:spcPts val="0"/>
-              </a:spcAft>
-              <a:buNone/>
-            </a:pPr>
-            <a:r>
-              <a:rPr lang="zh-CN"/>
-              <a:t>CLM article: supplied Contrastive Language Models PDF, pages 6-8; https://contrastive-lm.notion.site/</a:t>
+              <a:t>Kev-4B retains a hybrid Gated DeltaNet/full-attention backbone. Install hash-pinned flash-linear-attention/fla-core 0.5.2, causal-conv1d 1.7.0 (cp313, Torch 2.8, CUDA 12, Linux x86_64 CXX11 ABI), einops 0.8.1 and Ninja 1.13.0 without replacing Kev's frozen Torch 2.8.0/CUDA 12.8, Triton 3.4.0, Transformers 5.17.0 and PEFT stack. Require BF16 and verify actual loss/backward/LoRA-head gradients plus fused AdamW on two suite records. Reference-kernel fallback fails the check. This checks compatibility rather than full-stage memory or timing. Default execution: batch 1 × accumulation 8, non-reentrant checkpointing, row_budget 2048; full attention uses SDPA. Inference-only Kev fusion/CUDA graphs remain disabled for training. The course has no completed GPU run of this 4B setup. Colab allocation varies, including on paid plans; arrange access and measure compute-unit cost. T4/P100 do not satisfy this optimized training contract. Sources: https://huggingface.co/docs/transformers/en/model_doc/qwen3_5 ; https://github.com/fla-org/flash-linear-attention/releases/tag/v0.5.2 ; https://github.com/Dao-AILab/causal-conv1d/releases/tag/v1.7.0 ; https://research.google.com/colaboratory/faq.html</a:t>
             </a:r>
             <a:endParaRPr/>
           </a:p>
@@ -2978,182 +2469,7 @@
             </a:pPr>
             <a:r>
               <a:rPr lang="zh-CN"/>
-              <a:t>The notebook calls unchanged upstream kev.train and reads the selected seed-2 configuration from experiments/q35-08b.json at the pinned code commit. Base Qwen/Qwen3.5-0.8B-Base revision dc7cdfe2ee4154fa7e30f5b51ca41bfa40174e68. LoRA rank 16 alpha 32 on attention, MLP and DeltaNet projections, pointer dimension 256, batch 8, accumulation 1, two epochs, learning rate 1e-4, AdamW/OneCycleLR, BF16 autocast over FP32 weights. Default option-order/none/distractor augmentation and p_none_pair=0.25 are retained. Upstream suite loader fetches train data from its pinned Hub mirror and verifies manifest checksum/count. No decision adapter/head warm start. The full initial run is prework, with a configurable 90-minute attempt cap. The model card's ~20-minute base run used an H100. No RTX PRO 6000 training time has been measured here. This reproduces the base stage rather than the later full released curriculum.</a:t>
-            </a:r>
-            <a:endParaRPr/>
-          </a:p>
-          <a:p>
-            <a:pPr indent="0" lvl="0" marL="0" rtl="0" algn="l">
-              <a:spcBef>
-                <a:spcPts val="0"/>
-              </a:spcBef>
-              <a:spcAft>
-                <a:spcPts val="0"/>
-              </a:spcAft>
-              <a:buNone/>
-            </a:pPr>
-            <a:r>
-              <a:rPr lang="zh-CN"/>
-              <a:t>Sources: https://github.com/jaredpalmer/kev/blob/84847f0a883d900f7de5b7a57eaa341ca7f9a6b4/experiments/q35-08b.json ; pinned Kev train.py, suite.py and model card.</a:t>
-            </a:r>
-            <a:endParaRPr/>
-          </a:p>
-          <a:p>
-            <a:pPr indent="0" lvl="0" marL="0" rtl="0" algn="l">
-              <a:spcBef>
-                <a:spcPts val="0"/>
-              </a:spcBef>
-              <a:spcAft>
-                <a:spcPts val="0"/>
-              </a:spcAft>
-              <a:buNone/>
-            </a:pPr>
-            <a:r>
-              <a:t/>
-            </a:r>
-            <a:endParaRPr/>
-          </a:p>
-          <a:p>
-            <a:pPr indent="0" lvl="0" marL="0" rtl="0" algn="l">
-              <a:spcBef>
-                <a:spcPts val="0"/>
-              </a:spcBef>
-              <a:spcAft>
-                <a:spcPts val="0"/>
-              </a:spcAft>
-              <a:buNone/>
-            </a:pPr>
-            <a:r>
-              <a:rPr lang="zh-CN"/>
-              <a:t>Reference URLs checked October 2, 2026:</a:t>
-            </a:r>
-            <a:endParaRPr/>
-          </a:p>
-          <a:p>
-            <a:pPr indent="0" lvl="0" marL="0" rtl="0" algn="l">
-              <a:spcBef>
-                <a:spcPts val="0"/>
-              </a:spcBef>
-              <a:spcAft>
-                <a:spcPts val="0"/>
-              </a:spcAft>
-              <a:buNone/>
-            </a:pPr>
-            <a:r>
-              <a:rPr lang="zh-CN"/>
-              <a:t>https://github.com/jaredpalmer/kev/tree/84847f0a883d900f7de5b7a57eaa341ca7f9a6b4</a:t>
-            </a:r>
-            <a:endParaRPr/>
-          </a:p>
-          <a:p>
-            <a:pPr indent="0" lvl="0" marL="0" rtl="0" algn="l">
-              <a:spcBef>
-                <a:spcPts val="0"/>
-              </a:spcBef>
-              <a:spcAft>
-                <a:spcPts val="0"/>
-              </a:spcAft>
-              <a:buNone/>
-            </a:pPr>
-            <a:r>
-              <a:rPr lang="zh-CN"/>
-              <a:t>https://github.com/Contrastive-LM/CLM/tree/bb42c6c5bf914fd449bed2f6ca65be80602cb1f7</a:t>
-            </a:r>
-            <a:endParaRPr/>
-          </a:p>
-          <a:p>
-            <a:pPr indent="0" lvl="0" marL="0" rtl="0" algn="l">
-              <a:spcBef>
-                <a:spcPts val="0"/>
-              </a:spcBef>
-              <a:spcAft>
-                <a:spcPts val="0"/>
-              </a:spcAft>
-              <a:buNone/>
-            </a:pPr>
-            <a:r>
-              <a:rPr lang="zh-CN"/>
-              <a:t>https://github.com/Contrastive-LM/CLM/blob/bb42c6c5bf914fd449bed2f6ca65be80602cb1f7/src/clm/heads.py</a:t>
-            </a:r>
-            <a:endParaRPr/>
-          </a:p>
-          <a:p>
-            <a:pPr indent="0" lvl="0" marL="0" rtl="0" algn="l">
-              <a:spcBef>
-                <a:spcPts val="0"/>
-              </a:spcBef>
-              <a:spcAft>
-                <a:spcPts val="0"/>
-              </a:spcAft>
-              <a:buNone/>
-            </a:pPr>
-            <a:r>
-              <a:rPr lang="zh-CN"/>
-              <a:t>https://github.com/Contrastive-LM/CLM/blob/bb42c6c5bf914fd449bed2f6ca65be80602cb1f7/train/finetune.py</a:t>
-            </a:r>
-            <a:endParaRPr/>
-          </a:p>
-          <a:p>
-            <a:pPr indent="0" lvl="0" marL="0" rtl="0" algn="l">
-              <a:spcBef>
-                <a:spcPts val="0"/>
-              </a:spcBef>
-              <a:spcAft>
-                <a:spcPts val="0"/>
-              </a:spcAft>
-              <a:buNone/>
-            </a:pPr>
-            <a:r>
-              <a:rPr lang="zh-CN"/>
-              <a:t>https://github.com/jaredpalmer/kev/blob/84847f0a883d900f7de5b7a57eaa341ca7f9a6b4/kev/model.py</a:t>
-            </a:r>
-            <a:endParaRPr/>
-          </a:p>
-          <a:p>
-            <a:pPr indent="0" lvl="0" marL="0" rtl="0" algn="l">
-              <a:spcBef>
-                <a:spcPts val="0"/>
-              </a:spcBef>
-              <a:spcAft>
-                <a:spcPts val="0"/>
-              </a:spcAft>
-              <a:buNone/>
-            </a:pPr>
-            <a:r>
-              <a:rPr lang="zh-CN"/>
-              <a:t>https://huggingface.co/blog/ggml-org/decision-models-in-llamacpp</a:t>
-            </a:r>
-            <a:endParaRPr/>
-          </a:p>
-          <a:p>
-            <a:pPr indent="0" lvl="0" marL="0" rtl="0" algn="l">
-              <a:spcBef>
-                <a:spcPts val="0"/>
-              </a:spcBef>
-              <a:spcAft>
-                <a:spcPts val="0"/>
-              </a:spcAft>
-              <a:buNone/>
-            </a:pPr>
-            <a:r>
-              <a:rPr lang="zh-CN"/>
-              <a:t>https://github.com/ggml-org/llama.cpp/pull/29818</a:t>
-            </a:r>
-            <a:endParaRPr/>
-          </a:p>
-          <a:p>
-            <a:pPr indent="0" lvl="0" marL="0" rtl="0" algn="l">
-              <a:spcBef>
-                <a:spcPts val="0"/>
-              </a:spcBef>
-              <a:spcAft>
-                <a:spcPts val="0"/>
-              </a:spcAft>
-              <a:buNone/>
-            </a:pPr>
-            <a:r>
-              <a:rPr lang="zh-CN"/>
-              <a:t>CLM article: supplied Contrastive Language Models PDF, pages 6-8; https://contrastive-lm.notion.site/</a:t>
+              <a:t>Stage 1 selects seed 2 in experiments/q35-4b-s23.json: 12,576 source records, two epochs, lr 5e-5, batch 4 × accumulation 2, checkpointing, BF16 autocast over FP32 parameters, rank 16/alpha 32, head 256; no init_from. Stage 2: dates/missing evidence, 1,425 new + 2,000 replay, one epoch, lr 2e-5, batch 4 × accumulation 2, seed 1. Stage 3: documents-v1 train, 5,219 new + 2,000 replay, one epoch, lr 2e-5, batch 2 × accumulation 4, max_state 7552, seed 2. Stage 4: hard-v1 train (6,000) + devtools-v1 train (5,320) with 4,000 replay, one epoch, lr 2e-5, batch 2 × accumulation 4, max_state 7552, seed 1. Expected steps: 3144, 429, 903, 1915. All general stages preserve option/none/distractor augmentation and p_none_pair=.25. Default lab execution uses batch 1 × accumulation 8, checkpointing and row_budget 2048: same effective batch/curriculum/schedule, different grouping/dropout and kernel numerics. The skills concatenation uses verified public partitions and a course checksum; byte identity to the historical round10 joint file is not asserted. Replay uses decision-v7 train only. General attempt caps are configurable 180 minutes, not predictions. Stage 5: 64 Pac-Man train boards, two epochs, lr 2e-5, batch 1 × accumulation 8, 16 steps, no none/distractor insertion, retained option shuffling. All five output directories and backups remain separate. Sources: https://github.com/jaredpalmer/kev/blob/84847f0a883d900f7de5b7a57eaa341ca7f9a6b4/experiments/q35-4b-s23.json ; https://github.com/jaredpalmer/kev/blob/84847f0a883d900f7de5b7a57eaa341ca7f9a6b4/experiments/night2-4b-du.json ; https://huggingface.co/jaredpalmer/kev-4b/blob/957b91e762e883935830246eeb02381f9d2694b6/training_config.json ; https://huggingface.co/jaredpalmer/kev-4b/blob/6cfce5c2fa4b4bd64026336ab649c5ca78857d52/training_config.json</a:t>
             </a:r>
             <a:endParaRPr/>
           </a:p>
@@ -3253,182 +2569,7 @@
             </a:pPr>
             <a:r>
               <a:rPr lang="zh-CN"/>
-              <a:t>Use the learner's full initial decision-v7 checkpoint as --init_from, then the reviewed Pac-Man training JSONL through the upstream custom-data path. Follow the documented fine-tuning settings: two epochs, learning rate 2e-5, batch 1, accumulation 8, BF16 autocast, gradient checkpointing. With 64 admitted rows this gives 16 optimizer steps. Context max_state=2048; record any rejected rows and actual positive step count. The game only offers legal directions, so domain adaptation disables p_none, p_none_distract and p_distract, with no none minimal pairs. Option shuffling remains active. This deliberate task-specific deviation preserves the action set. Stop inference before training and reload after. The 20-minute attempt cap is a class budget, not a measured runtime. If the attempt fails, clearly label a compatible instructor checkpoint instead of claiming learner training succeeded.</a:t>
-            </a:r>
-            <a:endParaRPr/>
-          </a:p>
-          <a:p>
-            <a:pPr indent="0" lvl="0" marL="0" rtl="0" algn="l">
-              <a:spcBef>
-                <a:spcPts val="0"/>
-              </a:spcBef>
-              <a:spcAft>
-                <a:spcPts val="0"/>
-              </a:spcAft>
-              <a:buNone/>
-            </a:pPr>
-            <a:r>
-              <a:rPr lang="zh-CN"/>
-              <a:t>Sources: pinned Kev README custom-data fine-tuning section and train.py; lab/cloud_runtime.py.</a:t>
-            </a:r>
-            <a:endParaRPr/>
-          </a:p>
-          <a:p>
-            <a:pPr indent="0" lvl="0" marL="0" rtl="0" algn="l">
-              <a:spcBef>
-                <a:spcPts val="0"/>
-              </a:spcBef>
-              <a:spcAft>
-                <a:spcPts val="0"/>
-              </a:spcAft>
-              <a:buNone/>
-            </a:pPr>
-            <a:r>
-              <a:t/>
-            </a:r>
-            <a:endParaRPr/>
-          </a:p>
-          <a:p>
-            <a:pPr indent="0" lvl="0" marL="0" rtl="0" algn="l">
-              <a:spcBef>
-                <a:spcPts val="0"/>
-              </a:spcBef>
-              <a:spcAft>
-                <a:spcPts val="0"/>
-              </a:spcAft>
-              <a:buNone/>
-            </a:pPr>
-            <a:r>
-              <a:rPr lang="zh-CN"/>
-              <a:t>Reference URLs checked October 2, 2026:</a:t>
-            </a:r>
-            <a:endParaRPr/>
-          </a:p>
-          <a:p>
-            <a:pPr indent="0" lvl="0" marL="0" rtl="0" algn="l">
-              <a:spcBef>
-                <a:spcPts val="0"/>
-              </a:spcBef>
-              <a:spcAft>
-                <a:spcPts val="0"/>
-              </a:spcAft>
-              <a:buNone/>
-            </a:pPr>
-            <a:r>
-              <a:rPr lang="zh-CN"/>
-              <a:t>https://github.com/jaredpalmer/kev/tree/84847f0a883d900f7de5b7a57eaa341ca7f9a6b4</a:t>
-            </a:r>
-            <a:endParaRPr/>
-          </a:p>
-          <a:p>
-            <a:pPr indent="0" lvl="0" marL="0" rtl="0" algn="l">
-              <a:spcBef>
-                <a:spcPts val="0"/>
-              </a:spcBef>
-              <a:spcAft>
-                <a:spcPts val="0"/>
-              </a:spcAft>
-              <a:buNone/>
-            </a:pPr>
-            <a:r>
-              <a:rPr lang="zh-CN"/>
-              <a:t>https://github.com/Contrastive-LM/CLM/tree/bb42c6c5bf914fd449bed2f6ca65be80602cb1f7</a:t>
-            </a:r>
-            <a:endParaRPr/>
-          </a:p>
-          <a:p>
-            <a:pPr indent="0" lvl="0" marL="0" rtl="0" algn="l">
-              <a:spcBef>
-                <a:spcPts val="0"/>
-              </a:spcBef>
-              <a:spcAft>
-                <a:spcPts val="0"/>
-              </a:spcAft>
-              <a:buNone/>
-            </a:pPr>
-            <a:r>
-              <a:rPr lang="zh-CN"/>
-              <a:t>https://github.com/Contrastive-LM/CLM/blob/bb42c6c5bf914fd449bed2f6ca65be80602cb1f7/src/clm/heads.py</a:t>
-            </a:r>
-            <a:endParaRPr/>
-          </a:p>
-          <a:p>
-            <a:pPr indent="0" lvl="0" marL="0" rtl="0" algn="l">
-              <a:spcBef>
-                <a:spcPts val="0"/>
-              </a:spcBef>
-              <a:spcAft>
-                <a:spcPts val="0"/>
-              </a:spcAft>
-              <a:buNone/>
-            </a:pPr>
-            <a:r>
-              <a:rPr lang="zh-CN"/>
-              <a:t>https://github.com/Contrastive-LM/CLM/blob/bb42c6c5bf914fd449bed2f6ca65be80602cb1f7/train/finetune.py</a:t>
-            </a:r>
-            <a:endParaRPr/>
-          </a:p>
-          <a:p>
-            <a:pPr indent="0" lvl="0" marL="0" rtl="0" algn="l">
-              <a:spcBef>
-                <a:spcPts val="0"/>
-              </a:spcBef>
-              <a:spcAft>
-                <a:spcPts val="0"/>
-              </a:spcAft>
-              <a:buNone/>
-            </a:pPr>
-            <a:r>
-              <a:rPr lang="zh-CN"/>
-              <a:t>https://github.com/jaredpalmer/kev/blob/84847f0a883d900f7de5b7a57eaa341ca7f9a6b4/kev/model.py</a:t>
-            </a:r>
-            <a:endParaRPr/>
-          </a:p>
-          <a:p>
-            <a:pPr indent="0" lvl="0" marL="0" rtl="0" algn="l">
-              <a:spcBef>
-                <a:spcPts val="0"/>
-              </a:spcBef>
-              <a:spcAft>
-                <a:spcPts val="0"/>
-              </a:spcAft>
-              <a:buNone/>
-            </a:pPr>
-            <a:r>
-              <a:rPr lang="zh-CN"/>
-              <a:t>https://huggingface.co/blog/ggml-org/decision-models-in-llamacpp</a:t>
-            </a:r>
-            <a:endParaRPr/>
-          </a:p>
-          <a:p>
-            <a:pPr indent="0" lvl="0" marL="0" rtl="0" algn="l">
-              <a:spcBef>
-                <a:spcPts val="0"/>
-              </a:spcBef>
-              <a:spcAft>
-                <a:spcPts val="0"/>
-              </a:spcAft>
-              <a:buNone/>
-            </a:pPr>
-            <a:r>
-              <a:rPr lang="zh-CN"/>
-              <a:t>https://github.com/ggml-org/llama.cpp/pull/29818</a:t>
-            </a:r>
-            <a:endParaRPr/>
-          </a:p>
-          <a:p>
-            <a:pPr indent="0" lvl="0" marL="0" rtl="0" algn="l">
-              <a:spcBef>
-                <a:spcPts val="0"/>
-              </a:spcBef>
-              <a:spcAft>
-                <a:spcPts val="0"/>
-              </a:spcAft>
-              <a:buNone/>
-            </a:pPr>
-            <a:r>
-              <a:rPr lang="zh-CN"/>
-              <a:t>CLM article: supplied Contrastive Language Models PDF, pages 6-8; https://contrastive-lm.notion.site/</a:t>
+              <a:t>Warm-start the learner's Stage 4 skills/devtools checkpoint with init_from, then use reviewed Pac-Man training JSONL. Two epochs, lr 2e-5, batch 1 × accumulation 8, BF16 autocast over FP32 weights, gradient checkpointing, state budget 2048. Sixty-four accepted rows give 16 steps. Disable none/distractor augmentation to retain legal directions; option shuffling remains active. Stop inference before training and reload afterward. The 20-minute training cap is a class budget pending a full GPU run. After interruption, use RESUME_PACMAN with the same inputs/arguments and an existing recovery snapshot, or explicitly label an instructor checkpoint. Source: pinned Kev README custom-data training and course cloud_runtime.py.</a:t>
             </a:r>
             <a:endParaRPr/>
           </a:p>
@@ -3528,182 +2669,7 @@
             </a:pPr>
             <a:r>
               <a:rPr lang="zh-CN"/>
-              <a:t>prepare_training creates trainable-parameters.json using the pinned DecisionModel and checks that all trainable names belong to LoRA A/B or head parameters, that both groups exist, and that original matrices are fixed. LoRA A is freshly initialized and B starts at zero through PEFT. No trainable token embeddings or full-weight training. Upstream training still backpropagates through the encoder to update adapters. Save adapter_config.json, adapter weights, head.pt, tokenizer files, training_config.json, training_metrics.json and run-evidence.json. The checkpoint loader checks base/revision/rank/head compatibility. run-evidence records the complete command and elapsed time including loading/saving; upstream metrics include optimizer steps and peak device bytes. Parameter audit and CPU checks do not replace a real GPU run.</a:t>
-            </a:r>
-            <a:endParaRPr/>
-          </a:p>
-          <a:p>
-            <a:pPr indent="0" lvl="0" marL="0" rtl="0" algn="l">
-              <a:spcBef>
-                <a:spcPts val="0"/>
-              </a:spcBef>
-              <a:spcAft>
-                <a:spcPts val="0"/>
-              </a:spcAft>
-              <a:buNone/>
-            </a:pPr>
-            <a:r>
-              <a:rPr lang="zh-CN"/>
-              <a:t>Sources: pinned Kev model.py, train.py and checkpoint.py; lab/cloud_runtime.py.</a:t>
-            </a:r>
-            <a:endParaRPr/>
-          </a:p>
-          <a:p>
-            <a:pPr indent="0" lvl="0" marL="0" rtl="0" algn="l">
-              <a:spcBef>
-                <a:spcPts val="0"/>
-              </a:spcBef>
-              <a:spcAft>
-                <a:spcPts val="0"/>
-              </a:spcAft>
-              <a:buNone/>
-            </a:pPr>
-            <a:r>
-              <a:t/>
-            </a:r>
-            <a:endParaRPr/>
-          </a:p>
-          <a:p>
-            <a:pPr indent="0" lvl="0" marL="0" rtl="0" algn="l">
-              <a:spcBef>
-                <a:spcPts val="0"/>
-              </a:spcBef>
-              <a:spcAft>
-                <a:spcPts val="0"/>
-              </a:spcAft>
-              <a:buNone/>
-            </a:pPr>
-            <a:r>
-              <a:rPr lang="zh-CN"/>
-              <a:t>Reference URLs checked October 2, 2026:</a:t>
-            </a:r>
-            <a:endParaRPr/>
-          </a:p>
-          <a:p>
-            <a:pPr indent="0" lvl="0" marL="0" rtl="0" algn="l">
-              <a:spcBef>
-                <a:spcPts val="0"/>
-              </a:spcBef>
-              <a:spcAft>
-                <a:spcPts val="0"/>
-              </a:spcAft>
-              <a:buNone/>
-            </a:pPr>
-            <a:r>
-              <a:rPr lang="zh-CN"/>
-              <a:t>https://github.com/jaredpalmer/kev/tree/84847f0a883d900f7de5b7a57eaa341ca7f9a6b4</a:t>
-            </a:r>
-            <a:endParaRPr/>
-          </a:p>
-          <a:p>
-            <a:pPr indent="0" lvl="0" marL="0" rtl="0" algn="l">
-              <a:spcBef>
-                <a:spcPts val="0"/>
-              </a:spcBef>
-              <a:spcAft>
-                <a:spcPts val="0"/>
-              </a:spcAft>
-              <a:buNone/>
-            </a:pPr>
-            <a:r>
-              <a:rPr lang="zh-CN"/>
-              <a:t>https://github.com/Contrastive-LM/CLM/tree/bb42c6c5bf914fd449bed2f6ca65be80602cb1f7</a:t>
-            </a:r>
-            <a:endParaRPr/>
-          </a:p>
-          <a:p>
-            <a:pPr indent="0" lvl="0" marL="0" rtl="0" algn="l">
-              <a:spcBef>
-                <a:spcPts val="0"/>
-              </a:spcBef>
-              <a:spcAft>
-                <a:spcPts val="0"/>
-              </a:spcAft>
-              <a:buNone/>
-            </a:pPr>
-            <a:r>
-              <a:rPr lang="zh-CN"/>
-              <a:t>https://github.com/Contrastive-LM/CLM/blob/bb42c6c5bf914fd449bed2f6ca65be80602cb1f7/src/clm/heads.py</a:t>
-            </a:r>
-            <a:endParaRPr/>
-          </a:p>
-          <a:p>
-            <a:pPr indent="0" lvl="0" marL="0" rtl="0" algn="l">
-              <a:spcBef>
-                <a:spcPts val="0"/>
-              </a:spcBef>
-              <a:spcAft>
-                <a:spcPts val="0"/>
-              </a:spcAft>
-              <a:buNone/>
-            </a:pPr>
-            <a:r>
-              <a:rPr lang="zh-CN"/>
-              <a:t>https://github.com/Contrastive-LM/CLM/blob/bb42c6c5bf914fd449bed2f6ca65be80602cb1f7/train/finetune.py</a:t>
-            </a:r>
-            <a:endParaRPr/>
-          </a:p>
-          <a:p>
-            <a:pPr indent="0" lvl="0" marL="0" rtl="0" algn="l">
-              <a:spcBef>
-                <a:spcPts val="0"/>
-              </a:spcBef>
-              <a:spcAft>
-                <a:spcPts val="0"/>
-              </a:spcAft>
-              <a:buNone/>
-            </a:pPr>
-            <a:r>
-              <a:rPr lang="zh-CN"/>
-              <a:t>https://github.com/jaredpalmer/kev/blob/84847f0a883d900f7de5b7a57eaa341ca7f9a6b4/kev/model.py</a:t>
-            </a:r>
-            <a:endParaRPr/>
-          </a:p>
-          <a:p>
-            <a:pPr indent="0" lvl="0" marL="0" rtl="0" algn="l">
-              <a:spcBef>
-                <a:spcPts val="0"/>
-              </a:spcBef>
-              <a:spcAft>
-                <a:spcPts val="0"/>
-              </a:spcAft>
-              <a:buNone/>
-            </a:pPr>
-            <a:r>
-              <a:rPr lang="zh-CN"/>
-              <a:t>https://huggingface.co/blog/ggml-org/decision-models-in-llamacpp</a:t>
-            </a:r>
-            <a:endParaRPr/>
-          </a:p>
-          <a:p>
-            <a:pPr indent="0" lvl="0" marL="0" rtl="0" algn="l">
-              <a:spcBef>
-                <a:spcPts val="0"/>
-              </a:spcBef>
-              <a:spcAft>
-                <a:spcPts val="0"/>
-              </a:spcAft>
-              <a:buNone/>
-            </a:pPr>
-            <a:r>
-              <a:rPr lang="zh-CN"/>
-              <a:t>https://github.com/ggml-org/llama.cpp/pull/29818</a:t>
-            </a:r>
-            <a:endParaRPr/>
-          </a:p>
-          <a:p>
-            <a:pPr indent="0" lvl="0" marL="0" rtl="0" algn="l">
-              <a:spcBef>
-                <a:spcPts val="0"/>
-              </a:spcBef>
-              <a:spcAft>
-                <a:spcPts val="0"/>
-              </a:spcAft>
-              <a:buNone/>
-            </a:pPr>
-            <a:r>
-              <a:rPr lang="zh-CN"/>
-              <a:t>CLM article: supplied Contrastive Language Models PDF, pages 6-8; https://contrastive-lm.notion.site/</a:t>
+              <a:t>Audit LoRA A/B and head as the only trainable parameters. Original matrices stay fixed while gradients pass through the encoder. Every optimizer step logs CE, learning rate, gradients, duration and peak/live allocated/reserved/free VRAM to TensorBoard/JSONL/CSV. Per-forward row counts/token shapes and record IDs remain in batches.jsonl. Save LoRA/head plus optimizer/scheduler/RNG/counters after step 1, every 100 steps or five minutes at optimizer boundaries, and the final step. Keep the latest two complete recovery snapshots. Native Kev resume is full-weight-only; the lab supplies guarded LoRA continuation. Use Drive storage or export snapshots before Colab disconnects. The older 0.8B notebook saved weights only at completion, so its failed step-2073 run had no automatic learned checkpoint. Source: course training_monitor.py and lora_recovery.py.</a:t>
             </a:r>
             <a:endParaRPr/>
           </a:p>
@@ -4078,182 +3044,7 @@
             </a:pPr>
             <a:r>
               <a:rPr lang="zh-CN"/>
-              <a:t>Compare the learner's initially trained decision-v7 model against the same model after Pac-Man adaptation. Keep base, input recipe, legal actions, ghost rules and runtime precision identical. Decide the candidate using development data before opening evaluation. Report accuracy against heuristic labels and immediate captures after applying each chosen move and the fixed ghost rule. Do not substitute a released Kev checkpoint silently or inherit release benchmark/calibration scores. The teacher is a heuristic, not optimal human gameplay. Report unchanged decisions and regressions.</a:t>
-            </a:r>
-            <a:endParaRPr/>
-          </a:p>
-          <a:p>
-            <a:pPr indent="0" lvl="0" marL="0" rtl="0" algn="l">
-              <a:spcBef>
-                <a:spcPts val="0"/>
-              </a:spcBef>
-              <a:spcAft>
-                <a:spcPts val="0"/>
-              </a:spcAft>
-              <a:buNone/>
-            </a:pPr>
-            <a:r>
-              <a:rPr lang="zh-CN"/>
-              <a:t>Source: lab/pacman_lab.py and lab/notebooks/pacman_kev_lab.ipynb.</a:t>
-            </a:r>
-            <a:endParaRPr/>
-          </a:p>
-          <a:p>
-            <a:pPr indent="0" lvl="0" marL="0" rtl="0" algn="l">
-              <a:spcBef>
-                <a:spcPts val="0"/>
-              </a:spcBef>
-              <a:spcAft>
-                <a:spcPts val="0"/>
-              </a:spcAft>
-              <a:buNone/>
-            </a:pPr>
-            <a:r>
-              <a:t/>
-            </a:r>
-            <a:endParaRPr/>
-          </a:p>
-          <a:p>
-            <a:pPr indent="0" lvl="0" marL="0" rtl="0" algn="l">
-              <a:spcBef>
-                <a:spcPts val="0"/>
-              </a:spcBef>
-              <a:spcAft>
-                <a:spcPts val="0"/>
-              </a:spcAft>
-              <a:buNone/>
-            </a:pPr>
-            <a:r>
-              <a:rPr lang="zh-CN"/>
-              <a:t>Reference URLs checked October 2, 2026:</a:t>
-            </a:r>
-            <a:endParaRPr/>
-          </a:p>
-          <a:p>
-            <a:pPr indent="0" lvl="0" marL="0" rtl="0" algn="l">
-              <a:spcBef>
-                <a:spcPts val="0"/>
-              </a:spcBef>
-              <a:spcAft>
-                <a:spcPts val="0"/>
-              </a:spcAft>
-              <a:buNone/>
-            </a:pPr>
-            <a:r>
-              <a:rPr lang="zh-CN"/>
-              <a:t>https://github.com/jaredpalmer/kev/tree/84847f0a883d900f7de5b7a57eaa341ca7f9a6b4</a:t>
-            </a:r>
-            <a:endParaRPr/>
-          </a:p>
-          <a:p>
-            <a:pPr indent="0" lvl="0" marL="0" rtl="0" algn="l">
-              <a:spcBef>
-                <a:spcPts val="0"/>
-              </a:spcBef>
-              <a:spcAft>
-                <a:spcPts val="0"/>
-              </a:spcAft>
-              <a:buNone/>
-            </a:pPr>
-            <a:r>
-              <a:rPr lang="zh-CN"/>
-              <a:t>https://github.com/Contrastive-LM/CLM/tree/bb42c6c5bf914fd449bed2f6ca65be80602cb1f7</a:t>
-            </a:r>
-            <a:endParaRPr/>
-          </a:p>
-          <a:p>
-            <a:pPr indent="0" lvl="0" marL="0" rtl="0" algn="l">
-              <a:spcBef>
-                <a:spcPts val="0"/>
-              </a:spcBef>
-              <a:spcAft>
-                <a:spcPts val="0"/>
-              </a:spcAft>
-              <a:buNone/>
-            </a:pPr>
-            <a:r>
-              <a:rPr lang="zh-CN"/>
-              <a:t>https://github.com/Contrastive-LM/CLM/blob/bb42c6c5bf914fd449bed2f6ca65be80602cb1f7/src/clm/heads.py</a:t>
-            </a:r>
-            <a:endParaRPr/>
-          </a:p>
-          <a:p>
-            <a:pPr indent="0" lvl="0" marL="0" rtl="0" algn="l">
-              <a:spcBef>
-                <a:spcPts val="0"/>
-              </a:spcBef>
-              <a:spcAft>
-                <a:spcPts val="0"/>
-              </a:spcAft>
-              <a:buNone/>
-            </a:pPr>
-            <a:r>
-              <a:rPr lang="zh-CN"/>
-              <a:t>https://github.com/Contrastive-LM/CLM/blob/bb42c6c5bf914fd449bed2f6ca65be80602cb1f7/train/finetune.py</a:t>
-            </a:r>
-            <a:endParaRPr/>
-          </a:p>
-          <a:p>
-            <a:pPr indent="0" lvl="0" marL="0" rtl="0" algn="l">
-              <a:spcBef>
-                <a:spcPts val="0"/>
-              </a:spcBef>
-              <a:spcAft>
-                <a:spcPts val="0"/>
-              </a:spcAft>
-              <a:buNone/>
-            </a:pPr>
-            <a:r>
-              <a:rPr lang="zh-CN"/>
-              <a:t>https://github.com/jaredpalmer/kev/blob/84847f0a883d900f7de5b7a57eaa341ca7f9a6b4/kev/model.py</a:t>
-            </a:r>
-            <a:endParaRPr/>
-          </a:p>
-          <a:p>
-            <a:pPr indent="0" lvl="0" marL="0" rtl="0" algn="l">
-              <a:spcBef>
-                <a:spcPts val="0"/>
-              </a:spcBef>
-              <a:spcAft>
-                <a:spcPts val="0"/>
-              </a:spcAft>
-              <a:buNone/>
-            </a:pPr>
-            <a:r>
-              <a:rPr lang="zh-CN"/>
-              <a:t>https://huggingface.co/blog/ggml-org/decision-models-in-llamacpp</a:t>
-            </a:r>
-            <a:endParaRPr/>
-          </a:p>
-          <a:p>
-            <a:pPr indent="0" lvl="0" marL="0" rtl="0" algn="l">
-              <a:spcBef>
-                <a:spcPts val="0"/>
-              </a:spcBef>
-              <a:spcAft>
-                <a:spcPts val="0"/>
-              </a:spcAft>
-              <a:buNone/>
-            </a:pPr>
-            <a:r>
-              <a:rPr lang="zh-CN"/>
-              <a:t>https://github.com/ggml-org/llama.cpp/pull/29818</a:t>
-            </a:r>
-            <a:endParaRPr/>
-          </a:p>
-          <a:p>
-            <a:pPr indent="0" lvl="0" marL="0" rtl="0" algn="l">
-              <a:spcBef>
-                <a:spcPts val="0"/>
-              </a:spcBef>
-              <a:spcAft>
-                <a:spcPts val="0"/>
-              </a:spcAft>
-              <a:buNone/>
-            </a:pPr>
-            <a:r>
-              <a:rPr lang="zh-CN"/>
-              <a:t>CLM article: supplied Contrastive Language Models PDF, pages 6-8; https://contrastive-lm.notion.site/</a:t>
+              <a:t>Compare the learner's completed Stage 4 general checkpoint and Stage 5 Pac-Man checkpoint. Keep backbone, legal actions, ghost rules and precision fixed. Freeze the candidate before viewing evaluation. Report heuristic teacher agreement, immediate captures, unchanged decisions and regressions. The release's scores and calibration do not transfer to these runs. Source: course pacman_lab.py.</a:t>
             </a:r>
             <a:endParaRPr/>
           </a:p>
@@ -4612,166 +3403,7 @@
             </a:pPr>
             <a:r>
               <a:rPr lang="zh-CN"/>
-              <a:t>Submit executed notebook, reviewed training JSONL, initial and Pac-Man adapter/head checkpoints, base/code/suite provenance, both training configurations/metrics, trainable-parameters.json, runtime-preflight.json and comparison.json. Package small adapter/head files and tokenizer/configuration, without full foundation-model weights or installed dependencies. Record actual Colab compute-unit use. Save outputs before temporary runtime disconnects. Explain why LoRA changes representations while original matrices remain fixed, and contrast with CLM's independently reusable action features.</a:t>
-            </a:r>
-            <a:endParaRPr/>
-          </a:p>
-          <a:p>
-            <a:pPr indent="0" lvl="0" marL="0" rtl="0" algn="l">
-              <a:spcBef>
-                <a:spcPts val="0"/>
-              </a:spcBef>
-              <a:spcAft>
-                <a:spcPts val="0"/>
-              </a:spcAft>
-              <a:buNone/>
-            </a:pPr>
-            <a:r>
-              <a:t/>
-            </a:r>
-            <a:endParaRPr/>
-          </a:p>
-          <a:p>
-            <a:pPr indent="0" lvl="0" marL="0" rtl="0" algn="l">
-              <a:spcBef>
-                <a:spcPts val="0"/>
-              </a:spcBef>
-              <a:spcAft>
-                <a:spcPts val="0"/>
-              </a:spcAft>
-              <a:buNone/>
-            </a:pPr>
-            <a:r>
-              <a:rPr lang="zh-CN"/>
-              <a:t>Reference URLs checked October 2, 2026:</a:t>
-            </a:r>
-            <a:endParaRPr/>
-          </a:p>
-          <a:p>
-            <a:pPr indent="0" lvl="0" marL="0" rtl="0" algn="l">
-              <a:spcBef>
-                <a:spcPts val="0"/>
-              </a:spcBef>
-              <a:spcAft>
-                <a:spcPts val="0"/>
-              </a:spcAft>
-              <a:buNone/>
-            </a:pPr>
-            <a:r>
-              <a:rPr lang="zh-CN"/>
-              <a:t>https://github.com/jaredpalmer/kev/tree/84847f0a883d900f7de5b7a57eaa341ca7f9a6b4</a:t>
-            </a:r>
-            <a:endParaRPr/>
-          </a:p>
-          <a:p>
-            <a:pPr indent="0" lvl="0" marL="0" rtl="0" algn="l">
-              <a:spcBef>
-                <a:spcPts val="0"/>
-              </a:spcBef>
-              <a:spcAft>
-                <a:spcPts val="0"/>
-              </a:spcAft>
-              <a:buNone/>
-            </a:pPr>
-            <a:r>
-              <a:rPr lang="zh-CN"/>
-              <a:t>https://github.com/Contrastive-LM/CLM/tree/bb42c6c5bf914fd449bed2f6ca65be80602cb1f7</a:t>
-            </a:r>
-            <a:endParaRPr/>
-          </a:p>
-          <a:p>
-            <a:pPr indent="0" lvl="0" marL="0" rtl="0" algn="l">
-              <a:spcBef>
-                <a:spcPts val="0"/>
-              </a:spcBef>
-              <a:spcAft>
-                <a:spcPts val="0"/>
-              </a:spcAft>
-              <a:buNone/>
-            </a:pPr>
-            <a:r>
-              <a:rPr lang="zh-CN"/>
-              <a:t>https://github.com/Contrastive-LM/CLM/blob/bb42c6c5bf914fd449bed2f6ca65be80602cb1f7/src/clm/heads.py</a:t>
-            </a:r>
-            <a:endParaRPr/>
-          </a:p>
-          <a:p>
-            <a:pPr indent="0" lvl="0" marL="0" rtl="0" algn="l">
-              <a:spcBef>
-                <a:spcPts val="0"/>
-              </a:spcBef>
-              <a:spcAft>
-                <a:spcPts val="0"/>
-              </a:spcAft>
-              <a:buNone/>
-            </a:pPr>
-            <a:r>
-              <a:rPr lang="zh-CN"/>
-              <a:t>https://github.com/Contrastive-LM/CLM/blob/bb42c6c5bf914fd449bed2f6ca65be80602cb1f7/train/finetune.py</a:t>
-            </a:r>
-            <a:endParaRPr/>
-          </a:p>
-          <a:p>
-            <a:pPr indent="0" lvl="0" marL="0" rtl="0" algn="l">
-              <a:spcBef>
-                <a:spcPts val="0"/>
-              </a:spcBef>
-              <a:spcAft>
-                <a:spcPts val="0"/>
-              </a:spcAft>
-              <a:buNone/>
-            </a:pPr>
-            <a:r>
-              <a:rPr lang="zh-CN"/>
-              <a:t>https://github.com/jaredpalmer/kev/blob/84847f0a883d900f7de5b7a57eaa341ca7f9a6b4/kev/model.py</a:t>
-            </a:r>
-            <a:endParaRPr/>
-          </a:p>
-          <a:p>
-            <a:pPr indent="0" lvl="0" marL="0" rtl="0" algn="l">
-              <a:spcBef>
-                <a:spcPts val="0"/>
-              </a:spcBef>
-              <a:spcAft>
-                <a:spcPts val="0"/>
-              </a:spcAft>
-              <a:buNone/>
-            </a:pPr>
-            <a:r>
-              <a:rPr lang="zh-CN"/>
-              <a:t>https://huggingface.co/blog/ggml-org/decision-models-in-llamacpp</a:t>
-            </a:r>
-            <a:endParaRPr/>
-          </a:p>
-          <a:p>
-            <a:pPr indent="0" lvl="0" marL="0" rtl="0" algn="l">
-              <a:spcBef>
-                <a:spcPts val="0"/>
-              </a:spcBef>
-              <a:spcAft>
-                <a:spcPts val="0"/>
-              </a:spcAft>
-              <a:buNone/>
-            </a:pPr>
-            <a:r>
-              <a:rPr lang="zh-CN"/>
-              <a:t>https://github.com/ggml-org/llama.cpp/pull/29818</a:t>
-            </a:r>
-            <a:endParaRPr/>
-          </a:p>
-          <a:p>
-            <a:pPr indent="0" lvl="0" marL="0" rtl="0" algn="l">
-              <a:spcBef>
-                <a:spcPts val="0"/>
-              </a:spcBef>
-              <a:spcAft>
-                <a:spcPts val="0"/>
-              </a:spcAft>
-              <a:buNone/>
-            </a:pPr>
-            <a:r>
-              <a:rPr lang="zh-CN"/>
-              <a:t>CLM article: supplied Contrastive Language Models PDF, pages 6-8; https://contrastive-lm.notion.site/</a:t>
+              <a:t>Submit executed notebook, reviewed training JSONL, all five adapter/head checkpoints, every configuration/metrics file, paired predictions, raw logs and TensorBoard events, trainable-parameters.json, runtime-preflight.json and optimized-training-preflight.json. Package adapters/heads rather than foundation weights or dependencies. Record compute units and elapsed GPU time. Checkpoint ownership must identify learner versus instructor. Source: course notebook submission cell.</a:t>
             </a:r>
             <a:endParaRPr/>
           </a:p>
@@ -11706,7 +10338,7 @@
             <a:tbl>
               <a:tblPr>
                 <a:noFill/>
-                <a:tableStyleId>{D3873B56-893F-467F-BDC1-E29B79847113}</a:tableStyleId>
+                <a:tableStyleId>{7752FCCB-C744-403B-90CA-A14BC9C0A3A7}</a:tableStyleId>
               </a:tblPr>
               <a:tblGrid>
                 <a:gridCol w="1549400"/>
@@ -12794,7 +11426,7 @@
                   <a:srgbClr val="111829"/>
                 </a:solidFill>
               </a:rPr>
-              <a:t>Our Kev-0.8B Pac-Man lab</a:t>
+              <a:t>Our Kev-4B Pac-Man lab</a:t>
             </a:r>
             <a:endParaRPr b="1" sz="3000">
               <a:solidFill>
@@ -12874,7 +11506,7 @@
                   <a:srgbClr val="1A2433"/>
                 </a:solidFill>
               </a:rPr>
-              <a:t>Start from Qwen3.5-0.8B-Base</a:t>
+              <a:t>Start from Qwen3.5-4B-Base</a:t>
             </a:r>
             <a:endParaRPr sz="2300">
               <a:solidFill>
@@ -12928,7 +11560,7 @@
                   <a:srgbClr val="1A2433"/>
                 </a:solidFill>
               </a:rPr>
-              <a:t>Fine-tune your checkpoint for player moves</a:t>
+              <a:t>Complete four general stages before class</a:t>
             </a:r>
             <a:endParaRPr sz="2300">
               <a:solidFill>
@@ -12955,7 +11587,7 @@
                   <a:srgbClr val="1A2433"/>
                 </a:solidFill>
               </a:rPr>
-              <a:t>Use Colab with RTX PRO 6000 Blackwell</a:t>
+              <a:t>Fine-tune your own checkpoint for moves</a:t>
             </a:r>
             <a:endParaRPr sz="2300">
               <a:solidFill>
@@ -13224,7 +11856,7 @@
                   <a:srgbClr val="1A2433"/>
                 </a:solidFill>
               </a:rPr>
-              <a:t>10-20  Inspect initial decision training</a:t>
+              <a:t>10-20  Inspect the four general training stages</a:t>
             </a:r>
             <a:endParaRPr sz="2300">
               <a:solidFill>
@@ -13385,7 +12017,7 @@
                   <a:srgbClr val="5E6E80"/>
                 </a:solidFill>
               </a:rPr>
-              <a:t>Prework includes full initial training. Fine-tuning takes 30 class minutes.</a:t>
+              <a:t>Four general stages are prework. Fine-tuning takes 30 class minutes.</a:t>
             </a:r>
             <a:endParaRPr sz="900">
               <a:solidFill>
@@ -13574,7 +12206,7 @@
                   <a:srgbClr val="1A2433"/>
                 </a:solidFill>
               </a:rPr>
-              <a:t>Target: RTX PRO 6000 Blackwell</a:t>
+              <a:t>Target: RTX PRO 6000 Blackwell, 96 GB</a:t>
             </a:r>
             <a:endParaRPr sz="2300">
               <a:solidFill>
@@ -13601,7 +12233,7 @@
                   <a:srgbClr val="1A2433"/>
                 </a:solidFill>
               </a:rPr>
-              <a:t>Full Server Edition: 96 GB VRAM</a:t>
+              <a:t>PyTorch 2.8 / CUDA 12.8 with BF16</a:t>
             </a:r>
             <a:endParaRPr sz="2300">
               <a:solidFill>
@@ -13628,7 +12260,7 @@
                   <a:srgbClr val="1A2433"/>
                 </a:solidFill>
               </a:rPr>
-              <a:t>Verify the actual GPU and BF16 support</a:t>
+              <a:t>Required: FLA and CUDA causal convolution</a:t>
             </a:r>
             <a:endParaRPr sz="2300">
               <a:solidFill>
@@ -13655,7 +12287,7 @@
                   <a:srgbClr val="1A2433"/>
                 </a:solidFill>
               </a:rPr>
-              <a:t>Use pinned PyTorch 2.8 with CUDA 12.8</a:t>
+              <a:t>Verify Kev loss and backward before training</a:t>
             </a:r>
             <a:endParaRPr sz="2300">
               <a:solidFill>
@@ -13682,7 +12314,7 @@
                   <a:srgbClr val="1A2433"/>
                 </a:solidFill>
               </a:rPr>
-              <a:t>Finish setup and initial training before class</a:t>
+              <a:t>Use checkpointing and fused AdamW</a:t>
             </a:r>
             <a:endParaRPr sz="2300">
               <a:solidFill>
@@ -15244,7 +13876,7 @@
                   <a:srgbClr val="111829"/>
                 </a:solidFill>
               </a:rPr>
-              <a:t>Initial decision training</a:t>
+              <a:t>Kev-4B training stages</a:t>
             </a:r>
             <a:endParaRPr b="1" sz="3000">
               <a:solidFill>
@@ -15297,7 +13929,7 @@
                   <a:srgbClr val="1A2433"/>
                 </a:solidFill>
               </a:rPr>
-              <a:t>Load the pinned pretrained Qwen base</a:t>
+              <a:t>1  Decisions: 12,576 records × 2 epochs</a:t>
             </a:r>
             <a:endParaRPr sz="2300">
               <a:solidFill>
@@ -15324,7 +13956,7 @@
                   <a:srgbClr val="1A2433"/>
                 </a:solidFill>
               </a:rPr>
-              <a:t>Initialize fresh LoRA and a pointer head</a:t>
+              <a:t>2  Dates/evidence: 1,425 + 2,000 replay</a:t>
             </a:r>
             <a:endParaRPr sz="2300">
               <a:solidFill>
@@ -15351,7 +13983,7 @@
                   <a:srgbClr val="1A2433"/>
                 </a:solidFill>
               </a:rPr>
-              <a:t>Train on 12,576 decision-v7 records</a:t>
+              <a:t>3  Documents: 5,219 + 2,000 replay</a:t>
             </a:r>
             <a:endParaRPr sz="2300">
               <a:solidFill>
@@ -15378,7 +14010,7 @@
                   <a:srgbClr val="1A2433"/>
                 </a:solidFill>
               </a:rPr>
-              <a:t>Two epochs, batch 8, learning rate 1e-4</a:t>
+              <a:t>4  Skills/devtools: 11,320 + 4,000 replay</a:t>
             </a:r>
             <a:endParaRPr sz="2300">
               <a:solidFill>
@@ -15405,7 +14037,7 @@
                   <a:srgbClr val="1A2433"/>
                 </a:solidFill>
               </a:rPr>
-              <a:t>Use cross-entropy over supplied options</a:t>
+              <a:t>5  Pac-Man: 64 labelled boards × 2 epochs</a:t>
             </a:r>
             <a:endParaRPr sz="2300">
               <a:solidFill>
@@ -15458,7 +14090,7 @@
                   <a:srgbClr val="5E6E80"/>
                 </a:solidFill>
               </a:rPr>
-              <a:t>Complete this full base stage as prework. No --init_from.</a:t>
+              <a:t>Stages 1–4 are prework. Stage 5 is the mandatory class adaptation.</a:t>
             </a:r>
             <a:endParaRPr sz="900">
               <a:solidFill>
@@ -15674,7 +14306,7 @@
                   <a:srgbClr val="1A2433"/>
                 </a:solidFill>
               </a:rPr>
-              <a:t>20 min  Fine-tune your initial checkpoint</a:t>
+              <a:t>20 min  Fine-tune your skills checkpoint</a:t>
             </a:r>
             <a:endParaRPr sz="2300">
               <a:solidFill>
@@ -16078,7 +14710,7 @@
                   <a:srgbClr val="1A2433"/>
                 </a:solidFill>
               </a:rPr>
-              <a:t>Save adapter, head and base/data revisions</a:t>
+              <a:t>Track loss and live memory in TensorBoard</a:t>
             </a:r>
             <a:endParaRPr sz="2300">
               <a:solidFill>
@@ -16105,7 +14737,7 @@
                   <a:srgbClr val="1A2433"/>
                 </a:solidFill>
               </a:rPr>
-              <a:t>Record steps, elapsed time and peak memory</a:t>
+              <a:t>Save recovery weights during every stage</a:t>
             </a:r>
             <a:endParaRPr sz="2300">
               <a:solidFill>
@@ -16478,7 +15110,7 @@
             <a:tbl>
               <a:tblPr>
                 <a:noFill/>
-                <a:tableStyleId>{D3873B56-893F-467F-BDC1-E29B79847113}</a:tableStyleId>
+                <a:tableStyleId>{7752FCCB-C744-403B-90CA-A14BC9C0A3A7}</a:tableStyleId>
               </a:tblPr>
               <a:tblGrid>
                 <a:gridCol w="1346200"/>
@@ -17673,7 +16305,7 @@
                   <a:srgbClr val="1A2433"/>
                 </a:solidFill>
               </a:rPr>
-              <a:t>Fix initial and Pac-Man checkpoints</a:t>
+              <a:t>Fix skills and Pac-Man checkpoints</a:t>
             </a:r>
             <a:endParaRPr sz="2300">
               <a:solidFill>
@@ -18427,7 +17059,7 @@
                   <a:srgbClr val="1A2433"/>
                 </a:solidFill>
               </a:rPr>
-              <a:t>Save both adapters and pointer heads</a:t>
+              <a:t>Save all five adapters and pointer heads</a:t>
             </a:r>
             <a:endParaRPr sz="2300">
               <a:solidFill>
@@ -18454,7 +17086,7 @@
                   <a:srgbClr val="1A2433"/>
                 </a:solidFill>
               </a:rPr>
-              <a:t>Submit paired predictions and runtime evidence</a:t>
+              <a:t>Submit paired predictions and training curves</a:t>
             </a:r>
             <a:endParaRPr sz="2300">
               <a:solidFill>
@@ -18481,7 +17113,7 @@
                   <a:srgbClr val="1A2433"/>
                 </a:solidFill>
               </a:rPr>
-              <a:t>Separate observations from broader claims</a:t>
+              <a:t>Record runtime and actual compute-unit use</a:t>
             </a:r>
             <a:endParaRPr sz="2300">
               <a:solidFill>
@@ -18534,7 +17166,7 @@
                   <a:srgbClr val="5E6E80"/>
                 </a:solidFill>
               </a:rPr>
-              <a:t>Evidence: initial decision model, domain adaptation, paired evaluation</a:t>
+              <a:t>Evidence: four general stages, Pac-Man adaptation, paired evaluation</a:t>
             </a:r>
             <a:endParaRPr sz="900">
               <a:solidFill>
@@ -19204,7 +17836,7 @@
             <a:tbl>
               <a:tblPr>
                 <a:noFill/>
-                <a:tableStyleId>{D3873B56-893F-467F-BDC1-E29B79847113}</a:tableStyleId>
+                <a:tableStyleId>{7752FCCB-C744-403B-90CA-A14BC9C0A3A7}</a:tableStyleId>
               </a:tblPr>
               <a:tblGrid>
                 <a:gridCol w="1346200"/>
@@ -20530,7 +19162,7 @@
             <a:tbl>
               <a:tblPr>
                 <a:noFill/>
-                <a:tableStyleId>{D3873B56-893F-467F-BDC1-E29B79847113}</a:tableStyleId>
+                <a:tableStyleId>{7752FCCB-C744-403B-90CA-A14BC9C0A3A7}</a:tableStyleId>
               </a:tblPr>
               <a:tblGrid>
                 <a:gridCol w="1346200"/>
@@ -21856,7 +20488,7 @@
             <a:tbl>
               <a:tblPr>
                 <a:noFill/>
-                <a:tableStyleId>{D3873B56-893F-467F-BDC1-E29B79847113}</a:tableStyleId>
+                <a:tableStyleId>{7752FCCB-C744-403B-90CA-A14BC9C0A3A7}</a:tableStyleId>
               </a:tblPr>
               <a:tblGrid>
                 <a:gridCol w="2146300"/>
@@ -23182,7 +21814,7 @@
             <a:tbl>
               <a:tblPr>
                 <a:noFill/>
-                <a:tableStyleId>{D3873B56-893F-467F-BDC1-E29B79847113}</a:tableStyleId>
+                <a:tableStyleId>{7752FCCB-C744-403B-90CA-A14BC9C0A3A7}</a:tableStyleId>
               </a:tblPr>
               <a:tblGrid>
                 <a:gridCol w="1041400"/>
@@ -26554,6 +25186,285 @@
 </file>
 
 <file path=ppt/theme/theme1.xml><?xml version="1.0" encoding="utf-8"?>
+<a:theme xmlns:a="http://schemas.openxmlformats.org/drawingml/2006/main" xmlns:r="http://schemas.openxmlformats.org/officeDocument/2006/relationships" name="Simple Light">
+  <a:themeElements>
+    <a:clrScheme name="Simple Light">
+      <a:dk1>
+        <a:srgbClr val="000000"/>
+      </a:dk1>
+      <a:lt1>
+        <a:srgbClr val="FFFFFF"/>
+      </a:lt1>
+      <a:dk2>
+        <a:srgbClr val="595959"/>
+      </a:dk2>
+      <a:lt2>
+        <a:srgbClr val="EEEEEE"/>
+      </a:lt2>
+      <a:accent1>
+        <a:srgbClr val="4285F4"/>
+      </a:accent1>
+      <a:accent2>
+        <a:srgbClr val="212121"/>
+      </a:accent2>
+      <a:accent3>
+        <a:srgbClr val="78909C"/>
+      </a:accent3>
+      <a:accent4>
+        <a:srgbClr val="FFAB40"/>
+      </a:accent4>
+      <a:accent5>
+        <a:srgbClr val="0097A7"/>
+      </a:accent5>
+      <a:accent6>
+        <a:srgbClr val="EEFF41"/>
+      </a:accent6>
+      <a:hlink>
+        <a:srgbClr val="0097A7"/>
+      </a:hlink>
+      <a:folHlink>
+        <a:srgbClr val="0097A7"/>
+      </a:folHlink>
+    </a:clrScheme>
+    <a:fontScheme name="Office">
+      <a:majorFont>
+        <a:latin typeface="Arial"/>
+        <a:ea typeface=""/>
+        <a:cs typeface=""/>
+        <a:font script="Jpan" typeface="ＭＳ Ｐゴシック"/>
+        <a:font script="Hang" typeface="맑은 고딕"/>
+        <a:font script="Hans" typeface="宋体"/>
+        <a:font script="Hant" typeface="新細明體"/>
+        <a:font script="Arab" typeface="Times New Roman"/>
+        <a:font script="Hebr" typeface="Times New Roman"/>
+        <a:font script="Thai" typeface="Angsana New"/>
+        <a:font script="Ethi" typeface="Nyala"/>
+        <a:font script="Beng" typeface="Vrinda"/>
+        <a:font script="Gujr" typeface="Shruti"/>
+        <a:font script="Khmr" typeface="MoolBoran"/>
+        <a:font script="Knda" typeface="Tunga"/>
+        <a:font script="Guru" typeface="Raavi"/>
+        <a:font script="Cans" typeface="Euphemia"/>
+        <a:font script="Cher" typeface="Plantagenet Cherokee"/>
+        <a:font script="Yiii" typeface="Microsoft Yi Baiti"/>
+        <a:font script="Tibt" typeface="Microsoft Himalaya"/>
+        <a:font script="Thaa" typeface="MV Boli"/>
+        <a:font script="Deva" typeface="Mangal"/>
+        <a:font script="Telu" typeface="Gautami"/>
+        <a:font script="Taml" typeface="Latha"/>
+        <a:font script="Syrc" typeface="Estrangelo Edessa"/>
+        <a:font script="Orya" typeface="Kalinga"/>
+        <a:font script="Mlym" typeface="Kartika"/>
+        <a:font script="Laoo" typeface="DokChampa"/>
+        <a:font script="Sinh" typeface="Iskoola Pota"/>
+        <a:font script="Mong" typeface="Mongolian Baiti"/>
+        <a:font script="Viet" typeface="Times New Roman"/>
+        <a:font script="Uigh" typeface="Microsoft Uighur"/>
+        <a:font script="Geor" typeface="Sylfaen"/>
+      </a:majorFont>
+      <a:minorFont>
+        <a:latin typeface="Arial"/>
+        <a:ea typeface=""/>
+        <a:cs typeface=""/>
+        <a:font script="Jpan" typeface="ＭＳ Ｐゴシック"/>
+        <a:font script="Hang" typeface="맑은 고딕"/>
+        <a:font script="Hans" typeface="宋体"/>
+        <a:font script="Hant" typeface="新細明體"/>
+        <a:font script="Arab" typeface="Arial"/>
+        <a:font script="Hebr" typeface="Arial"/>
+        <a:font script="Thai" typeface="Cordia New"/>
+        <a:font script="Ethi" typeface="Nyala"/>
+        <a:font script="Beng" typeface="Vrinda"/>
+        <a:font script="Gujr" typeface="Shruti"/>
+        <a:font script="Khmr" typeface="DaunPenh"/>
+        <a:font script="Knda" typeface="Tunga"/>
+        <a:font script="Guru" typeface="Raavi"/>
+        <a:font script="Cans" typeface="Euphemia"/>
+        <a:font script="Cher" typeface="Plantagenet Cherokee"/>
+        <a:font script="Yiii" typeface="Microsoft Yi Baiti"/>
+        <a:font script="Tibt" typeface="Microsoft Himalaya"/>
+        <a:font script="Thaa" typeface="MV Boli"/>
+        <a:font script="Deva" typeface="Mangal"/>
+        <a:font script="Telu" typeface="Gautami"/>
+        <a:font script="Taml" typeface="Latha"/>
+        <a:font script="Syrc" typeface="Estrangelo Edessa"/>
+        <a:font script="Orya" typeface="Kalinga"/>
+        <a:font script="Mlym" typeface="Kartika"/>
+        <a:font script="Laoo" typeface="DokChampa"/>
+        <a:font script="Sinh" typeface="Iskoola Pota"/>
+        <a:font script="Mong" typeface="Mongolian Baiti"/>
+        <a:font script="Viet" typeface="Arial"/>
+        <a:font script="Uigh" typeface="Microsoft Uighur"/>
+        <a:font script="Geor" typeface="Sylfaen"/>
+      </a:minorFont>
+    </a:fontScheme>
+    <a:fmtScheme name="Office">
+      <a:fillStyleLst>
+        <a:solidFill>
+          <a:schemeClr val="phClr"/>
+        </a:solidFill>
+        <a:gradFill rotWithShape="1">
+          <a:gsLst>
+            <a:gs pos="0">
+              <a:schemeClr val="phClr">
+                <a:tint val="50000"/>
+                <a:satMod val="300000"/>
+              </a:schemeClr>
+            </a:gs>
+            <a:gs pos="35000">
+              <a:schemeClr val="phClr">
+                <a:tint val="37000"/>
+                <a:satMod val="300000"/>
+              </a:schemeClr>
+            </a:gs>
+            <a:gs pos="100000">
+              <a:schemeClr val="phClr">
+                <a:tint val="15000"/>
+                <a:satMod val="350000"/>
+              </a:schemeClr>
+            </a:gs>
+          </a:gsLst>
+          <a:lin ang="16200000" scaled="1"/>
+        </a:gradFill>
+        <a:gradFill rotWithShape="1">
+          <a:gsLst>
+            <a:gs pos="0">
+              <a:schemeClr val="phClr">
+                <a:tint val="100000"/>
+                <a:shade val="100000"/>
+                <a:satMod val="130000"/>
+              </a:schemeClr>
+            </a:gs>
+            <a:gs pos="100000">
+              <a:schemeClr val="phClr">
+                <a:tint val="50000"/>
+                <a:shade val="100000"/>
+                <a:satMod val="350000"/>
+              </a:schemeClr>
+            </a:gs>
+          </a:gsLst>
+          <a:lin ang="16200000" scaled="0"/>
+        </a:gradFill>
+      </a:fillStyleLst>
+      <a:lnStyleLst>
+        <a:ln w="9525" cap="flat" cmpd="sng" algn="ctr">
+          <a:solidFill>
+            <a:schemeClr val="phClr">
+              <a:shade val="95000"/>
+              <a:satMod val="105000"/>
+            </a:schemeClr>
+          </a:solidFill>
+          <a:prstDash val="solid"/>
+        </a:ln>
+        <a:ln w="25400" cap="flat" cmpd="sng" algn="ctr">
+          <a:solidFill>
+            <a:schemeClr val="phClr"/>
+          </a:solidFill>
+          <a:prstDash val="solid"/>
+        </a:ln>
+        <a:ln w="38100" cap="flat" cmpd="sng" algn="ctr">
+          <a:solidFill>
+            <a:schemeClr val="phClr"/>
+          </a:solidFill>
+          <a:prstDash val="solid"/>
+        </a:ln>
+      </a:lnStyleLst>
+      <a:effectStyleLst>
+        <a:effectStyle>
+          <a:effectLst>
+            <a:outerShdw blurRad="40000" dist="20000" dir="5400000" rotWithShape="0">
+              <a:srgbClr val="000000">
+                <a:alpha val="38000"/>
+              </a:srgbClr>
+            </a:outerShdw>
+          </a:effectLst>
+        </a:effectStyle>
+        <a:effectStyle>
+          <a:effectLst>
+            <a:outerShdw blurRad="40000" dist="23000" dir="5400000" rotWithShape="0">
+              <a:srgbClr val="000000">
+                <a:alpha val="35000"/>
+              </a:srgbClr>
+            </a:outerShdw>
+          </a:effectLst>
+        </a:effectStyle>
+        <a:effectStyle>
+          <a:effectLst>
+            <a:outerShdw blurRad="40000" dist="23000" dir="5400000" rotWithShape="0">
+              <a:srgbClr val="000000">
+                <a:alpha val="35000"/>
+              </a:srgbClr>
+            </a:outerShdw>
+          </a:effectLst>
+          <a:scene3d>
+            <a:camera prst="orthographicFront">
+              <a:rot lat="0" lon="0" rev="0"/>
+            </a:camera>
+            <a:lightRig rig="threePt" dir="t">
+              <a:rot lat="0" lon="0" rev="1200000"/>
+            </a:lightRig>
+          </a:scene3d>
+          <a:sp3d>
+            <a:bevelT w="63500" h="25400"/>
+          </a:sp3d>
+        </a:effectStyle>
+      </a:effectStyleLst>
+      <a:bgFillStyleLst>
+        <a:solidFill>
+          <a:schemeClr val="phClr"/>
+        </a:solidFill>
+        <a:gradFill rotWithShape="1">
+          <a:gsLst>
+            <a:gs pos="0">
+              <a:schemeClr val="phClr">
+                <a:tint val="40000"/>
+                <a:satMod val="350000"/>
+              </a:schemeClr>
+            </a:gs>
+            <a:gs pos="40000">
+              <a:schemeClr val="phClr">
+                <a:tint val="45000"/>
+                <a:shade val="99000"/>
+                <a:satMod val="350000"/>
+              </a:schemeClr>
+            </a:gs>
+            <a:gs pos="100000">
+              <a:schemeClr val="phClr">
+                <a:shade val="20000"/>
+                <a:satMod val="255000"/>
+              </a:schemeClr>
+            </a:gs>
+          </a:gsLst>
+          <a:path path="circle">
+            <a:fillToRect l="50000" t="-80000" r="50000" b="180000"/>
+          </a:path>
+        </a:gradFill>
+        <a:gradFill rotWithShape="1">
+          <a:gsLst>
+            <a:gs pos="0">
+              <a:schemeClr val="phClr">
+                <a:tint val="80000"/>
+                <a:satMod val="300000"/>
+              </a:schemeClr>
+            </a:gs>
+            <a:gs pos="100000">
+              <a:schemeClr val="phClr">
+                <a:shade val="30000"/>
+                <a:satMod val="200000"/>
+              </a:schemeClr>
+            </a:gs>
+          </a:gsLst>
+          <a:path path="circle">
+            <a:fillToRect l="50000" t="50000" r="50000" b="50000"/>
+          </a:path>
+        </a:gradFill>
+      </a:bgFillStyleLst>
+    </a:fmtScheme>
+  </a:themeElements>
+</a:theme>
+</file>
+
+<file path=ppt/theme/theme2.xml><?xml version="1.0" encoding="utf-8"?>
 <a:theme xmlns:a="http://schemas.openxmlformats.org/drawingml/2006/main" xmlns:r="http://schemas.openxmlformats.org/officeDocument/2006/relationships">
   <a:themeElements>
     <a:clrScheme name="Default">
@@ -26830,283 +25741,4 @@
     </a:fmtScheme>
   </a:themeElements>
 </a:theme>
-</file>
-
-<file path=ppt/theme/theme2.xml><?xml version="1.0" encoding="utf-8"?>
-<a:theme xmlns:a="http://schemas.openxmlformats.org/drawingml/2006/main" xmlns:r="http://schemas.openxmlformats.org/officeDocument/2006/relationships" name="Simple Light">
-  <a:themeElements>
-    <a:clrScheme name="Simple Light">
-      <a:dk1>
-        <a:srgbClr val="000000"/>
-      </a:dk1>
-      <a:lt1>
-        <a:srgbClr val="FFFFFF"/>
-      </a:lt1>
-      <a:dk2>
-        <a:srgbClr val="595959"/>
-      </a:dk2>
-      <a:lt2>
-        <a:srgbClr val="EEEEEE"/>
-      </a:lt2>
-      <a:accent1>
-        <a:srgbClr val="4285F4"/>
-      </a:accent1>
-      <a:accent2>
-        <a:srgbClr val="212121"/>
-      </a:accent2>
-      <a:accent3>
-        <a:srgbClr val="78909C"/>
-      </a:accent3>
-      <a:accent4>
-        <a:srgbClr val="FFAB40"/>
-      </a:accent4>
-      <a:accent5>
-        <a:srgbClr val="0097A7"/>
-      </a:accent5>
-      <a:accent6>
-        <a:srgbClr val="EEFF41"/>
-      </a:accent6>
-      <a:hlink>
-        <a:srgbClr val="0097A7"/>
-      </a:hlink>
-      <a:folHlink>
-        <a:srgbClr val="0097A7"/>
-      </a:folHlink>
-    </a:clrScheme>
-    <a:fontScheme name="Office">
-      <a:majorFont>
-        <a:latin typeface="Arial"/>
-        <a:ea typeface=""/>
-        <a:cs typeface=""/>
-        <a:font script="Jpan" typeface="ＭＳ Ｐゴシック"/>
-        <a:font script="Hang" typeface="맑은 고딕"/>
-        <a:font script="Hans" typeface="宋体"/>
-        <a:font script="Hant" typeface="新細明體"/>
-        <a:font script="Arab" typeface="Times New Roman"/>
-        <a:font script="Hebr" typeface="Times New Roman"/>
-        <a:font script="Thai" typeface="Angsana New"/>
-        <a:font script="Ethi" typeface="Nyala"/>
-        <a:font script="Beng" typeface="Vrinda"/>
-        <a:font script="Gujr" typeface="Shruti"/>
-        <a:font script="Khmr" typeface="MoolBoran"/>
-        <a:font script="Knda" typeface="Tunga"/>
-        <a:font script="Guru" typeface="Raavi"/>
-        <a:font script="Cans" typeface="Euphemia"/>
-        <a:font script="Cher" typeface="Plantagenet Cherokee"/>
-        <a:font script="Yiii" typeface="Microsoft Yi Baiti"/>
-        <a:font script="Tibt" typeface="Microsoft Himalaya"/>
-        <a:font script="Thaa" typeface="MV Boli"/>
-        <a:font script="Deva" typeface="Mangal"/>
-        <a:font script="Telu" typeface="Gautami"/>
-        <a:font script="Taml" typeface="Latha"/>
-        <a:font script="Syrc" typeface="Estrangelo Edessa"/>
-        <a:font script="Orya" typeface="Kalinga"/>
-        <a:font script="Mlym" typeface="Kartika"/>
-        <a:font script="Laoo" typeface="DokChampa"/>
-        <a:font script="Sinh" typeface="Iskoola Pota"/>
-        <a:font script="Mong" typeface="Mongolian Baiti"/>
-        <a:font script="Viet" typeface="Times New Roman"/>
-        <a:font script="Uigh" typeface="Microsoft Uighur"/>
-        <a:font script="Geor" typeface="Sylfaen"/>
-      </a:majorFont>
-      <a:minorFont>
-        <a:latin typeface="Arial"/>
-        <a:ea typeface=""/>
-        <a:cs typeface=""/>
-        <a:font script="Jpan" typeface="ＭＳ Ｐゴシック"/>
-        <a:font script="Hang" typeface="맑은 고딕"/>
-        <a:font script="Hans" typeface="宋体"/>
-        <a:font script="Hant" typeface="新細明體"/>
-        <a:font script="Arab" typeface="Arial"/>
-        <a:font script="Hebr" typeface="Arial"/>
-        <a:font script="Thai" typeface="Cordia New"/>
-        <a:font script="Ethi" typeface="Nyala"/>
-        <a:font script="Beng" typeface="Vrinda"/>
-        <a:font script="Gujr" typeface="Shruti"/>
-        <a:font script="Khmr" typeface="DaunPenh"/>
-        <a:font script="Knda" typeface="Tunga"/>
-        <a:font script="Guru" typeface="Raavi"/>
-        <a:font script="Cans" typeface="Euphemia"/>
-        <a:font script="Cher" typeface="Plantagenet Cherokee"/>
-        <a:font script="Yiii" typeface="Microsoft Yi Baiti"/>
-        <a:font script="Tibt" typeface="Microsoft Himalaya"/>
-        <a:font script="Thaa" typeface="MV Boli"/>
-        <a:font script="Deva" typeface="Mangal"/>
-        <a:font script="Telu" typeface="Gautami"/>
-        <a:font script="Taml" typeface="Latha"/>
-        <a:font script="Syrc" typeface="Estrangelo Edessa"/>
-        <a:font script="Orya" typeface="Kalinga"/>
-        <a:font script="Mlym" typeface="Kartika"/>
-        <a:font script="Laoo" typeface="DokChampa"/>
-        <a:font script="Sinh" typeface="Iskoola Pota"/>
-        <a:font script="Mong" typeface="Mongolian Baiti"/>
-        <a:font script="Viet" typeface="Arial"/>
-        <a:font script="Uigh" typeface="Microsoft Uighur"/>
-        <a:font script="Geor" typeface="Sylfaen"/>
-      </a:minorFont>
-    </a:fontScheme>
-    <a:fmtScheme name="Office">
-      <a:fillStyleLst>
-        <a:solidFill>
-          <a:schemeClr val="phClr"/>
-        </a:solidFill>
-        <a:gradFill rotWithShape="1">
-          <a:gsLst>
-            <a:gs pos="0">
-              <a:schemeClr val="phClr">
-                <a:tint val="50000"/>
-                <a:satMod val="300000"/>
-              </a:schemeClr>
-            </a:gs>
-            <a:gs pos="35000">
-              <a:schemeClr val="phClr">
-                <a:tint val="37000"/>
-                <a:satMod val="300000"/>
-              </a:schemeClr>
-            </a:gs>
-            <a:gs pos="100000">
-              <a:schemeClr val="phClr">
-                <a:tint val="15000"/>
-                <a:satMod val="350000"/>
-              </a:schemeClr>
-            </a:gs>
-          </a:gsLst>
-          <a:lin ang="16200000" scaled="1"/>
-        </a:gradFill>
-        <a:gradFill rotWithShape="1">
-          <a:gsLst>
-            <a:gs pos="0">
-              <a:schemeClr val="phClr">
-                <a:tint val="100000"/>
-                <a:shade val="100000"/>
-                <a:satMod val="130000"/>
-              </a:schemeClr>
-            </a:gs>
-            <a:gs pos="100000">
-              <a:schemeClr val="phClr">
-                <a:tint val="50000"/>
-                <a:shade val="100000"/>
-                <a:satMod val="350000"/>
-              </a:schemeClr>
-            </a:gs>
-          </a:gsLst>
-          <a:lin ang="16200000" scaled="0"/>
-        </a:gradFill>
-      </a:fillStyleLst>
-      <a:lnStyleLst>
-        <a:ln w="9525" cap="flat" cmpd="sng" algn="ctr">
-          <a:solidFill>
-            <a:schemeClr val="phClr">
-              <a:shade val="95000"/>
-              <a:satMod val="105000"/>
-            </a:schemeClr>
-          </a:solidFill>
-          <a:prstDash val="solid"/>
-        </a:ln>
-        <a:ln w="25400" cap="flat" cmpd="sng" algn="ctr">
-          <a:solidFill>
-            <a:schemeClr val="phClr"/>
-          </a:solidFill>
-          <a:prstDash val="solid"/>
-        </a:ln>
-        <a:ln w="38100" cap="flat" cmpd="sng" algn="ctr">
-          <a:solidFill>
-            <a:schemeClr val="phClr"/>
-          </a:solidFill>
-          <a:prstDash val="solid"/>
-        </a:ln>
-      </a:lnStyleLst>
-      <a:effectStyleLst>
-        <a:effectStyle>
-          <a:effectLst>
-            <a:outerShdw blurRad="40000" dist="20000" dir="5400000" rotWithShape="0">
-              <a:srgbClr val="000000">
-                <a:alpha val="38000"/>
-              </a:srgbClr>
-            </a:outerShdw>
-          </a:effectLst>
-        </a:effectStyle>
-        <a:effectStyle>
-          <a:effectLst>
-            <a:outerShdw blurRad="40000" dist="23000" dir="5400000" rotWithShape="0">
-              <a:srgbClr val="000000">
-                <a:alpha val="35000"/>
-              </a:srgbClr>
-            </a:outerShdw>
-          </a:effectLst>
-        </a:effectStyle>
-        <a:effectStyle>
-          <a:effectLst>
-            <a:outerShdw blurRad="40000" dist="23000" dir="5400000" rotWithShape="0">
-              <a:srgbClr val="000000">
-                <a:alpha val="35000"/>
-              </a:srgbClr>
-            </a:outerShdw>
-          </a:effectLst>
-          <a:scene3d>
-            <a:camera prst="orthographicFront">
-              <a:rot lat="0" lon="0" rev="0"/>
-            </a:camera>
-            <a:lightRig rig="threePt" dir="t">
-              <a:rot lat="0" lon="0" rev="1200000"/>
-            </a:lightRig>
-          </a:scene3d>
-          <a:sp3d>
-            <a:bevelT w="63500" h="25400"/>
-          </a:sp3d>
-        </a:effectStyle>
-      </a:effectStyleLst>
-      <a:bgFillStyleLst>
-        <a:solidFill>
-          <a:schemeClr val="phClr"/>
-        </a:solidFill>
-        <a:gradFill rotWithShape="1">
-          <a:gsLst>
-            <a:gs pos="0">
-              <a:schemeClr val="phClr">
-                <a:tint val="40000"/>
-                <a:satMod val="350000"/>
-              </a:schemeClr>
-            </a:gs>
-            <a:gs pos="40000">
-              <a:schemeClr val="phClr">
-                <a:tint val="45000"/>
-                <a:shade val="99000"/>
-                <a:satMod val="350000"/>
-              </a:schemeClr>
-            </a:gs>
-            <a:gs pos="100000">
-              <a:schemeClr val="phClr">
-                <a:shade val="20000"/>
-                <a:satMod val="255000"/>
-              </a:schemeClr>
-            </a:gs>
-          </a:gsLst>
-          <a:path path="circle">
-            <a:fillToRect l="50000" t="-80000" r="50000" b="180000"/>
-          </a:path>
-        </a:gradFill>
-        <a:gradFill rotWithShape="1">
-          <a:gsLst>
-            <a:gs pos="0">
-              <a:schemeClr val="phClr">
-                <a:tint val="80000"/>
-                <a:satMod val="300000"/>
-              </a:schemeClr>
-            </a:gs>
-            <a:gs pos="100000">
-              <a:schemeClr val="phClr">
-                <a:shade val="30000"/>
-                <a:satMod val="200000"/>
-              </a:schemeClr>
-            </a:gs>
-          </a:gsLst>
-          <a:path path="circle">
-            <a:fillToRect l="50000" t="50000" r="50000" b="50000"/>
-          </a:path>
-        </a:gradFill>
-      </a:bgFillStyleLst>
-    </a:fmtScheme>
-  </a:themeElements>
-</a:theme>
 </file>
</xml_diff>

<commit_message>
Publish planner lab notebook, ghost status display and revised slides
</commit_message>
<xml_diff>
--- a/labs/lab-01-kev-pacman/slides/pacman-lab.pptx
+++ b/labs/lab-01-kev-pacman/slides/pacman-lab.pptx
@@ -1069,7 +1069,22 @@
             </a:pPr>
             <a:r>
               <a:rPr lang="zh-CN"/>
-              <a:t>The main lab uses Qwen/Qwen3.5-4B-Base@1001bb4d826a52d1f399e183466143f4da7b741b, fresh rank-16 LoRA (alpha 32) targeting all projections and a 256-dimensional pointer head. Follow the four general training stages in Kev-4B's released curriculum, each in a separate notebook cell and checkpoint. Stage 5 warm-starts the learner's skills checkpoint for Pac-Man imitation. The original base matrices remain fixed while LoRA changes effective features. Calibration is separate and is not fitted or copied from the release. A 0.8B adapter cannot initialize the 4B model. Sources: https://huggingface.co/jaredpalmer/kev-4b ; https://github.com/jaredpalmer/kev/blob/84847f0a883d900f7de5b7a57eaa341ca7f9a6b4/experiments/q35-4b-s23.json</a:t>
+              <a:t>The lab uses Qwen/Qwen3.5-4B-Base@1001bb4d826a52d1f399e183466143f4da7b741b. Rank-16 LoRA (alpha 32) targets all supported projections, plus a 256-dimensional pointer head; the base matrices stay fixed. CP0 serves the completed Skills adapter. CP3 warm-starts that adapter for a separate Pac-Man task stage. The native game is masonicGIT/pacman@7407174c1d6a38be8cd230577489e39e0873145b. It retains the classic maze, assets, four ghost personalities, release rules, speed tables, phases, power pellets and fruit. It is a faithful recreation with documented differences from the arcade ROM. Calibration remains separate. Sources: https://huggingface.co/jaredpalmer/kev-4b ; https://github.com/masonicGIT/pacman/tree/7407174c1d6a38be8cd230577489e39e0873145b ; https://github.com/yxc20089/QPlusLearning/tree/main/labs/lab-01-kev-pacman</a:t>
+            </a:r>
+            <a:endParaRPr/>
+          </a:p>
+          <a:p>
+            <a:pPr indent="0" lvl="0" marL="0" rtl="0" algn="l">
+              <a:spcBef>
+                <a:spcPts val="0"/>
+              </a:spcBef>
+              <a:spcAft>
+                <a:spcPts val="0"/>
+              </a:spcAft>
+              <a:buNone/>
+            </a:pPr>
+            <a:r>
+              <a:t/>
             </a:r>
             <a:endParaRPr/>
           </a:p>
@@ -1169,7 +1184,22 @@
             </a:pPr>
             <a:r>
               <a:rPr lang="zh-CN"/>
-              <a:t>Installation, optimized-kernel verification, downloads and all four general decision stages are prework. Keep 90 minutes in class with a mandatory 30-minute Pac-Man fine-tuning block: inspect for 5 minutes, train within a 20-minute attempt cap, inspect/save for 5 minutes. These are scheduling budgets, not measured training durations. Check the separate initial, dates, documents and skills configurations and TensorBoard curves. Source: https://github.com/yxc20089/QPlusLearning/tree/main/labs/lab-01-kev-pacman</a:t>
+              <a:t>Keep the 90-minute lab with a 30-minute fine-tuning block. Installation, model downloads, four general decision stages and offline label generation are prework. The Pac-Man stage now runs a full epoch over 4,096 task records and 2,000 decision-v7 replay records, giving 762 updates at effective batch eight. There is no automatic short-step cap. Time the full stage before class. At 1.5 seconds per update, optimizer work is about 19 minutes; at 3 seconds it is about 38 minutes, plus loading/compilation/saving. These are calculations, not measured GPU timings. Complete slower full runs as prework. Source: https://github.com/yxc20089/QPlusLearning/tree/main/labs/lab-01-kev-pacman/cloud_runtime.py</a:t>
+            </a:r>
+            <a:endParaRPr/>
+          </a:p>
+          <a:p>
+            <a:pPr indent="0" lvl="0" marL="0" rtl="0" algn="l">
+              <a:spcBef>
+                <a:spcPts val="0"/>
+              </a:spcBef>
+              <a:spcAft>
+                <a:spcPts val="0"/>
+              </a:spcAft>
+              <a:buNone/>
+            </a:pPr>
+            <a:r>
+              <a:t/>
             </a:r>
             <a:endParaRPr/>
           </a:p>
@@ -1269,7 +1299,22 @@
             </a:pPr>
             <a:r>
               <a:rPr lang="zh-CN"/>
-              <a:t>Kev-4B retains a hybrid Gated DeltaNet/full-attention backbone. Install hash-pinned flash-linear-attention/fla-core 0.5.2, causal-conv1d 1.7.0 (cp313, Torch 2.8, CUDA 12, Linux x86_64 CXX11 ABI), einops 0.8.1 and Ninja 1.13.0 without replacing Kev's frozen Torch 2.8.0/CUDA 12.8, Triton 3.4.0, Transformers 5.17.0 and PEFT stack. Require BF16 and verify actual loss/backward/LoRA-head gradients plus fused AdamW on two suite records. Reference-kernel fallback fails the check. This checks compatibility rather than full-stage memory or timing. Default execution: batch 1 × accumulation 8, non-reentrant checkpointing, row_budget 2048; full attention uses SDPA. Inference-only Kev fusion/CUDA graphs remain disabled for training. The course has no completed GPU run of this 4B setup. Colab allocation varies, including on paid plans; arrange access and measure compute-unit cost. T4/P100 do not satisfy this optimized training contract. Sources: https://huggingface.co/docs/transformers/en/model_doc/qwen3_5 ; https://github.com/fla-org/flash-linear-attention/releases/tag/v0.5.2 ; https://github.com/Dao-AILab/causal-conv1d/releases/tag/v1.7.0 ; https://research.google.com/colaboratory/faq.html</a:t>
+              <a:t>Require the pinned optimized stack: PyTorch 2.8.0/CUDA 12.8, Triton 3.4.0, Transformers 5.17.0, PEFT 0.21.0, FLA/fla-core 0.5.2, causal-conv1d 1.7.0, einops 0.8.1, Ninja 1.13.0. Training uses BF16 autocast over FP32 stored parameters, non-reentrant gradient checkpointing, fused AdamW, FLA gated-delta kernels and SDPA full attention. Kernel binding verification is the default; the separate actual CUDA loss/backward check is optional and may compile slowly on a fresh runtime. Pac-Man explicitly selects batch 4 x accumulation 2 and row_budget 0 after the generic profile. Earlier long-document stages retain their memory-safe execution profile. Colab allocation and compute-unit costs vary. No course-author GPU timing is claimed. Sources: https://huggingface.co/docs/transformers/en/model_doc/qwen3_5 ; https://github.com/fla-org/flash-linear-attention/releases/tag/v0.5.2 ; https://github.com/Dao-AILab/causal-conv1d/releases/tag/v1.7.0 ; https://github.com/yxc20089/QPlusLearning/tree/main/labs/lab-01-kev-pacman/optimized_training.py</a:t>
+            </a:r>
+            <a:endParaRPr/>
+          </a:p>
+          <a:p>
+            <a:pPr indent="0" lvl="0" marL="0" rtl="0" algn="l">
+              <a:spcBef>
+                <a:spcPts val="0"/>
+              </a:spcBef>
+              <a:spcAft>
+                <a:spcPts val="0"/>
+              </a:spcAft>
+              <a:buNone/>
+            </a:pPr>
+            <a:r>
+              <a:t/>
             </a:r>
             <a:endParaRPr/>
           </a:p>
@@ -1369,7 +1414,7 @@
             </a:pPr>
             <a:r>
               <a:rPr lang="zh-CN"/>
-              <a:t>Keep the established player/ghost role. Existing community adaptation has one 13-by-15 maze, two deterministic ghosts and no power pellets. Ghosts move after every second player move. The simulation waits for inference, so wall-clock survival confounds latency with skill. No screenshot encoder or ROM is used in this lab.</a:t>
+              <a:t>Blinky targets Pac-Man; Pinky targets four tiles ahead with the native upward overflow quirk; Inky reflects the two-tile-ahead point around Blinky, also preserving the upward quirk; Clyde targets Pac-Man when far away and its scatter corner when close. Chase/scatter turns use deterministic native targeting and tie-breaking. Frightened turns use the native RNG. Ghost-house release uses native pellet counters and inactivity timeouts: at level 1 Pinky releases first, Inky has a personal threshold of 30, Clyde 60, and a four-second no-pellet timeout can release the next waiting ghost. These are personal counters, not total board pellets. Game time pauses while the model decides, so wall-clock minutes can represent only a few simulation seconds. The UI shows simulated seconds and each ghost mode; do not force every ghost outside at the start. Sources: https://github.com/masonicGIT/pacman/blob/7407174c1d6a38be8cd230577489e39e0873145b/src/targets.js ; https://github.com/masonicGIT/pacman/blob/7407174c1d6a38be8cd230577489e39e0873145b/src/ghostReleaser.js ; https://github.com/yxc20089/QPlusLearning/tree/main/labs/lab-01-kev-pacman/games/arcade-engine.js</a:t>
             </a:r>
             <a:endParaRPr/>
           </a:p>
@@ -1384,167 +1429,7 @@
               <a:buNone/>
             </a:pPr>
             <a:r>
-              <a:rPr lang="zh-CN"/>
-              <a:t>Source: https://github.com/codaaiteam/jev-pacman/tree/8446fe74690cd61909bda91acfadbccb0f02b422 ; lab/pacman_lab.py.</a:t>
-            </a:r>
-            <a:endParaRPr/>
-          </a:p>
-          <a:p>
-            <a:pPr indent="0" lvl="0" marL="0" rtl="0" algn="l">
-              <a:spcBef>
-                <a:spcPts val="0"/>
-              </a:spcBef>
-              <a:spcAft>
-                <a:spcPts val="0"/>
-              </a:spcAft>
-              <a:buNone/>
-            </a:pPr>
-            <a:r>
               <a:t/>
-            </a:r>
-            <a:endParaRPr/>
-          </a:p>
-          <a:p>
-            <a:pPr indent="0" lvl="0" marL="0" rtl="0" algn="l">
-              <a:spcBef>
-                <a:spcPts val="0"/>
-              </a:spcBef>
-              <a:spcAft>
-                <a:spcPts val="0"/>
-              </a:spcAft>
-              <a:buNone/>
-            </a:pPr>
-            <a:r>
-              <a:rPr lang="zh-CN"/>
-              <a:t>Reference URLs checked October 2, 2026:</a:t>
-            </a:r>
-            <a:endParaRPr/>
-          </a:p>
-          <a:p>
-            <a:pPr indent="0" lvl="0" marL="0" rtl="0" algn="l">
-              <a:spcBef>
-                <a:spcPts val="0"/>
-              </a:spcBef>
-              <a:spcAft>
-                <a:spcPts val="0"/>
-              </a:spcAft>
-              <a:buNone/>
-            </a:pPr>
-            <a:r>
-              <a:rPr lang="zh-CN"/>
-              <a:t>https://github.com/jaredpalmer/kev/tree/84847f0a883d900f7de5b7a57eaa341ca7f9a6b4</a:t>
-            </a:r>
-            <a:endParaRPr/>
-          </a:p>
-          <a:p>
-            <a:pPr indent="0" lvl="0" marL="0" rtl="0" algn="l">
-              <a:spcBef>
-                <a:spcPts val="0"/>
-              </a:spcBef>
-              <a:spcAft>
-                <a:spcPts val="0"/>
-              </a:spcAft>
-              <a:buNone/>
-            </a:pPr>
-            <a:r>
-              <a:rPr lang="zh-CN"/>
-              <a:t>https://github.com/Contrastive-LM/CLM/tree/bb42c6c5bf914fd449bed2f6ca65be80602cb1f7</a:t>
-            </a:r>
-            <a:endParaRPr/>
-          </a:p>
-          <a:p>
-            <a:pPr indent="0" lvl="0" marL="0" rtl="0" algn="l">
-              <a:spcBef>
-                <a:spcPts val="0"/>
-              </a:spcBef>
-              <a:spcAft>
-                <a:spcPts val="0"/>
-              </a:spcAft>
-              <a:buNone/>
-            </a:pPr>
-            <a:r>
-              <a:rPr lang="zh-CN"/>
-              <a:t>https://github.com/Contrastive-LM/CLM/blob/bb42c6c5bf914fd449bed2f6ca65be80602cb1f7/src/clm/heads.py</a:t>
-            </a:r>
-            <a:endParaRPr/>
-          </a:p>
-          <a:p>
-            <a:pPr indent="0" lvl="0" marL="0" rtl="0" algn="l">
-              <a:spcBef>
-                <a:spcPts val="0"/>
-              </a:spcBef>
-              <a:spcAft>
-                <a:spcPts val="0"/>
-              </a:spcAft>
-              <a:buNone/>
-            </a:pPr>
-            <a:r>
-              <a:rPr lang="zh-CN"/>
-              <a:t>https://github.com/Contrastive-LM/CLM/blob/bb42c6c5bf914fd449bed2f6ca65be80602cb1f7/train/finetune.py</a:t>
-            </a:r>
-            <a:endParaRPr/>
-          </a:p>
-          <a:p>
-            <a:pPr indent="0" lvl="0" marL="0" rtl="0" algn="l">
-              <a:spcBef>
-                <a:spcPts val="0"/>
-              </a:spcBef>
-              <a:spcAft>
-                <a:spcPts val="0"/>
-              </a:spcAft>
-              <a:buNone/>
-            </a:pPr>
-            <a:r>
-              <a:rPr lang="zh-CN"/>
-              <a:t>https://github.com/jaredpalmer/kev/blob/84847f0a883d900f7de5b7a57eaa341ca7f9a6b4/kev/model.py</a:t>
-            </a:r>
-            <a:endParaRPr/>
-          </a:p>
-          <a:p>
-            <a:pPr indent="0" lvl="0" marL="0" rtl="0" algn="l">
-              <a:spcBef>
-                <a:spcPts val="0"/>
-              </a:spcBef>
-              <a:spcAft>
-                <a:spcPts val="0"/>
-              </a:spcAft>
-              <a:buNone/>
-            </a:pPr>
-            <a:r>
-              <a:rPr lang="zh-CN"/>
-              <a:t>https://huggingface.co/blog/ggml-org/decision-models-in-llamacpp</a:t>
-            </a:r>
-            <a:endParaRPr/>
-          </a:p>
-          <a:p>
-            <a:pPr indent="0" lvl="0" marL="0" rtl="0" algn="l">
-              <a:spcBef>
-                <a:spcPts val="0"/>
-              </a:spcBef>
-              <a:spcAft>
-                <a:spcPts val="0"/>
-              </a:spcAft>
-              <a:buNone/>
-            </a:pPr>
-            <a:r>
-              <a:rPr lang="zh-CN"/>
-              <a:t>https://github.com/ggml-org/llama.cpp/pull/29818</a:t>
-            </a:r>
-            <a:endParaRPr/>
-          </a:p>
-          <a:p>
-            <a:pPr indent="0" lvl="0" marL="0" rtl="0" algn="l">
-              <a:spcBef>
-                <a:spcPts val="0"/>
-              </a:spcBef>
-              <a:spcAft>
-                <a:spcPts val="0"/>
-              </a:spcAft>
-              <a:buNone/>
-            </a:pPr>
-            <a:r>
-              <a:rPr lang="zh-CN"/>
-              <a:t>CLM article: supplied Contrastive Language Models PDF, pages 6-8; https://contrastive-lm.notion.site/</a:t>
             </a:r>
             <a:endParaRPr/>
           </a:p>
@@ -2194,7 +2079,7 @@
             </a:pPr>
             <a:r>
               <a:rPr lang="zh-CN"/>
-              <a:t>The existing reproducible dataset is retained: immediate safety, shortest paths to dots, ghost separation and a fixed direction tie order. It is heuristic imitation on one maze, not optimal actions or human recordings. Position groups are disjoint across splits. Kev adaptation uses labelled System One JSONL with each structured state, movement question, legal criteria and correct direction. Learners can replace teacher labels only in the training partition. Do not leak labels or metadata into observations, and do not tune on the 16 evaluation boards.</a:t>
+              <a:t>The committed planner dataset has 4,096 train, 256 development and 256 evaluation boards, stored in a checksum-verified compact ZIP. Collect native-game episodes with 70% planner, 20% old heuristic and 10% random legal exploration; snapshot eligible states every fourth move. Each label searches up to 20 legal player moves with beam width eight per first action. Native ghost code predicts normal chase/scatter; two independent future RNG scenarios handle frightened turns and sampled fruit duration. Optimize worst-scenario survival, then mean score, pellets, revisits, nearest-pellet distance and ghost distance. Finite horizon and pruning make this approximate planning, not globally optimal play. The teacher has current native timers/pixel offsets; the student sees board, ghost modes, history and elapsed frames. This is privileged-state imitation. Whole episodes and exact observable-state hashes are disjoint across splits; the maze is shared. Label and search metadata never enter model observations. Source: https://github.com/yxc20089/QPlusLearning/tree/main/labs/lab-01-kev-pacman/planner_data.py ; https://github.com/yxc20089/QPlusLearning/tree/main/labs/lab-01-kev-pacman/games/arcade-planner.js ; https://github.com/yxc20089/QPlusLearning/tree/main/labs/lab-01-kev-pacman/data/pacman-planner-v1-manifest.json</a:t>
             </a:r>
             <a:endParaRPr/>
           </a:p>
@@ -2209,167 +2094,7 @@
               <a:buNone/>
             </a:pPr>
             <a:r>
-              <a:rPr lang="zh-CN"/>
-              <a:t>Source: lab/pacman_lab.py and lab/data/pacman-manifest.json.</a:t>
-            </a:r>
-            <a:endParaRPr/>
-          </a:p>
-          <a:p>
-            <a:pPr indent="0" lvl="0" marL="0" rtl="0" algn="l">
-              <a:spcBef>
-                <a:spcPts val="0"/>
-              </a:spcBef>
-              <a:spcAft>
-                <a:spcPts val="0"/>
-              </a:spcAft>
-              <a:buNone/>
-            </a:pPr>
-            <a:r>
               <a:t/>
-            </a:r>
-            <a:endParaRPr/>
-          </a:p>
-          <a:p>
-            <a:pPr indent="0" lvl="0" marL="0" rtl="0" algn="l">
-              <a:spcBef>
-                <a:spcPts val="0"/>
-              </a:spcBef>
-              <a:spcAft>
-                <a:spcPts val="0"/>
-              </a:spcAft>
-              <a:buNone/>
-            </a:pPr>
-            <a:r>
-              <a:rPr lang="zh-CN"/>
-              <a:t>Reference URLs checked October 2, 2026:</a:t>
-            </a:r>
-            <a:endParaRPr/>
-          </a:p>
-          <a:p>
-            <a:pPr indent="0" lvl="0" marL="0" rtl="0" algn="l">
-              <a:spcBef>
-                <a:spcPts val="0"/>
-              </a:spcBef>
-              <a:spcAft>
-                <a:spcPts val="0"/>
-              </a:spcAft>
-              <a:buNone/>
-            </a:pPr>
-            <a:r>
-              <a:rPr lang="zh-CN"/>
-              <a:t>https://github.com/jaredpalmer/kev/tree/84847f0a883d900f7de5b7a57eaa341ca7f9a6b4</a:t>
-            </a:r>
-            <a:endParaRPr/>
-          </a:p>
-          <a:p>
-            <a:pPr indent="0" lvl="0" marL="0" rtl="0" algn="l">
-              <a:spcBef>
-                <a:spcPts val="0"/>
-              </a:spcBef>
-              <a:spcAft>
-                <a:spcPts val="0"/>
-              </a:spcAft>
-              <a:buNone/>
-            </a:pPr>
-            <a:r>
-              <a:rPr lang="zh-CN"/>
-              <a:t>https://github.com/Contrastive-LM/CLM/tree/bb42c6c5bf914fd449bed2f6ca65be80602cb1f7</a:t>
-            </a:r>
-            <a:endParaRPr/>
-          </a:p>
-          <a:p>
-            <a:pPr indent="0" lvl="0" marL="0" rtl="0" algn="l">
-              <a:spcBef>
-                <a:spcPts val="0"/>
-              </a:spcBef>
-              <a:spcAft>
-                <a:spcPts val="0"/>
-              </a:spcAft>
-              <a:buNone/>
-            </a:pPr>
-            <a:r>
-              <a:rPr lang="zh-CN"/>
-              <a:t>https://github.com/Contrastive-LM/CLM/blob/bb42c6c5bf914fd449bed2f6ca65be80602cb1f7/src/clm/heads.py</a:t>
-            </a:r>
-            <a:endParaRPr/>
-          </a:p>
-          <a:p>
-            <a:pPr indent="0" lvl="0" marL="0" rtl="0" algn="l">
-              <a:spcBef>
-                <a:spcPts val="0"/>
-              </a:spcBef>
-              <a:spcAft>
-                <a:spcPts val="0"/>
-              </a:spcAft>
-              <a:buNone/>
-            </a:pPr>
-            <a:r>
-              <a:rPr lang="zh-CN"/>
-              <a:t>https://github.com/Contrastive-LM/CLM/blob/bb42c6c5bf914fd449bed2f6ca65be80602cb1f7/train/finetune.py</a:t>
-            </a:r>
-            <a:endParaRPr/>
-          </a:p>
-          <a:p>
-            <a:pPr indent="0" lvl="0" marL="0" rtl="0" algn="l">
-              <a:spcBef>
-                <a:spcPts val="0"/>
-              </a:spcBef>
-              <a:spcAft>
-                <a:spcPts val="0"/>
-              </a:spcAft>
-              <a:buNone/>
-            </a:pPr>
-            <a:r>
-              <a:rPr lang="zh-CN"/>
-              <a:t>https://github.com/jaredpalmer/kev/blob/84847f0a883d900f7de5b7a57eaa341ca7f9a6b4/kev/model.py</a:t>
-            </a:r>
-            <a:endParaRPr/>
-          </a:p>
-          <a:p>
-            <a:pPr indent="0" lvl="0" marL="0" rtl="0" algn="l">
-              <a:spcBef>
-                <a:spcPts val="0"/>
-              </a:spcBef>
-              <a:spcAft>
-                <a:spcPts val="0"/>
-              </a:spcAft>
-              <a:buNone/>
-            </a:pPr>
-            <a:r>
-              <a:rPr lang="zh-CN"/>
-              <a:t>https://huggingface.co/blog/ggml-org/decision-models-in-llamacpp</a:t>
-            </a:r>
-            <a:endParaRPr/>
-          </a:p>
-          <a:p>
-            <a:pPr indent="0" lvl="0" marL="0" rtl="0" algn="l">
-              <a:spcBef>
-                <a:spcPts val="0"/>
-              </a:spcBef>
-              <a:spcAft>
-                <a:spcPts val="0"/>
-              </a:spcAft>
-              <a:buNone/>
-            </a:pPr>
-            <a:r>
-              <a:rPr lang="zh-CN"/>
-              <a:t>https://github.com/ggml-org/llama.cpp/pull/29818</a:t>
-            </a:r>
-            <a:endParaRPr/>
-          </a:p>
-          <a:p>
-            <a:pPr indent="0" lvl="0" marL="0" rtl="0" algn="l">
-              <a:spcBef>
-                <a:spcPts val="0"/>
-              </a:spcBef>
-              <a:spcAft>
-                <a:spcPts val="0"/>
-              </a:spcAft>
-              <a:buNone/>
-            </a:pPr>
-            <a:r>
-              <a:rPr lang="zh-CN"/>
-              <a:t>CLM article: supplied Contrastive Language Models PDF, pages 6-8; https://contrastive-lm.notion.site/</a:t>
             </a:r>
             <a:endParaRPr/>
           </a:p>
@@ -2469,7 +2194,22 @@
             </a:pPr>
             <a:r>
               <a:rPr lang="zh-CN"/>
-              <a:t>Stage 1 selects seed 2 in experiments/q35-4b-s23.json: 12,576 source records, two epochs, lr 5e-5, batch 4 × accumulation 2, checkpointing, BF16 autocast over FP32 parameters, rank 16/alpha 32, head 256; no init_from. Stage 2: dates/missing evidence, 1,425 new + 2,000 replay, one epoch, lr 2e-5, batch 4 × accumulation 2, seed 1. Stage 3: documents-v1 train, 5,219 new + 2,000 replay, one epoch, lr 2e-5, batch 2 × accumulation 4, max_state 7552, seed 2. Stage 4: hard-v1 train (6,000) + devtools-v1 train (5,320) with 4,000 replay, one epoch, lr 2e-5, batch 2 × accumulation 4, max_state 7552, seed 1. Expected steps: 3144, 429, 903, 1915. All general stages preserve option/none/distractor augmentation and p_none_pair=.25. Default lab execution uses batch 1 × accumulation 8, checkpointing and row_budget 2048: same effective batch/curriculum/schedule, different grouping/dropout and kernel numerics. The skills concatenation uses verified public partitions and a course checksum; byte identity to the historical round10 joint file is not asserted. Replay uses decision-v7 train only. General attempt caps are configurable 180 minutes, not predictions. Stage 5: 64 Pac-Man train boards, two epochs, lr 2e-5, batch 1 × accumulation 8, 16 steps, no none/distractor insertion, retained option shuffling. All five output directories and backups remain separate. Sources: https://github.com/jaredpalmer/kev/blob/84847f0a883d900f7de5b7a57eaa341ca7f9a6b4/experiments/q35-4b-s23.json ; https://github.com/jaredpalmer/kev/blob/84847f0a883d900f7de5b7a57eaa341ca7f9a6b4/experiments/night2-4b-du.json ; https://huggingface.co/jaredpalmer/kev-4b/blob/957b91e762e883935830246eeb02381f9d2694b6/training_config.json ; https://huggingface.co/jaredpalmer/kev-4b/blob/6cfce5c2fa4b4bd64026336ab649c5ca78857d52/training_config.json</a:t>
+              <a:t>General stages are separate: decision-v7 12,576 records x two epochs (3,144 updates); dates 1,425 plus 2,000 replay (429); documents 5,219 plus 2,000 replay (903); skills/devtools 11,320 plus 4,000 replay (1,915). All use effective batch eight. Initial selects 4 x 2; later long-document stages use the memory-safe 1 x 8 and row_budget 2048. The skills dataset concatenates the published hard-v1 and devtools-v1 partitions with course checksums; identity to the unavailable historical joint file is not asserted. Pac-Man is a course-specific fifth stage: warm-start completed Skills, 4,096 task records plus 2,000 decision-v7 training replay, one epoch, lr 2e-5, 4 x 2, checkpointing, row_budget 0, max_state 4096, seed 7. Same rank-16 all-projection LoRA/head architecture; task-specific zero none/distractor/none-pair augmentation, option shuffling retained. 6,096 requests give 762 updates. Sources: https://github.com/jaredpalmer/kev/blob/84847f0a883d900f7de5b7a57eaa341ca7f9a6b4/experiments/q35-4b-s23.json ; https://huggingface.co/jaredpalmer/kev-4b ; https://github.com/yxc20089/QPlusLearning/tree/main/labs/lab-01-kev-pacman/cloud_runtime.py</a:t>
+            </a:r>
+            <a:endParaRPr/>
+          </a:p>
+          <a:p>
+            <a:pPr indent="0" lvl="0" marL="0" rtl="0" algn="l">
+              <a:spcBef>
+                <a:spcPts val="0"/>
+              </a:spcBef>
+              <a:spcAft>
+                <a:spcPts val="0"/>
+              </a:spcAft>
+              <a:buNone/>
+            </a:pPr>
+            <a:r>
+              <a:t/>
             </a:r>
             <a:endParaRPr/>
           </a:p>
@@ -2569,7 +2309,22 @@
             </a:pPr>
             <a:r>
               <a:rPr lang="zh-CN"/>
-              <a:t>Warm-start the learner's Stage 4 skills/devtools checkpoint with init_from, then use reviewed Pac-Man training JSONL. Two epochs, lr 2e-5, batch 1 × accumulation 8, BF16 autocast over FP32 weights, gradient checkpointing, state budget 2048. Sixty-four accepted rows give 16 steps. Disable none/distractor augmentation to retain legal directions; option shuffling remains active. Stop inference before training and reload afterward. The 20-minute training cap is a class budget pending a full GPU run. After interruption, use RESUME_PACMAN with the same inputs/arguments and an existing recovery snapshot, or explicitly label an instructor checkpoint. Source: pinned Kev README custom-data training and course cloud_runtime.py.</a:t>
+              <a:t>CP3 trains one full task epoch from the learner completed Skills checkpoint, using reviewed training labels while preserving development/evaluation splits. The exact command is printed. Output kev-4b-pacman-planner-v1 is separate from the earlier small heuristic experiment. Effective batch eight, rank-16 alpha-32 all-module LoRA, 256-dimensional head, lr 2e-5, BF16 autocast over FP32 weights, checkpointing, max_state 4096. Add 2,000 decision-v7 train replay records. Verify 6,096 accepted/seen records, no dropped/truncated records and 762 optimizer updates. Stop the serving process before training and reload afterward. Recovery saves after step 1, every 100 steps or five minutes, and at the final step. If SAVE_TO_DRIVE is enabled and mounted, each complete recovery/final checkpoint triggers a verified Drive backup. Source: https://github.com/yxc20089/QPlusLearning/tree/main/labs/lab-01-kev-pacman/cloud_runtime.py ; https://github.com/yxc20089/QPlusLearning/tree/main/labs/lab-01-kev-pacman/checkpoint_backup.py</a:t>
+            </a:r>
+            <a:endParaRPr/>
+          </a:p>
+          <a:p>
+            <a:pPr indent="0" lvl="0" marL="0" rtl="0" algn="l">
+              <a:spcBef>
+                <a:spcPts val="0"/>
+              </a:spcBef>
+              <a:spcAft>
+                <a:spcPts val="0"/>
+              </a:spcAft>
+              <a:buNone/>
+            </a:pPr>
+            <a:r>
+              <a:t/>
             </a:r>
             <a:endParaRPr/>
           </a:p>
@@ -2669,7 +2424,22 @@
             </a:pPr>
             <a:r>
               <a:rPr lang="zh-CN"/>
-              <a:t>Audit LoRA A/B and head as the only trainable parameters. Original matrices stay fixed while gradients pass through the encoder. Every optimizer step logs CE, learning rate, gradients, duration and peak/live allocated/reserved/free VRAM to TensorBoard/JSONL/CSV. Per-forward row counts/token shapes and record IDs remain in batches.jsonl. Save LoRA/head plus optimizer/scheduler/RNG/counters after step 1, every 100 steps or five minutes at optimizer boundaries, and the final step. Keep the latest two complete recovery snapshots. Native Kev resume is full-weight-only; the lab supplies guarded LoRA continuation. Use Drive storage or export snapshots before Colab disconnects. The older 0.8B notebook saved weights only at completion, so its failed step-2073 run had no automatic learned checkpoint. Source: course training_monitor.py and lora_recovery.py.</a:t>
+              <a:t>Only the 33.8M LoRA/head parameters train. Original base matrices stay fixed while gradients pass through the encoder. Optimizer steps log loss, learning rate, gradient norm, duration and live/peak allocated/reserved/free VRAM to JSONL/CSV/TensorBoard. Batch logs record shapes and source IDs. Recovery includes LoRA/head, optimizer/scheduler/RNG and counters; keep the latest two complete snapshots. Drive backup is automatic after saves when enabled, not deferred until export. Calibration is separate: raw probabilities remain uncalibrated and no release temperature is copied. Source: https://github.com/yxc20089/QPlusLearning/tree/main/labs/lab-01-kev-pacman/training_monitor.py ; https://github.com/yxc20089/QPlusLearning/tree/main/labs/lab-01-kev-pacman/lora_recovery.py ; https://github.com/yxc20089/QPlusLearning/tree/main/labs/lab-01-kev-pacman/checkpoint_backup.py</a:t>
+            </a:r>
+            <a:endParaRPr/>
+          </a:p>
+          <a:p>
+            <a:pPr indent="0" lvl="0" marL="0" rtl="0" algn="l">
+              <a:spcBef>
+                <a:spcPts val="0"/>
+              </a:spcBef>
+              <a:spcAft>
+                <a:spcPts val="0"/>
+              </a:spcAft>
+              <a:buNone/>
+            </a:pPr>
+            <a:r>
+              <a:t/>
             </a:r>
             <a:endParaRPr/>
           </a:p>
@@ -3044,7 +2814,22 @@
             </a:pPr>
             <a:r>
               <a:rPr lang="zh-CN"/>
-              <a:t>Compare the learner's completed Stage 4 general checkpoint and Stage 5 Pac-Man checkpoint. Keep backbone, legal actions, ghost rules and precision fixed. Freeze the candidate before viewing evaluation. Report heuristic teacher agreement, immediate captures, unchanged decisions and regressions. The release's scores and calibration do not transfer to these runs. Source: course pacman_lab.py.</a:t>
+              <a:t>Evaluate the completed Skills checkpoint and the separate planner-trained checkpoint on the same 256 held-out boards. Report strict label agreement, tie-aware agreement for equal search scores/survival, lower-search-survival choices, same-survival search regret and native immediate captures. Keep source IDs and paired predictions. These metrics measure agreement with an approximate privileged-state teacher, not full-game win rate, new-maze generalization or actual trained-model improvement before running the experiment. Sources: https://github.com/yxc20089/QPlusLearning/tree/main/labs/lab-01-kev-pacman/pacman_lab.py ; https://github.com/yxc20089/QPlusLearning/tree/main/labs/lab-01-kev-pacman/data/pacman-planner-v1-manifest.json</a:t>
+            </a:r>
+            <a:endParaRPr/>
+          </a:p>
+          <a:p>
+            <a:pPr indent="0" lvl="0" marL="0" rtl="0" algn="l">
+              <a:spcBef>
+                <a:spcPts val="0"/>
+              </a:spcBef>
+              <a:spcAft>
+                <a:spcPts val="0"/>
+              </a:spcAft>
+              <a:buNone/>
+            </a:pPr>
+            <a:r>
+              <a:t/>
             </a:r>
             <a:endParaRPr/>
           </a:p>
@@ -3144,7 +2929,7 @@
             </a:pPr>
             <a:r>
               <a:rPr lang="zh-CN"/>
-              <a:t>Keep the existing capped 24-turn initial/fine-tuned rollout pair and rules teacher. Two trajectories illustrate behavior, not average win rate. Save HTTP latency for paired evaluations and report enough repeats for a meaningful later p50/p95 benchmark. CUDA kernel/graph options and serving precision affect latency. Keep them identical and state this notebook disables optional fused kernels/graphs for its reference path. Record upstream peak_device_bytes and training wall_seconds, helper elapsed time including load/save, and actual Colab compute-unit use rather than inventing a fixed dollar rate. No GPU or live browser results have been collected for this revision. Broader evaluation needs multiple starts and held-out mazes.</a:t>
+              <a:t>Compare native 128-action Skills/fine-tuned rollouts with the same level/seed and verified active adapter. A separate native planner rollout is a rules-controller reference; it never replaces a requested model controller. The five-seed CPU planning audit uses level 1 and up to 512 actions, stopping at first life loss or clear. Mean pellets: planner 225, old heuristic 199.4; mean score: 3,590 versus 2,594; losses one versus four; clears zero versus one, with four planner turn limits. This is a small deterministic controller comparison, not a trained-Kev result or proof of optimality. It exposes remaining endgame limitations. Record measured GPU step time/utilization and Colab compute units. Sources: https://github.com/yxc20089/QPlusLearning/tree/main/labs/lab-01-kev-pacman/data/pacman-planner-v1-quality.json ; https://github.com/yxc20089/QPlusLearning/tree/main/labs/lab-01-kev-pacman/planner_data.py</a:t>
             </a:r>
             <a:endParaRPr/>
           </a:p>
@@ -3160,150 +2945,6 @@
             </a:pPr>
             <a:r>
               <a:t/>
-            </a:r>
-            <a:endParaRPr/>
-          </a:p>
-          <a:p>
-            <a:pPr indent="0" lvl="0" marL="0" rtl="0" algn="l">
-              <a:spcBef>
-                <a:spcPts val="0"/>
-              </a:spcBef>
-              <a:spcAft>
-                <a:spcPts val="0"/>
-              </a:spcAft>
-              <a:buNone/>
-            </a:pPr>
-            <a:r>
-              <a:rPr lang="zh-CN"/>
-              <a:t>Reference URLs checked October 2, 2026:</a:t>
-            </a:r>
-            <a:endParaRPr/>
-          </a:p>
-          <a:p>
-            <a:pPr indent="0" lvl="0" marL="0" rtl="0" algn="l">
-              <a:spcBef>
-                <a:spcPts val="0"/>
-              </a:spcBef>
-              <a:spcAft>
-                <a:spcPts val="0"/>
-              </a:spcAft>
-              <a:buNone/>
-            </a:pPr>
-            <a:r>
-              <a:rPr lang="zh-CN"/>
-              <a:t>https://github.com/jaredpalmer/kev/tree/84847f0a883d900f7de5b7a57eaa341ca7f9a6b4</a:t>
-            </a:r>
-            <a:endParaRPr/>
-          </a:p>
-          <a:p>
-            <a:pPr indent="0" lvl="0" marL="0" rtl="0" algn="l">
-              <a:spcBef>
-                <a:spcPts val="0"/>
-              </a:spcBef>
-              <a:spcAft>
-                <a:spcPts val="0"/>
-              </a:spcAft>
-              <a:buNone/>
-            </a:pPr>
-            <a:r>
-              <a:rPr lang="zh-CN"/>
-              <a:t>https://github.com/Contrastive-LM/CLM/tree/bb42c6c5bf914fd449bed2f6ca65be80602cb1f7</a:t>
-            </a:r>
-            <a:endParaRPr/>
-          </a:p>
-          <a:p>
-            <a:pPr indent="0" lvl="0" marL="0" rtl="0" algn="l">
-              <a:spcBef>
-                <a:spcPts val="0"/>
-              </a:spcBef>
-              <a:spcAft>
-                <a:spcPts val="0"/>
-              </a:spcAft>
-              <a:buNone/>
-            </a:pPr>
-            <a:r>
-              <a:rPr lang="zh-CN"/>
-              <a:t>https://github.com/Contrastive-LM/CLM/blob/bb42c6c5bf914fd449bed2f6ca65be80602cb1f7/src/clm/heads.py</a:t>
-            </a:r>
-            <a:endParaRPr/>
-          </a:p>
-          <a:p>
-            <a:pPr indent="0" lvl="0" marL="0" rtl="0" algn="l">
-              <a:spcBef>
-                <a:spcPts val="0"/>
-              </a:spcBef>
-              <a:spcAft>
-                <a:spcPts val="0"/>
-              </a:spcAft>
-              <a:buNone/>
-            </a:pPr>
-            <a:r>
-              <a:rPr lang="zh-CN"/>
-              <a:t>https://github.com/Contrastive-LM/CLM/blob/bb42c6c5bf914fd449bed2f6ca65be80602cb1f7/train/finetune.py</a:t>
-            </a:r>
-            <a:endParaRPr/>
-          </a:p>
-          <a:p>
-            <a:pPr indent="0" lvl="0" marL="0" rtl="0" algn="l">
-              <a:spcBef>
-                <a:spcPts val="0"/>
-              </a:spcBef>
-              <a:spcAft>
-                <a:spcPts val="0"/>
-              </a:spcAft>
-              <a:buNone/>
-            </a:pPr>
-            <a:r>
-              <a:rPr lang="zh-CN"/>
-              <a:t>https://github.com/jaredpalmer/kev/blob/84847f0a883d900f7de5b7a57eaa341ca7f9a6b4/kev/model.py</a:t>
-            </a:r>
-            <a:endParaRPr/>
-          </a:p>
-          <a:p>
-            <a:pPr indent="0" lvl="0" marL="0" rtl="0" algn="l">
-              <a:spcBef>
-                <a:spcPts val="0"/>
-              </a:spcBef>
-              <a:spcAft>
-                <a:spcPts val="0"/>
-              </a:spcAft>
-              <a:buNone/>
-            </a:pPr>
-            <a:r>
-              <a:rPr lang="zh-CN"/>
-              <a:t>https://huggingface.co/blog/ggml-org/decision-models-in-llamacpp</a:t>
-            </a:r>
-            <a:endParaRPr/>
-          </a:p>
-          <a:p>
-            <a:pPr indent="0" lvl="0" marL="0" rtl="0" algn="l">
-              <a:spcBef>
-                <a:spcPts val="0"/>
-              </a:spcBef>
-              <a:spcAft>
-                <a:spcPts val="0"/>
-              </a:spcAft>
-              <a:buNone/>
-            </a:pPr>
-            <a:r>
-              <a:rPr lang="zh-CN"/>
-              <a:t>https://github.com/ggml-org/llama.cpp/pull/29818</a:t>
-            </a:r>
-            <a:endParaRPr/>
-          </a:p>
-          <a:p>
-            <a:pPr indent="0" lvl="0" marL="0" rtl="0" algn="l">
-              <a:spcBef>
-                <a:spcPts val="0"/>
-              </a:spcBef>
-              <a:spcAft>
-                <a:spcPts val="0"/>
-              </a:spcAft>
-              <a:buNone/>
-            </a:pPr>
-            <a:r>
-              <a:rPr lang="zh-CN"/>
-              <a:t>CLM article: supplied Contrastive Language Models PDF, pages 6-8; https://contrastive-lm.notion.site/</a:t>
             </a:r>
             <a:endParaRPr/>
           </a:p>
@@ -3503,7 +3144,7 @@
             </a:pPr>
             <a:r>
               <a:rPr lang="zh-CN"/>
-              <a:t>This is an adaptation of the independently authored MIT Jev Pac-Man game, not an official Kev/CLM game release. Preserve the maze, renderer and license. Replace controllers so the learned model controls Pac-Man and fixed code controls ghosts. The notebook integrates the player's /v1/systemone request with a Colab callback and provides Python evaluation/rollouts. GPU training and live callback need instructor preflight. The comparison/lab slides are native editable objects. The original 30-slide lecture stays unchanged.</a:t>
+              <a:t>The accepted browser game is masonicGIT/pacman@7407174c1d6a38be8cd230577489e39e0873145b, replacing the earlier Jev-style maze. Archive the upstream engine, assets and GPL notices unchanged and inject the lab integration separately. Browser and CPU teacher/evaluation run the same native mechanics. The learned adapter controls Pac-Man; all four ghosts retain native personalities, timing, release and frightened behavior. Offline planner snapshots/restores the native engine, including hidden timers, and does not mutate the live episode. It resamples future RNG independently rather than reading the actual episode future. Candidate paths and labels are metadata outside the model input. The recreation has documented arcade differences. Sources: https://github.com/masonicGIT/pacman/tree/7407174c1d6a38be8cd230577489e39e0873145b ; https://github.com/yxc20089/QPlusLearning/tree/main/labs/lab-01-kev-pacman/games/arcade-planner.js ; https://github.com/yxc20089/QPlusLearning/tree/main/labs/lab-01-kev-pacman/vendor/arcade-pacman/source.json</a:t>
             </a:r>
             <a:endParaRPr/>
           </a:p>
@@ -3518,167 +3159,7 @@
               <a:buNone/>
             </a:pPr>
             <a:r>
-              <a:rPr lang="zh-CN"/>
-              <a:t>Source: https://github.com/codaaiteam/jev-pacman/tree/8446fe74690cd61909bda91acfadbccb0f02b422 .</a:t>
-            </a:r>
-            <a:endParaRPr/>
-          </a:p>
-          <a:p>
-            <a:pPr indent="0" lvl="0" marL="0" rtl="0" algn="l">
-              <a:spcBef>
-                <a:spcPts val="0"/>
-              </a:spcBef>
-              <a:spcAft>
-                <a:spcPts val="0"/>
-              </a:spcAft>
-              <a:buNone/>
-            </a:pPr>
-            <a:r>
               <a:t/>
-            </a:r>
-            <a:endParaRPr/>
-          </a:p>
-          <a:p>
-            <a:pPr indent="0" lvl="0" marL="0" rtl="0" algn="l">
-              <a:spcBef>
-                <a:spcPts val="0"/>
-              </a:spcBef>
-              <a:spcAft>
-                <a:spcPts val="0"/>
-              </a:spcAft>
-              <a:buNone/>
-            </a:pPr>
-            <a:r>
-              <a:rPr lang="zh-CN"/>
-              <a:t>Reference URLs checked October 2, 2026:</a:t>
-            </a:r>
-            <a:endParaRPr/>
-          </a:p>
-          <a:p>
-            <a:pPr indent="0" lvl="0" marL="0" rtl="0" algn="l">
-              <a:spcBef>
-                <a:spcPts val="0"/>
-              </a:spcBef>
-              <a:spcAft>
-                <a:spcPts val="0"/>
-              </a:spcAft>
-              <a:buNone/>
-            </a:pPr>
-            <a:r>
-              <a:rPr lang="zh-CN"/>
-              <a:t>https://github.com/jaredpalmer/kev/tree/84847f0a883d900f7de5b7a57eaa341ca7f9a6b4</a:t>
-            </a:r>
-            <a:endParaRPr/>
-          </a:p>
-          <a:p>
-            <a:pPr indent="0" lvl="0" marL="0" rtl="0" algn="l">
-              <a:spcBef>
-                <a:spcPts val="0"/>
-              </a:spcBef>
-              <a:spcAft>
-                <a:spcPts val="0"/>
-              </a:spcAft>
-              <a:buNone/>
-            </a:pPr>
-            <a:r>
-              <a:rPr lang="zh-CN"/>
-              <a:t>https://github.com/Contrastive-LM/CLM/tree/bb42c6c5bf914fd449bed2f6ca65be80602cb1f7</a:t>
-            </a:r>
-            <a:endParaRPr/>
-          </a:p>
-          <a:p>
-            <a:pPr indent="0" lvl="0" marL="0" rtl="0" algn="l">
-              <a:spcBef>
-                <a:spcPts val="0"/>
-              </a:spcBef>
-              <a:spcAft>
-                <a:spcPts val="0"/>
-              </a:spcAft>
-              <a:buNone/>
-            </a:pPr>
-            <a:r>
-              <a:rPr lang="zh-CN"/>
-              <a:t>https://github.com/Contrastive-LM/CLM/blob/bb42c6c5bf914fd449bed2f6ca65be80602cb1f7/src/clm/heads.py</a:t>
-            </a:r>
-            <a:endParaRPr/>
-          </a:p>
-          <a:p>
-            <a:pPr indent="0" lvl="0" marL="0" rtl="0" algn="l">
-              <a:spcBef>
-                <a:spcPts val="0"/>
-              </a:spcBef>
-              <a:spcAft>
-                <a:spcPts val="0"/>
-              </a:spcAft>
-              <a:buNone/>
-            </a:pPr>
-            <a:r>
-              <a:rPr lang="zh-CN"/>
-              <a:t>https://github.com/Contrastive-LM/CLM/blob/bb42c6c5bf914fd449bed2f6ca65be80602cb1f7/train/finetune.py</a:t>
-            </a:r>
-            <a:endParaRPr/>
-          </a:p>
-          <a:p>
-            <a:pPr indent="0" lvl="0" marL="0" rtl="0" algn="l">
-              <a:spcBef>
-                <a:spcPts val="0"/>
-              </a:spcBef>
-              <a:spcAft>
-                <a:spcPts val="0"/>
-              </a:spcAft>
-              <a:buNone/>
-            </a:pPr>
-            <a:r>
-              <a:rPr lang="zh-CN"/>
-              <a:t>https://github.com/jaredpalmer/kev/blob/84847f0a883d900f7de5b7a57eaa341ca7f9a6b4/kev/model.py</a:t>
-            </a:r>
-            <a:endParaRPr/>
-          </a:p>
-          <a:p>
-            <a:pPr indent="0" lvl="0" marL="0" rtl="0" algn="l">
-              <a:spcBef>
-                <a:spcPts val="0"/>
-              </a:spcBef>
-              <a:spcAft>
-                <a:spcPts val="0"/>
-              </a:spcAft>
-              <a:buNone/>
-            </a:pPr>
-            <a:r>
-              <a:rPr lang="zh-CN"/>
-              <a:t>https://huggingface.co/blog/ggml-org/decision-models-in-llamacpp</a:t>
-            </a:r>
-            <a:endParaRPr/>
-          </a:p>
-          <a:p>
-            <a:pPr indent="0" lvl="0" marL="0" rtl="0" algn="l">
-              <a:spcBef>
-                <a:spcPts val="0"/>
-              </a:spcBef>
-              <a:spcAft>
-                <a:spcPts val="0"/>
-              </a:spcAft>
-              <a:buNone/>
-            </a:pPr>
-            <a:r>
-              <a:rPr lang="zh-CN"/>
-              <a:t>https://github.com/ggml-org/llama.cpp/pull/29818</a:t>
-            </a:r>
-            <a:endParaRPr/>
-          </a:p>
-          <a:p>
-            <a:pPr indent="0" lvl="0" marL="0" rtl="0" algn="l">
-              <a:spcBef>
-                <a:spcPts val="0"/>
-              </a:spcBef>
-              <a:spcAft>
-                <a:spcPts val="0"/>
-              </a:spcAft>
-              <a:buNone/>
-            </a:pPr>
-            <a:r>
-              <a:rPr lang="zh-CN"/>
-              <a:t>CLM article: supplied Contrastive Language Models PDF, pages 6-8; https://contrastive-lm.notion.site/</a:t>
             </a:r>
             <a:endParaRPr/>
           </a:p>
@@ -10338,7 +9819,7 @@
             <a:tbl>
               <a:tblPr>
                 <a:noFill/>
-                <a:tableStyleId>{7752FCCB-C744-403B-90CA-A14BC9C0A3A7}</a:tableStyleId>
+                <a:tableStyleId>{7655EB68-0E38-4612-8FD0-F1ACDE5AE169}</a:tableStyleId>
               </a:tblPr>
               <a:tblGrid>
                 <a:gridCol w="1549400"/>
@@ -11479,7 +10960,7 @@
                   <a:srgbClr val="1A2433"/>
                 </a:solidFill>
               </a:rPr>
-              <a:t>Train Pac-Man with fixed-code ghosts</a:t>
+              <a:t>Classic maze, power pellets and four ghost AIs</a:t>
             </a:r>
             <a:endParaRPr sz="2300">
               <a:solidFill>
@@ -11506,7 +10987,7 @@
                   <a:srgbClr val="1A2433"/>
                 </a:solidFill>
               </a:rPr>
-              <a:t>Start from Qwen3.5-4B-Base</a:t>
+              <a:t>Skills checkpoint controls Pac-Man at CP0</a:t>
             </a:r>
             <a:endParaRPr sz="2300">
               <a:solidFill>
@@ -11533,7 +11014,7 @@
                   <a:srgbClr val="1A2433"/>
                 </a:solidFill>
               </a:rPr>
-              <a:t>Train fresh LoRA and a pointer head</a:t>
+              <a:t>Native-engine search generates task labels</a:t>
             </a:r>
             <a:endParaRPr sz="2300">
               <a:solidFill>
@@ -11560,7 +11041,7 @@
                   <a:srgbClr val="1A2433"/>
                 </a:solidFill>
               </a:rPr>
-              <a:t>Complete four general stages before class</a:t>
+              <a:t>Fine-tune the same LoRA and pointer head</a:t>
             </a:r>
             <a:endParaRPr sz="2300">
               <a:solidFill>
@@ -11577,7 +11058,7 @@
                 <a:spcPts val="800"/>
               </a:spcBef>
               <a:spcAft>
-                <a:spcPts val="800"/>
+                <a:spcPts val="0"/>
               </a:spcAft>
               <a:buNone/>
             </a:pPr>
@@ -11587,7 +11068,29 @@
                   <a:srgbClr val="1A2433"/>
                 </a:solidFill>
               </a:rPr>
-              <a:t>Fine-tune your own checkpoint for moves</a:t>
+              <a:t>Compare the model with its planning teacher</a:t>
+            </a:r>
+            <a:endParaRPr sz="2300">
+              <a:solidFill>
+                <a:srgbClr val="1A2433"/>
+              </a:solidFill>
+            </a:endParaRPr>
+          </a:p>
+          <a:p>
+            <a:pPr indent="0" lvl="0" marL="0" marR="0" rtl="0" algn="l">
+              <a:lnSpc>
+                <a:spcPct val="112000"/>
+              </a:lnSpc>
+              <a:spcBef>
+                <a:spcPts val="800"/>
+              </a:spcBef>
+              <a:spcAft>
+                <a:spcPts val="800"/>
+              </a:spcAft>
+              <a:buNone/>
+            </a:pPr>
+            <a:r>
+              <a:t/>
             </a:r>
             <a:endParaRPr sz="2300">
               <a:solidFill>
@@ -11630,7 +11133,7 @@
                 <a:spcPts val="0"/>
               </a:spcBef>
               <a:spcAft>
-                <a:spcPts val="800"/>
+                <a:spcPts val="0"/>
               </a:spcAft>
               <a:buNone/>
             </a:pPr>
@@ -11640,7 +11143,29 @@
                   <a:srgbClr val="5E6E80"/>
                 </a:solidFill>
               </a:rPr>
-              <a:t>Published Kev base recipe, followed by our Pac-Man adaptation</a:t>
+              <a:t>masonicGIT/pacman 7407174; Kev 84847f0; task recipe in QPlusLearning</a:t>
+            </a:r>
+            <a:endParaRPr sz="900">
+              <a:solidFill>
+                <a:srgbClr val="5E6E80"/>
+              </a:solidFill>
+            </a:endParaRPr>
+          </a:p>
+          <a:p>
+            <a:pPr indent="0" lvl="0" marL="0" marR="0" rtl="0" algn="l">
+              <a:lnSpc>
+                <a:spcPct val="112000"/>
+              </a:lnSpc>
+              <a:spcBef>
+                <a:spcPts val="800"/>
+              </a:spcBef>
+              <a:spcAft>
+                <a:spcPts val="800"/>
+              </a:spcAft>
+              <a:buNone/>
+            </a:pPr>
+            <a:r>
+              <a:t/>
             </a:r>
             <a:endParaRPr sz="900">
               <a:solidFill>
@@ -12007,7 +11532,7 @@
                 <a:spcPts val="0"/>
               </a:spcBef>
               <a:spcAft>
-                <a:spcPts val="800"/>
+                <a:spcPts val="0"/>
               </a:spcAft>
               <a:buNone/>
             </a:pPr>
@@ -12017,7 +11542,29 @@
                   <a:srgbClr val="5E6E80"/>
                 </a:solidFill>
               </a:rPr>
-              <a:t>Four general stages are prework. Fine-tuning takes 30 class minutes.</a:t>
+              <a:t>General training and labels are prework; time the full task stage before class.</a:t>
+            </a:r>
+            <a:endParaRPr sz="900">
+              <a:solidFill>
+                <a:srgbClr val="5E6E80"/>
+              </a:solidFill>
+            </a:endParaRPr>
+          </a:p>
+          <a:p>
+            <a:pPr indent="0" lvl="0" marL="0" marR="0" rtl="0" algn="l">
+              <a:lnSpc>
+                <a:spcPct val="112000"/>
+              </a:lnSpc>
+              <a:spcBef>
+                <a:spcPts val="800"/>
+              </a:spcBef>
+              <a:spcAft>
+                <a:spcPts val="800"/>
+              </a:spcAft>
+              <a:buNone/>
+            </a:pPr>
+            <a:r>
+              <a:t/>
             </a:r>
             <a:endParaRPr sz="900">
               <a:solidFill>
@@ -12233,7 +11780,7 @@
                   <a:srgbClr val="1A2433"/>
                 </a:solidFill>
               </a:rPr>
-              <a:t>PyTorch 2.8 / CUDA 12.8 with BF16</a:t>
+              <a:t>Locked PyTorch 2.8 / CUDA 12.8 and BF16</a:t>
             </a:r>
             <a:endParaRPr sz="2300">
               <a:solidFill>
@@ -12260,7 +11807,7 @@
                   <a:srgbClr val="1A2433"/>
                 </a:solidFill>
               </a:rPr>
-              <a:t>Required: FLA and CUDA causal convolution</a:t>
+              <a:t>Required FLA, causal convolution, fused AdamW</a:t>
             </a:r>
             <a:endParaRPr sz="2300">
               <a:solidFill>
@@ -12287,7 +11834,7 @@
                   <a:srgbClr val="1A2433"/>
                 </a:solidFill>
               </a:rPr>
-              <a:t>Verify Kev loss and backward before training</a:t>
+              <a:t>Pac-Man: batch 4 × accumulation 2</a:t>
             </a:r>
             <a:endParaRPr sz="2300">
               <a:solidFill>
@@ -12304,7 +11851,7 @@
                 <a:spcPts val="800"/>
               </a:spcBef>
               <a:spcAft>
-                <a:spcPts val="800"/>
+                <a:spcPts val="0"/>
               </a:spcAft>
               <a:buNone/>
             </a:pPr>
@@ -12314,7 +11861,29 @@
                   <a:srgbClr val="1A2433"/>
                 </a:solidFill>
               </a:rPr>
-              <a:t>Use checkpointing and fused AdamW</a:t>
+              <a:t>Checkpointing on; row budget 0</a:t>
+            </a:r>
+            <a:endParaRPr sz="2300">
+              <a:solidFill>
+                <a:srgbClr val="1A2433"/>
+              </a:solidFill>
+            </a:endParaRPr>
+          </a:p>
+          <a:p>
+            <a:pPr indent="0" lvl="0" marL="0" marR="0" rtl="0" algn="l">
+              <a:lnSpc>
+                <a:spcPct val="112000"/>
+              </a:lnSpc>
+              <a:spcBef>
+                <a:spcPts val="800"/>
+              </a:spcBef>
+              <a:spcAft>
+                <a:spcPts val="800"/>
+              </a:spcAft>
+              <a:buNone/>
+            </a:pPr>
+            <a:r>
+              <a:t/>
             </a:r>
             <a:endParaRPr sz="2300">
               <a:solidFill>
@@ -12357,7 +11926,7 @@
                 <a:spcPts val="0"/>
               </a:spcBef>
               <a:spcAft>
-                <a:spcPts val="800"/>
+                <a:spcPts val="0"/>
               </a:spcAft>
               <a:buNone/>
             </a:pPr>
@@ -12367,7 +11936,29 @@
                   <a:srgbClr val="5E6E80"/>
                 </a:solidFill>
               </a:rPr>
-              <a:t>Colab GPU availability varies. The target is not a free-compute promise.</a:t>
+              <a:t>762 updates: 19 min at 1.5 s/update; 38 min at 3 s/update, plus setup/saves.</a:t>
+            </a:r>
+            <a:endParaRPr sz="900">
+              <a:solidFill>
+                <a:srgbClr val="5E6E80"/>
+              </a:solidFill>
+            </a:endParaRPr>
+          </a:p>
+          <a:p>
+            <a:pPr indent="0" lvl="0" marL="0" marR="0" rtl="0" algn="l">
+              <a:lnSpc>
+                <a:spcPct val="112000"/>
+              </a:lnSpc>
+              <a:spcBef>
+                <a:spcPts val="800"/>
+              </a:spcBef>
+              <a:spcAft>
+                <a:spcPts val="800"/>
+              </a:spcAft>
+              <a:buNone/>
+            </a:pPr>
+            <a:r>
+              <a:t/>
             </a:r>
             <a:endParaRPr sz="900">
               <a:solidFill>
@@ -12493,7 +12084,7 @@
                 <a:spcPts val="0"/>
               </a:spcBef>
               <a:spcAft>
-                <a:spcPts val="800"/>
+                <a:spcPts val="0"/>
               </a:spcAft>
               <a:buNone/>
             </a:pPr>
@@ -12503,7 +12094,29 @@
                   <a:srgbClr val="111829"/>
                 </a:solidFill>
               </a:rPr>
-              <a:t>CP0: what Pac-Man can observe</a:t>
+              <a:t>CP0: Pac-Man and four ghost personalities</a:t>
+            </a:r>
+            <a:endParaRPr b="1" sz="3000">
+              <a:solidFill>
+                <a:srgbClr val="111829"/>
+              </a:solidFill>
+            </a:endParaRPr>
+          </a:p>
+          <a:p>
+            <a:pPr indent="0" lvl="0" marL="0" rtl="0" algn="l">
+              <a:lnSpc>
+                <a:spcPct val="112000"/>
+              </a:lnSpc>
+              <a:spcBef>
+                <a:spcPts val="800"/>
+              </a:spcBef>
+              <a:spcAft>
+                <a:spcPts val="800"/>
+              </a:spcAft>
+              <a:buNone/>
+            </a:pPr>
+            <a:r>
+              <a:t/>
             </a:r>
             <a:endParaRPr b="1" sz="3000">
               <a:solidFill>
@@ -12556,7 +12169,7 @@
                   <a:srgbClr val="1A2433"/>
                 </a:solidFill>
               </a:rPr>
-              <a:t>Maze walls and remaining dots</a:t>
+              <a:t>Blinky pursues; Pinky targets ahead</a:t>
             </a:r>
             <a:endParaRPr sz="2300">
               <a:solidFill>
@@ -12583,7 +12196,7 @@
                   <a:srgbClr val="1A2433"/>
                 </a:solidFill>
               </a:rPr>
-              <a:t>Player position and heading</a:t>
+              <a:t>Inky uses Blinky; Clyde retreats when close</a:t>
             </a:r>
             <a:endParaRPr sz="2300">
               <a:solidFill>
@@ -12610,7 +12223,7 @@
                   <a:srgbClr val="1A2433"/>
                 </a:solidFill>
               </a:rPr>
-              <a:t>Ghost positions and headings</a:t>
+              <a:t>Ghosts leave home through counters/timeouts</a:t>
             </a:r>
             <a:endParaRPr sz="2300">
               <a:solidFill>
@@ -12627,7 +12240,7 @@
                 <a:spcPts val="800"/>
               </a:spcBef>
               <a:spcAft>
-                <a:spcPts val="800"/>
+                <a:spcPts val="0"/>
               </a:spcAft>
               <a:buNone/>
             </a:pPr>
@@ -12637,7 +12250,56 @@
                   <a:srgbClr val="1A2433"/>
                 </a:solidFill>
               </a:rPr>
-              <a:t>Turn number and ghost movement rule</a:t>
+              <a:t>Check each ghost mode and simulation seconds</a:t>
+            </a:r>
+            <a:endParaRPr sz="2300">
+              <a:solidFill>
+                <a:srgbClr val="1A2433"/>
+              </a:solidFill>
+            </a:endParaRPr>
+          </a:p>
+          <a:p>
+            <a:pPr indent="0" lvl="0" marL="0" rtl="0" algn="l">
+              <a:lnSpc>
+                <a:spcPct val="112000"/>
+              </a:lnSpc>
+              <a:spcBef>
+                <a:spcPts val="800"/>
+              </a:spcBef>
+              <a:spcAft>
+                <a:spcPts val="0"/>
+              </a:spcAft>
+              <a:buNone/>
+            </a:pPr>
+            <a:r>
+              <a:rPr lang="zh-CN" sz="2300">
+                <a:solidFill>
+                  <a:srgbClr val="1A2433"/>
+                </a:solidFill>
+              </a:rPr>
+              <a:t>Verify the active Skills adapter in the badge</a:t>
+            </a:r>
+            <a:endParaRPr sz="2300">
+              <a:solidFill>
+                <a:srgbClr val="1A2433"/>
+              </a:solidFill>
+            </a:endParaRPr>
+          </a:p>
+          <a:p>
+            <a:pPr indent="0" lvl="0" marL="0" rtl="0" algn="l">
+              <a:lnSpc>
+                <a:spcPct val="112000"/>
+              </a:lnSpc>
+              <a:spcBef>
+                <a:spcPts val="800"/>
+              </a:spcBef>
+              <a:spcAft>
+                <a:spcPts val="800"/>
+              </a:spcAft>
+              <a:buNone/>
+            </a:pPr>
+            <a:r>
+              <a:t/>
             </a:r>
             <a:endParaRPr sz="2300">
               <a:solidFill>
@@ -12680,7 +12342,7 @@
                 <a:spcPts val="0"/>
               </a:spcBef>
               <a:spcAft>
-                <a:spcPts val="800"/>
+                <a:spcPts val="0"/>
               </a:spcAft>
               <a:buNone/>
             </a:pPr>
@@ -12690,7 +12352,29 @@
                   <a:srgbClr val="5E6E80"/>
                 </a:solidFill>
               </a:rPr>
-              <a:t>Structured state; the model controls the player</a:t>
+              <a:t>Chase/scatter is deterministic. Kev pauses simulation while deciding.</a:t>
+            </a:r>
+            <a:endParaRPr sz="900">
+              <a:solidFill>
+                <a:srgbClr val="5E6E80"/>
+              </a:solidFill>
+            </a:endParaRPr>
+          </a:p>
+          <a:p>
+            <a:pPr indent="0" lvl="0" marL="0" rtl="0" algn="l">
+              <a:lnSpc>
+                <a:spcPct val="112000"/>
+              </a:lnSpc>
+              <a:spcBef>
+                <a:spcPts val="800"/>
+              </a:spcBef>
+              <a:spcAft>
+                <a:spcPts val="800"/>
+              </a:spcAft>
+              <a:buNone/>
+            </a:pPr>
+            <a:r>
+              <a:t/>
             </a:r>
             <a:endParaRPr sz="900">
               <a:solidFill>
@@ -13516,7 +13200,7 @@
                 <a:spcPts val="0"/>
               </a:spcBef>
               <a:spcAft>
-                <a:spcPts val="800"/>
+                <a:spcPts val="0"/>
               </a:spcAft>
               <a:buNone/>
             </a:pPr>
@@ -13526,7 +13210,29 @@
                   <a:srgbClr val="111829"/>
                 </a:solidFill>
               </a:rPr>
-              <a:t>CP2: prepare player labels</a:t>
+              <a:t>CP2: inspect planning labels</a:t>
+            </a:r>
+            <a:endParaRPr b="1" sz="3000">
+              <a:solidFill>
+                <a:srgbClr val="111829"/>
+              </a:solidFill>
+            </a:endParaRPr>
+          </a:p>
+          <a:p>
+            <a:pPr indent="0" lvl="0" marL="0" rtl="0" algn="l">
+              <a:lnSpc>
+                <a:spcPct val="112000"/>
+              </a:lnSpc>
+              <a:spcBef>
+                <a:spcPts val="800"/>
+              </a:spcBef>
+              <a:spcAft>
+                <a:spcPts val="800"/>
+              </a:spcAft>
+              <a:buNone/>
+            </a:pPr>
+            <a:r>
+              <a:t/>
             </a:r>
             <a:endParaRPr b="1" sz="3000">
               <a:solidFill>
@@ -13579,7 +13285,7 @@
                   <a:srgbClr val="1A2433"/>
                 </a:solidFill>
               </a:rPr>
-              <a:t>64 train, 16 development, 16 evaluation</a:t>
+              <a:t>4,096 train; 256 development; 256 evaluation</a:t>
             </a:r>
             <a:endParaRPr sz="2300">
               <a:solidFill>
@@ -13606,7 +13312,7 @@
                   <a:srgbClr val="1A2433"/>
                 </a:solidFill>
               </a:rPr>
-              <a:t>Inspect three boards and annotate legal moves</a:t>
+              <a:t>Simulate up to 20 moves in the native engine</a:t>
             </a:r>
             <a:endParaRPr sz="2300">
               <a:solidFill>
@@ -13633,7 +13339,7 @@
                   <a:srgbClr val="1A2433"/>
                 </a:solidFill>
               </a:rPr>
-              <a:t>Starter labels follow a stated heuristic</a:t>
+              <a:t>Keep eight paths per first legal action</a:t>
             </a:r>
             <a:endParaRPr sz="2300">
               <a:solidFill>
@@ -13660,7 +13366,7 @@
                   <a:srgbClr val="1A2433"/>
                 </a:solidFill>
               </a:rPr>
-              <a:t>Keep all edits in the training partition</a:t>
+              <a:t>Prioritize survival, score, pellets and progress</a:t>
             </a:r>
             <a:endParaRPr sz="2300">
               <a:solidFill>
@@ -13677,7 +13383,7 @@
                 <a:spcPts val="800"/>
               </a:spcBef>
               <a:spcAft>
-                <a:spcPts val="800"/>
+                <a:spcPts val="0"/>
               </a:spcAft>
               <a:buNone/>
             </a:pPr>
@@ -13687,7 +13393,29 @@
                   <a:srgbClr val="1A2433"/>
                 </a:solidFill>
               </a:rPr>
-              <a:t>Keep evaluation closed until the model is fixed</a:t>
+              <a:t>Review labels; keep episodes in separate splits</a:t>
+            </a:r>
+            <a:endParaRPr sz="2300">
+              <a:solidFill>
+                <a:srgbClr val="1A2433"/>
+              </a:solidFill>
+            </a:endParaRPr>
+          </a:p>
+          <a:p>
+            <a:pPr indent="0" lvl="0" marL="0" rtl="0" algn="l">
+              <a:lnSpc>
+                <a:spcPct val="112000"/>
+              </a:lnSpc>
+              <a:spcBef>
+                <a:spcPts val="800"/>
+              </a:spcBef>
+              <a:spcAft>
+                <a:spcPts val="800"/>
+              </a:spcAft>
+              <a:buNone/>
+            </a:pPr>
+            <a:r>
+              <a:t/>
             </a:r>
             <a:endParaRPr sz="2300">
               <a:solidFill>
@@ -13730,7 +13458,7 @@
                 <a:spcPts val="0"/>
               </a:spcBef>
               <a:spcAft>
-                <a:spcPts val="800"/>
+                <a:spcPts val="0"/>
               </a:spcAft>
               <a:buNone/>
             </a:pPr>
@@ -13740,7 +13468,29 @@
                   <a:srgbClr val="5E6E80"/>
                 </a:solidFill>
               </a:rPr>
-              <a:t>Synthetic teacher labels are not human demonstrations</a:t>
+              <a:t>Approximate beam search; two RNG scenarios for frightened turns. Not globally optimal.</a:t>
+            </a:r>
+            <a:endParaRPr sz="900">
+              <a:solidFill>
+                <a:srgbClr val="5E6E80"/>
+              </a:solidFill>
+            </a:endParaRPr>
+          </a:p>
+          <a:p>
+            <a:pPr indent="0" lvl="0" marL="0" rtl="0" algn="l">
+              <a:lnSpc>
+                <a:spcPct val="112000"/>
+              </a:lnSpc>
+              <a:spcBef>
+                <a:spcPts val="800"/>
+              </a:spcBef>
+              <a:spcAft>
+                <a:spcPts val="800"/>
+              </a:spcAft>
+              <a:buNone/>
+            </a:pPr>
+            <a:r>
+              <a:t/>
             </a:r>
             <a:endParaRPr sz="900">
               <a:solidFill>
@@ -14027,7 +13777,7 @@
                 <a:spcPts val="800"/>
               </a:spcBef>
               <a:spcAft>
-                <a:spcPts val="800"/>
+                <a:spcPts val="0"/>
               </a:spcAft>
               <a:buNone/>
             </a:pPr>
@@ -14037,7 +13787,29 @@
                   <a:srgbClr val="1A2433"/>
                 </a:solidFill>
               </a:rPr>
-              <a:t>5  Pac-Man: 64 labelled boards × 2 epochs</a:t>
+              <a:t>5  Pac-Man: 4,096 + 2,000 replay; 1 epoch</a:t>
+            </a:r>
+            <a:endParaRPr sz="2300">
+              <a:solidFill>
+                <a:srgbClr val="1A2433"/>
+              </a:solidFill>
+            </a:endParaRPr>
+          </a:p>
+          <a:p>
+            <a:pPr indent="0" lvl="0" marL="0" marR="0" rtl="0" algn="l">
+              <a:lnSpc>
+                <a:spcPct val="112000"/>
+              </a:lnSpc>
+              <a:spcBef>
+                <a:spcPts val="800"/>
+              </a:spcBef>
+              <a:spcAft>
+                <a:spcPts val="800"/>
+              </a:spcAft>
+              <a:buNone/>
+            </a:pPr>
+            <a:r>
+              <a:t/>
             </a:r>
             <a:endParaRPr sz="2300">
               <a:solidFill>
@@ -14080,7 +13852,7 @@
                 <a:spcPts val="0"/>
               </a:spcBef>
               <a:spcAft>
-                <a:spcPts val="800"/>
+                <a:spcPts val="0"/>
               </a:spcAft>
               <a:buNone/>
             </a:pPr>
@@ -14090,7 +13862,29 @@
                   <a:srgbClr val="5E6E80"/>
                 </a:solidFill>
               </a:rPr>
-              <a:t>Stages 1–4 are prework. Stage 5 is the mandatory class adaptation.</a:t>
+              <a:t>Pac-Man: 762 updates, lr 2e-5; prior stages and label generation are prework.</a:t>
+            </a:r>
+            <a:endParaRPr sz="900">
+              <a:solidFill>
+                <a:srgbClr val="5E6E80"/>
+              </a:solidFill>
+            </a:endParaRPr>
+          </a:p>
+          <a:p>
+            <a:pPr indent="0" lvl="0" marL="0" marR="0" rtl="0" algn="l">
+              <a:lnSpc>
+                <a:spcPct val="112000"/>
+              </a:lnSpc>
+              <a:spcBef>
+                <a:spcPts val="800"/>
+              </a:spcBef>
+              <a:spcAft>
+                <a:spcPts val="800"/>
+              </a:spcAft>
+              <a:buNone/>
+            </a:pPr>
+            <a:r>
+              <a:t/>
             </a:r>
             <a:endParaRPr sz="900">
               <a:solidFill>
@@ -14279,7 +14073,7 @@
                   <a:srgbClr val="1A2433"/>
                 </a:solidFill>
               </a:rPr>
-              <a:t>5 min    Inspect labelled moves and the loss</a:t>
+              <a:t>Warm-start your completed Skills checkpoint</a:t>
             </a:r>
             <a:endParaRPr sz="2300">
               <a:solidFill>
@@ -14306,7 +14100,7 @@
                   <a:srgbClr val="1A2433"/>
                 </a:solidFill>
               </a:rPr>
-              <a:t>20 min  Fine-tune your skills checkpoint</a:t>
+              <a:t>One epoch; lr 2e-5; effective batch eight</a:t>
             </a:r>
             <a:endParaRPr sz="2300">
               <a:solidFill>
@@ -14333,7 +14127,7 @@
                   <a:srgbClr val="1A2433"/>
                 </a:solidFill>
               </a:rPr>
-              <a:t>5 min    Inspect and save the adapter/head</a:t>
+              <a:t>Train rank-16 LoRA and 256-dim pointer head</a:t>
             </a:r>
             <a:endParaRPr sz="2300">
               <a:solidFill>
@@ -14360,7 +14154,7 @@
                   <a:srgbClr val="1A2433"/>
                 </a:solidFill>
               </a:rPr>
-              <a:t>Update LoRA and the pointer head together</a:t>
+              <a:t>Keep none/distractor augmentation disabled</a:t>
             </a:r>
             <a:endParaRPr sz="2300">
               <a:solidFill>
@@ -14377,7 +14171,7 @@
                 <a:spcPts val="800"/>
               </a:spcBef>
               <a:spcAft>
-                <a:spcPts val="800"/>
+                <a:spcPts val="0"/>
               </a:spcAft>
               <a:buNone/>
             </a:pPr>
@@ -14387,7 +14181,29 @@
                   <a:srgbClr val="1A2433"/>
                 </a:solidFill>
               </a:rPr>
-              <a:t>Keep original base matrices unchanged</a:t>
+              <a:t>Save recovery and enabled Drive backups</a:t>
+            </a:r>
+            <a:endParaRPr sz="2300">
+              <a:solidFill>
+                <a:srgbClr val="1A2433"/>
+              </a:solidFill>
+            </a:endParaRPr>
+          </a:p>
+          <a:p>
+            <a:pPr indent="0" lvl="0" marL="0" marR="0" rtl="0" algn="l">
+              <a:lnSpc>
+                <a:spcPct val="112000"/>
+              </a:lnSpc>
+              <a:spcBef>
+                <a:spcPts val="800"/>
+              </a:spcBef>
+              <a:spcAft>
+                <a:spcPts val="800"/>
+              </a:spcAft>
+              <a:buNone/>
+            </a:pPr>
+            <a:r>
+              <a:t/>
             </a:r>
             <a:endParaRPr sz="2300">
               <a:solidFill>
@@ -14430,7 +14246,7 @@
                 <a:spcPts val="0"/>
               </a:spcBef>
               <a:spcAft>
-                <a:spcPts val="800"/>
+                <a:spcPts val="0"/>
               </a:spcAft>
               <a:buNone/>
             </a:pPr>
@@ -14440,7 +14256,29 @@
                   <a:srgbClr val="5E6E80"/>
                 </a:solidFill>
               </a:rPr>
-              <a:t>Mandatory domain adaptation, warm-started with --init_from</a:t>
+              <a:t>30-minute class block; complete slower full runs as prework. No short-step cap.</a:t>
+            </a:r>
+            <a:endParaRPr sz="900">
+              <a:solidFill>
+                <a:srgbClr val="5E6E80"/>
+              </a:solidFill>
+            </a:endParaRPr>
+          </a:p>
+          <a:p>
+            <a:pPr indent="0" lvl="0" marL="0" marR="0" rtl="0" algn="l">
+              <a:lnSpc>
+                <a:spcPct val="112000"/>
+              </a:lnSpc>
+              <a:spcBef>
+                <a:spcPts val="800"/>
+              </a:spcBef>
+              <a:spcAft>
+                <a:spcPts val="800"/>
+              </a:spcAft>
+              <a:buNone/>
+            </a:pPr>
+            <a:r>
+              <a:t/>
             </a:r>
             <a:endParaRPr sz="900">
               <a:solidFill>
@@ -14780,7 +14618,7 @@
                 <a:spcPts val="0"/>
               </a:spcBef>
               <a:spcAft>
-                <a:spcPts val="800"/>
+                <a:spcPts val="0"/>
               </a:spcAft>
               <a:buNone/>
             </a:pPr>
@@ -14790,7 +14628,29 @@
                   <a:srgbClr val="5E6E80"/>
                 </a:solidFill>
               </a:rPr>
-              <a:t>Fixed base matrices still allow gradients through the encoder</a:t>
+              <a:t>33.8M trainable parameters; raw probabilities; calibration remains separate.</a:t>
+            </a:r>
+            <a:endParaRPr sz="900">
+              <a:solidFill>
+                <a:srgbClr val="5E6E80"/>
+              </a:solidFill>
+            </a:endParaRPr>
+          </a:p>
+          <a:p>
+            <a:pPr indent="0" lvl="0" marL="0" marR="0" rtl="0" algn="l">
+              <a:lnSpc>
+                <a:spcPct val="112000"/>
+              </a:lnSpc>
+              <a:spcBef>
+                <a:spcPts val="800"/>
+              </a:spcBef>
+              <a:spcAft>
+                <a:spcPts val="800"/>
+              </a:spcAft>
+              <a:buNone/>
+            </a:pPr>
+            <a:r>
+              <a:t/>
             </a:r>
             <a:endParaRPr sz="900">
               <a:solidFill>
@@ -15110,7 +14970,7 @@
             <a:tbl>
               <a:tblPr>
                 <a:noFill/>
-                <a:tableStyleId>{7752FCCB-C744-403B-90CA-A14BC9C0A3A7}</a:tableStyleId>
+                <a:tableStyleId>{7655EB68-0E38-4612-8FD0-F1ACDE5AE169}</a:tableStyleId>
               </a:tblPr>
               <a:tblGrid>
                 <a:gridCol w="1346200"/>
@@ -16305,7 +16165,7 @@
                   <a:srgbClr val="1A2433"/>
                 </a:solidFill>
               </a:rPr>
-              <a:t>Fix skills and Pac-Man checkpoints</a:t>
+              <a:t>Fix Skills and planner-trained checkpoints</a:t>
             </a:r>
             <a:endParaRPr sz="2300">
               <a:solidFill>
@@ -16332,7 +16192,7 @@
                   <a:srgbClr val="1A2433"/>
                 </a:solidFill>
               </a:rPr>
-              <a:t>Score the same 16 evaluation boards</a:t>
+              <a:t>Score the same 256 evaluation boards</a:t>
             </a:r>
             <a:endParaRPr sz="2300">
               <a:solidFill>
@@ -16359,7 +16219,34 @@
                   <a:srgbClr val="1A2433"/>
                 </a:solidFill>
               </a:rPr>
-              <a:t>Compare teacher accuracy and captures</a:t>
+              <a:t>Compare strict and tie-aware teacher agreement</a:t>
+            </a:r>
+            <a:endParaRPr sz="2300">
+              <a:solidFill>
+                <a:srgbClr val="1A2433"/>
+              </a:solidFill>
+            </a:endParaRPr>
+          </a:p>
+          <a:p>
+            <a:pPr indent="0" lvl="0" marL="0" marR="0" rtl="0" algn="l">
+              <a:lnSpc>
+                <a:spcPct val="112000"/>
+              </a:lnSpc>
+              <a:spcBef>
+                <a:spcPts val="800"/>
+              </a:spcBef>
+              <a:spcAft>
+                <a:spcPts val="0"/>
+              </a:spcAft>
+              <a:buNone/>
+            </a:pPr>
+            <a:r>
+              <a:rPr lang="zh-CN" sz="2300">
+                <a:solidFill>
+                  <a:srgbClr val="1A2433"/>
+                </a:solidFill>
+              </a:rPr>
+              <a:t>Inspect search regret and immediate captures</a:t>
             </a:r>
             <a:endParaRPr sz="2300">
               <a:solidFill>
@@ -16408,12 +16295,7 @@
               <a:buNone/>
             </a:pPr>
             <a:r>
-              <a:rPr lang="zh-CN" sz="2300">
-                <a:solidFill>
-                  <a:srgbClr val="1A2433"/>
-                </a:solidFill>
-              </a:rPr>
-              <a:t>Include a deterministic rules baseline</a:t>
+              <a:t/>
             </a:r>
             <a:endParaRPr sz="2300">
               <a:solidFill>
@@ -16456,7 +16338,7 @@
                 <a:spcPts val="0"/>
               </a:spcBef>
               <a:spcAft>
-                <a:spcPts val="800"/>
+                <a:spcPts val="0"/>
               </a:spcAft>
               <a:buNone/>
             </a:pPr>
@@ -16466,7 +16348,29 @@
                   <a:srgbClr val="5E6E80"/>
                 </a:solidFill>
               </a:rPr>
-              <a:t>One maze and 16 boards do not establish general game skill</a:t>
+              <a:t>Approximate teacher agreement is not full-game win rate or new-maze generalization.</a:t>
+            </a:r>
+            <a:endParaRPr sz="900">
+              <a:solidFill>
+                <a:srgbClr val="5E6E80"/>
+              </a:solidFill>
+            </a:endParaRPr>
+          </a:p>
+          <a:p>
+            <a:pPr indent="0" lvl="0" marL="0" rtl="0" algn="l">
+              <a:lnSpc>
+                <a:spcPct val="112000"/>
+              </a:lnSpc>
+              <a:spcBef>
+                <a:spcPts val="800"/>
+              </a:spcBef>
+              <a:spcAft>
+                <a:spcPts val="800"/>
+              </a:spcAft>
+              <a:buNone/>
+            </a:pPr>
+            <a:r>
+              <a:t/>
             </a:r>
             <a:endParaRPr sz="900">
               <a:solidFill>
@@ -16655,7 +16559,7 @@
                   <a:srgbClr val="1A2433"/>
                 </a:solidFill>
               </a:rPr>
-              <a:t>Use identical starts and fixed-code ghosts</a:t>
+              <a:t>Use the same native engine and starting seed</a:t>
             </a:r>
             <a:endParaRPr sz="2300">
               <a:solidFill>
@@ -16682,7 +16586,7 @@
                   <a:srgbClr val="1A2433"/>
                 </a:solidFill>
               </a:rPr>
-              <a:t>Compare dots collected and game turns</a:t>
+              <a:t>Compare pellets, score and repeated tiles</a:t>
             </a:r>
             <a:endParaRPr sz="2300">
               <a:solidFill>
@@ -16709,7 +16613,7 @@
                   <a:srgbClr val="1A2433"/>
                 </a:solidFill>
               </a:rPr>
-              <a:t>Measure end-to-end decision latency</a:t>
+              <a:t>Verify which LoRA is serving every decision</a:t>
             </a:r>
             <a:endParaRPr sz="2300">
               <a:solidFill>
@@ -16736,7 +16640,7 @@
                   <a:srgbClr val="1A2433"/>
                 </a:solidFill>
               </a:rPr>
-              <a:t>Record actual training time and peak memory</a:t>
+              <a:t>Record step time, GPU use and compute units</a:t>
             </a:r>
             <a:endParaRPr sz="2300">
               <a:solidFill>
@@ -16753,7 +16657,7 @@
                 <a:spcPts val="800"/>
               </a:spcBef>
               <a:spcAft>
-                <a:spcPts val="800"/>
+                <a:spcPts val="0"/>
               </a:spcAft>
               <a:buNone/>
             </a:pPr>
@@ -16763,7 +16667,29 @@
                   <a:srgbClr val="1A2433"/>
                 </a:solidFill>
               </a:rPr>
-              <a:t>Record Colab compute units consumed</a:t>
+              <a:t>Inspect the five-seed CPU teacher comparison</a:t>
+            </a:r>
+            <a:endParaRPr sz="2300">
+              <a:solidFill>
+                <a:srgbClr val="1A2433"/>
+              </a:solidFill>
+            </a:endParaRPr>
+          </a:p>
+          <a:p>
+            <a:pPr indent="0" lvl="0" marL="0" marR="0" rtl="0" algn="l">
+              <a:lnSpc>
+                <a:spcPct val="112000"/>
+              </a:lnSpc>
+              <a:spcBef>
+                <a:spcPts val="800"/>
+              </a:spcBef>
+              <a:spcAft>
+                <a:spcPts val="800"/>
+              </a:spcAft>
+              <a:buNone/>
+            </a:pPr>
+            <a:r>
+              <a:t/>
             </a:r>
             <a:endParaRPr sz="2300">
               <a:solidFill>
@@ -16806,7 +16732,7 @@
                 <a:spcPts val="0"/>
               </a:spcBef>
               <a:spcAft>
-                <a:spcPts val="800"/>
+                <a:spcPts val="0"/>
               </a:spcAft>
               <a:buNone/>
             </a:pPr>
@@ -16816,7 +16742,29 @@
                   <a:srgbClr val="5E6E80"/>
                 </a:solidFill>
               </a:rPr>
-              <a:t>Gameplay quality and inference speed are separate outcomes</a:t>
+              <a:t>Teacher: 225 vs 199.4 mean pellets; zero vs one clears at the 512-move cap.</a:t>
+            </a:r>
+            <a:endParaRPr sz="900">
+              <a:solidFill>
+                <a:srgbClr val="5E6E80"/>
+              </a:solidFill>
+            </a:endParaRPr>
+          </a:p>
+          <a:p>
+            <a:pPr indent="0" lvl="0" marL="0" rtl="0" algn="l">
+              <a:lnSpc>
+                <a:spcPct val="112000"/>
+              </a:lnSpc>
+              <a:spcBef>
+                <a:spcPts val="800"/>
+              </a:spcBef>
+              <a:spcAft>
+                <a:spcPts val="800"/>
+              </a:spcAft>
+              <a:buNone/>
+            </a:pPr>
+            <a:r>
+              <a:t/>
             </a:r>
             <a:endParaRPr sz="900">
               <a:solidFill>
@@ -17292,7 +17240,7 @@
                 <a:spcPts val="0"/>
               </a:spcBef>
               <a:spcAft>
-                <a:spcPts val="800"/>
+                <a:spcPts val="0"/>
               </a:spcAft>
               <a:buNone/>
             </a:pPr>
@@ -17302,7 +17250,29 @@
                   <a:srgbClr val="111829"/>
                 </a:solidFill>
               </a:rPr>
-              <a:t>The community starting point</a:t>
+              <a:t>The native game and planning teacher</a:t>
+            </a:r>
+            <a:endParaRPr b="1" sz="3000">
+              <a:solidFill>
+                <a:srgbClr val="111829"/>
+              </a:solidFill>
+            </a:endParaRPr>
+          </a:p>
+          <a:p>
+            <a:pPr indent="0" lvl="0" marL="0" rtl="0" algn="l">
+              <a:lnSpc>
+                <a:spcPct val="112000"/>
+              </a:lnSpc>
+              <a:spcBef>
+                <a:spcPts val="800"/>
+              </a:spcBef>
+              <a:spcAft>
+                <a:spcPts val="800"/>
+              </a:spcAft>
+              <a:buNone/>
+            </a:pPr>
+            <a:r>
+              <a:t/>
             </a:r>
             <a:endParaRPr b="1" sz="3000">
               <a:solidFill>
@@ -17355,7 +17325,7 @@
                   <a:srgbClr val="1A2433"/>
                 </a:solidFill>
               </a:rPr>
-              <a:t>Source: codaaiteam/jev-pacman, MIT</a:t>
+              <a:t>Game: masonicGIT/pacman at 7407174</a:t>
             </a:r>
             <a:endParaRPr sz="2300">
               <a:solidFill>
@@ -17382,7 +17352,7 @@
                   <a:srgbClr val="1A2433"/>
                 </a:solidFill>
               </a:rPr>
-              <a:t>Original demo: human player, Jev ghosts</a:t>
+              <a:t>Original maze, renderer, sounds and mechanics</a:t>
             </a:r>
             <a:endParaRPr sz="2300">
               <a:solidFill>
@@ -17409,7 +17379,7 @@
                   <a:srgbClr val="1A2433"/>
                 </a:solidFill>
               </a:rPr>
-              <a:t>Our design: learned player, fixed-code ghosts</a:t>
+              <a:t>Predict each ghost with its native targeting code</a:t>
             </a:r>
             <a:endParaRPr sz="2300">
               <a:solidFill>
@@ -17436,7 +17406,7 @@
                   <a:srgbClr val="1A2433"/>
                 </a:solidFill>
               </a:rPr>
-              <a:t>Use the same maze and rules for every model</a:t>
+              <a:t>Search uses current timers; model sees the board</a:t>
             </a:r>
             <a:endParaRPr sz="2300">
               <a:solidFill>
@@ -17453,7 +17423,7 @@
                 <a:spcPts val="800"/>
               </a:spcBef>
               <a:spcAft>
-                <a:spcPts val="800"/>
+                <a:spcPts val="0"/>
               </a:spcAft>
               <a:buNone/>
             </a:pPr>
@@ -17463,7 +17433,29 @@
                   <a:srgbClr val="1A2433"/>
                 </a:solidFill>
               </a:rPr>
-              <a:t>No ROM setup for this browser clone</a:t>
+              <a:t>Candidate paths stay outside the model input</a:t>
+            </a:r>
+            <a:endParaRPr sz="2300">
+              <a:solidFill>
+                <a:srgbClr val="1A2433"/>
+              </a:solidFill>
+            </a:endParaRPr>
+          </a:p>
+          <a:p>
+            <a:pPr indent="0" lvl="0" marL="0" rtl="0" algn="l">
+              <a:lnSpc>
+                <a:spcPct val="112000"/>
+              </a:lnSpc>
+              <a:spcBef>
+                <a:spcPts val="800"/>
+              </a:spcBef>
+              <a:spcAft>
+                <a:spcPts val="800"/>
+              </a:spcAft>
+              <a:buNone/>
+            </a:pPr>
+            <a:r>
+              <a:t/>
             </a:r>
             <a:endParaRPr sz="2300">
               <a:solidFill>
@@ -17506,7 +17498,7 @@
                 <a:spcPts val="0"/>
               </a:spcBef>
               <a:spcAft>
-                <a:spcPts val="800"/>
+                <a:spcPts val="0"/>
               </a:spcAft>
               <a:buNone/>
             </a:pPr>
@@ -17516,7 +17508,29 @@
                   <a:srgbClr val="5E6E80"/>
                 </a:solidFill>
               </a:rPr>
-              <a:t>Clean upstream source and MIT notice are preserved</a:t>
+              <a:t>A faithful recreation with documented differences; source/assets and GPL notice retained.</a:t>
+            </a:r>
+            <a:endParaRPr sz="900">
+              <a:solidFill>
+                <a:srgbClr val="5E6E80"/>
+              </a:solidFill>
+            </a:endParaRPr>
+          </a:p>
+          <a:p>
+            <a:pPr indent="0" lvl="0" marL="0" rtl="0" algn="l">
+              <a:lnSpc>
+                <a:spcPct val="112000"/>
+              </a:lnSpc>
+              <a:spcBef>
+                <a:spcPts val="800"/>
+              </a:spcBef>
+              <a:spcAft>
+                <a:spcPts val="800"/>
+              </a:spcAft>
+              <a:buNone/>
+            </a:pPr>
+            <a:r>
+              <a:t/>
             </a:r>
             <a:endParaRPr sz="900">
               <a:solidFill>
@@ -17836,7 +17850,7 @@
             <a:tbl>
               <a:tblPr>
                 <a:noFill/>
-                <a:tableStyleId>{7752FCCB-C744-403B-90CA-A14BC9C0A3A7}</a:tableStyleId>
+                <a:tableStyleId>{7655EB68-0E38-4612-8FD0-F1ACDE5AE169}</a:tableStyleId>
               </a:tblPr>
               <a:tblGrid>
                 <a:gridCol w="1346200"/>
@@ -19162,7 +19176,7 @@
             <a:tbl>
               <a:tblPr>
                 <a:noFill/>
-                <a:tableStyleId>{7752FCCB-C744-403B-90CA-A14BC9C0A3A7}</a:tableStyleId>
+                <a:tableStyleId>{7655EB68-0E38-4612-8FD0-F1ACDE5AE169}</a:tableStyleId>
               </a:tblPr>
               <a:tblGrid>
                 <a:gridCol w="1346200"/>
@@ -20488,7 +20502,7 @@
             <a:tbl>
               <a:tblPr>
                 <a:noFill/>
-                <a:tableStyleId>{7752FCCB-C744-403B-90CA-A14BC9C0A3A7}</a:tableStyleId>
+                <a:tableStyleId>{7655EB68-0E38-4612-8FD0-F1ACDE5AE169}</a:tableStyleId>
               </a:tblPr>
               <a:tblGrid>
                 <a:gridCol w="2146300"/>
@@ -21814,7 +21828,7 @@
             <a:tbl>
               <a:tblPr>
                 <a:noFill/>
-                <a:tableStyleId>{7752FCCB-C744-403B-90CA-A14BC9C0A3A7}</a:tableStyleId>
+                <a:tableStyleId>{7655EB68-0E38-4612-8FD0-F1ACDE5AE169}</a:tableStyleId>
               </a:tblPr>
               <a:tblGrid>
                 <a:gridCol w="1041400"/>
@@ -25186,6 +25200,285 @@
 </file>
 
 <file path=ppt/theme/theme1.xml><?xml version="1.0" encoding="utf-8"?>
+<a:theme xmlns:a="http://schemas.openxmlformats.org/drawingml/2006/main" xmlns:r="http://schemas.openxmlformats.org/officeDocument/2006/relationships">
+  <a:themeElements>
+    <a:clrScheme name="Default">
+      <a:dk1>
+        <a:srgbClr val="000000"/>
+      </a:dk1>
+      <a:lt1>
+        <a:srgbClr val="FFFFFF"/>
+      </a:lt1>
+      <a:dk2>
+        <a:srgbClr val="158158"/>
+      </a:dk2>
+      <a:lt2>
+        <a:srgbClr val="F3F3F3"/>
+      </a:lt2>
+      <a:accent1>
+        <a:srgbClr val="058DC7"/>
+      </a:accent1>
+      <a:accent2>
+        <a:srgbClr val="50B432"/>
+      </a:accent2>
+      <a:accent3>
+        <a:srgbClr val="ED561B"/>
+      </a:accent3>
+      <a:accent4>
+        <a:srgbClr val="EDEF00"/>
+      </a:accent4>
+      <a:accent5>
+        <a:srgbClr val="24CBE5"/>
+      </a:accent5>
+      <a:accent6>
+        <a:srgbClr val="64E572"/>
+      </a:accent6>
+      <a:hlink>
+        <a:srgbClr val="2200CC"/>
+      </a:hlink>
+      <a:folHlink>
+        <a:srgbClr val="551A8B"/>
+      </a:folHlink>
+    </a:clrScheme>
+    <a:fontScheme name="Office">
+      <a:majorFont>
+        <a:latin typeface="Arial"/>
+        <a:ea typeface=""/>
+        <a:cs typeface=""/>
+        <a:font script="Jpan" typeface="ＭＳ Ｐゴシック"/>
+        <a:font script="Hang" typeface="맑은 고딕"/>
+        <a:font script="Hans" typeface="宋体"/>
+        <a:font script="Hant" typeface="新細明體"/>
+        <a:font script="Arab" typeface="Times New Roman"/>
+        <a:font script="Hebr" typeface="Times New Roman"/>
+        <a:font script="Thai" typeface="Angsana New"/>
+        <a:font script="Ethi" typeface="Nyala"/>
+        <a:font script="Beng" typeface="Vrinda"/>
+        <a:font script="Gujr" typeface="Shruti"/>
+        <a:font script="Khmr" typeface="MoolBoran"/>
+        <a:font script="Knda" typeface="Tunga"/>
+        <a:font script="Guru" typeface="Raavi"/>
+        <a:font script="Cans" typeface="Euphemia"/>
+        <a:font script="Cher" typeface="Plantagenet Cherokee"/>
+        <a:font script="Yiii" typeface="Microsoft Yi Baiti"/>
+        <a:font script="Tibt" typeface="Microsoft Himalaya"/>
+        <a:font script="Thaa" typeface="MV Boli"/>
+        <a:font script="Deva" typeface="Mangal"/>
+        <a:font script="Telu" typeface="Gautami"/>
+        <a:font script="Taml" typeface="Latha"/>
+        <a:font script="Syrc" typeface="Estrangelo Edessa"/>
+        <a:font script="Orya" typeface="Kalinga"/>
+        <a:font script="Mlym" typeface="Kartika"/>
+        <a:font script="Laoo" typeface="DokChampa"/>
+        <a:font script="Sinh" typeface="Iskoola Pota"/>
+        <a:font script="Mong" typeface="Mongolian Baiti"/>
+        <a:font script="Viet" typeface="Times New Roman"/>
+        <a:font script="Uigh" typeface="Microsoft Uighur"/>
+        <a:font script="Geor" typeface="Sylfaen"/>
+      </a:majorFont>
+      <a:minorFont>
+        <a:latin typeface="Arial"/>
+        <a:ea typeface=""/>
+        <a:cs typeface=""/>
+        <a:font script="Jpan" typeface="ＭＳ Ｐゴシック"/>
+        <a:font script="Hang" typeface="맑은 고딕"/>
+        <a:font script="Hans" typeface="宋体"/>
+        <a:font script="Hant" typeface="新細明體"/>
+        <a:font script="Arab" typeface="Arial"/>
+        <a:font script="Hebr" typeface="Arial"/>
+        <a:font script="Thai" typeface="Cordia New"/>
+        <a:font script="Ethi" typeface="Nyala"/>
+        <a:font script="Beng" typeface="Vrinda"/>
+        <a:font script="Gujr" typeface="Shruti"/>
+        <a:font script="Khmr" typeface="DaunPenh"/>
+        <a:font script="Knda" typeface="Tunga"/>
+        <a:font script="Guru" typeface="Raavi"/>
+        <a:font script="Cans" typeface="Euphemia"/>
+        <a:font script="Cher" typeface="Plantagenet Cherokee"/>
+        <a:font script="Yiii" typeface="Microsoft Yi Baiti"/>
+        <a:font script="Tibt" typeface="Microsoft Himalaya"/>
+        <a:font script="Thaa" typeface="MV Boli"/>
+        <a:font script="Deva" typeface="Mangal"/>
+        <a:font script="Telu" typeface="Gautami"/>
+        <a:font script="Taml" typeface="Latha"/>
+        <a:font script="Syrc" typeface="Estrangelo Edessa"/>
+        <a:font script="Orya" typeface="Kalinga"/>
+        <a:font script="Mlym" typeface="Kartika"/>
+        <a:font script="Laoo" typeface="DokChampa"/>
+        <a:font script="Sinh" typeface="Iskoola Pota"/>
+        <a:font script="Mong" typeface="Mongolian Baiti"/>
+        <a:font script="Viet" typeface="Arial"/>
+        <a:font script="Uigh" typeface="Microsoft Uighur"/>
+        <a:font script="Geor" typeface="Sylfaen"/>
+      </a:minorFont>
+    </a:fontScheme>
+    <a:fmtScheme name="Office">
+      <a:fillStyleLst>
+        <a:solidFill>
+          <a:schemeClr val="phClr"/>
+        </a:solidFill>
+        <a:gradFill rotWithShape="1">
+          <a:gsLst>
+            <a:gs pos="0">
+              <a:schemeClr val="phClr">
+                <a:tint val="50000"/>
+                <a:satMod val="300000"/>
+              </a:schemeClr>
+            </a:gs>
+            <a:gs pos="35000">
+              <a:schemeClr val="phClr">
+                <a:tint val="37000"/>
+                <a:satMod val="300000"/>
+              </a:schemeClr>
+            </a:gs>
+            <a:gs pos="100000">
+              <a:schemeClr val="phClr">
+                <a:tint val="15000"/>
+                <a:satMod val="350000"/>
+              </a:schemeClr>
+            </a:gs>
+          </a:gsLst>
+          <a:lin ang="16200000" scaled="1"/>
+        </a:gradFill>
+        <a:gradFill rotWithShape="1">
+          <a:gsLst>
+            <a:gs pos="0">
+              <a:schemeClr val="phClr">
+                <a:tint val="100000"/>
+                <a:shade val="100000"/>
+                <a:satMod val="130000"/>
+              </a:schemeClr>
+            </a:gs>
+            <a:gs pos="100000">
+              <a:schemeClr val="phClr">
+                <a:tint val="50000"/>
+                <a:shade val="100000"/>
+                <a:satMod val="350000"/>
+              </a:schemeClr>
+            </a:gs>
+          </a:gsLst>
+          <a:lin ang="16200000" scaled="0"/>
+        </a:gradFill>
+      </a:fillStyleLst>
+      <a:lnStyleLst>
+        <a:ln w="9525" cap="flat" cmpd="sng" algn="ctr">
+          <a:solidFill>
+            <a:schemeClr val="phClr">
+              <a:shade val="95000"/>
+              <a:satMod val="105000"/>
+            </a:schemeClr>
+          </a:solidFill>
+          <a:prstDash val="solid"/>
+        </a:ln>
+        <a:ln w="25400" cap="flat" cmpd="sng" algn="ctr">
+          <a:solidFill>
+            <a:schemeClr val="phClr"/>
+          </a:solidFill>
+          <a:prstDash val="solid"/>
+        </a:ln>
+        <a:ln w="38100" cap="flat" cmpd="sng" algn="ctr">
+          <a:solidFill>
+            <a:schemeClr val="phClr"/>
+          </a:solidFill>
+          <a:prstDash val="solid"/>
+        </a:ln>
+      </a:lnStyleLst>
+      <a:effectStyleLst>
+        <a:effectStyle>
+          <a:effectLst>
+            <a:outerShdw blurRad="40000" dist="20000" dir="5400000" rotWithShape="0">
+              <a:srgbClr val="000000">
+                <a:alpha val="38000"/>
+              </a:srgbClr>
+            </a:outerShdw>
+          </a:effectLst>
+        </a:effectStyle>
+        <a:effectStyle>
+          <a:effectLst>
+            <a:outerShdw blurRad="40000" dist="23000" dir="5400000" rotWithShape="0">
+              <a:srgbClr val="000000">
+                <a:alpha val="35000"/>
+              </a:srgbClr>
+            </a:outerShdw>
+          </a:effectLst>
+        </a:effectStyle>
+        <a:effectStyle>
+          <a:effectLst>
+            <a:outerShdw blurRad="40000" dist="23000" dir="5400000" rotWithShape="0">
+              <a:srgbClr val="000000">
+                <a:alpha val="35000"/>
+              </a:srgbClr>
+            </a:outerShdw>
+          </a:effectLst>
+          <a:scene3d>
+            <a:camera prst="orthographicFront">
+              <a:rot lat="0" lon="0" rev="0"/>
+            </a:camera>
+            <a:lightRig rig="threePt" dir="t">
+              <a:rot lat="0" lon="0" rev="1200000"/>
+            </a:lightRig>
+          </a:scene3d>
+          <a:sp3d>
+            <a:bevelT w="63500" h="25400"/>
+          </a:sp3d>
+        </a:effectStyle>
+      </a:effectStyleLst>
+      <a:bgFillStyleLst>
+        <a:solidFill>
+          <a:schemeClr val="phClr"/>
+        </a:solidFill>
+        <a:gradFill rotWithShape="1">
+          <a:gsLst>
+            <a:gs pos="0">
+              <a:schemeClr val="phClr">
+                <a:tint val="40000"/>
+                <a:satMod val="350000"/>
+              </a:schemeClr>
+            </a:gs>
+            <a:gs pos="40000">
+              <a:schemeClr val="phClr">
+                <a:tint val="45000"/>
+                <a:shade val="99000"/>
+                <a:satMod val="350000"/>
+              </a:schemeClr>
+            </a:gs>
+            <a:gs pos="100000">
+              <a:schemeClr val="phClr">
+                <a:shade val="20000"/>
+                <a:satMod val="255000"/>
+              </a:schemeClr>
+            </a:gs>
+          </a:gsLst>
+          <a:path path="circle">
+            <a:fillToRect l="50000" t="-80000" r="50000" b="180000"/>
+          </a:path>
+        </a:gradFill>
+        <a:gradFill rotWithShape="1">
+          <a:gsLst>
+            <a:gs pos="0">
+              <a:schemeClr val="phClr">
+                <a:tint val="80000"/>
+                <a:satMod val="300000"/>
+              </a:schemeClr>
+            </a:gs>
+            <a:gs pos="100000">
+              <a:schemeClr val="phClr">
+                <a:shade val="30000"/>
+                <a:satMod val="200000"/>
+              </a:schemeClr>
+            </a:gs>
+          </a:gsLst>
+          <a:path path="circle">
+            <a:fillToRect l="50000" t="50000" r="50000" b="50000"/>
+          </a:path>
+        </a:gradFill>
+      </a:bgFillStyleLst>
+    </a:fmtScheme>
+  </a:themeElements>
+</a:theme>
+</file>
+
+<file path=ppt/theme/theme2.xml><?xml version="1.0" encoding="utf-8"?>
 <a:theme xmlns:a="http://schemas.openxmlformats.org/drawingml/2006/main" xmlns:r="http://schemas.openxmlformats.org/officeDocument/2006/relationships" name="Simple Light">
   <a:themeElements>
     <a:clrScheme name="Simple Light">
@@ -25462,283 +25755,4 @@
     </a:fmtScheme>
   </a:themeElements>
 </a:theme>
-</file>
-
-<file path=ppt/theme/theme2.xml><?xml version="1.0" encoding="utf-8"?>
-<a:theme xmlns:a="http://schemas.openxmlformats.org/drawingml/2006/main" xmlns:r="http://schemas.openxmlformats.org/officeDocument/2006/relationships">
-  <a:themeElements>
-    <a:clrScheme name="Default">
-      <a:dk1>
-        <a:srgbClr val="000000"/>
-      </a:dk1>
-      <a:lt1>
-        <a:srgbClr val="FFFFFF"/>
-      </a:lt1>
-      <a:dk2>
-        <a:srgbClr val="158158"/>
-      </a:dk2>
-      <a:lt2>
-        <a:srgbClr val="F3F3F3"/>
-      </a:lt2>
-      <a:accent1>
-        <a:srgbClr val="058DC7"/>
-      </a:accent1>
-      <a:accent2>
-        <a:srgbClr val="50B432"/>
-      </a:accent2>
-      <a:accent3>
-        <a:srgbClr val="ED561B"/>
-      </a:accent3>
-      <a:accent4>
-        <a:srgbClr val="EDEF00"/>
-      </a:accent4>
-      <a:accent5>
-        <a:srgbClr val="24CBE5"/>
-      </a:accent5>
-      <a:accent6>
-        <a:srgbClr val="64E572"/>
-      </a:accent6>
-      <a:hlink>
-        <a:srgbClr val="2200CC"/>
-      </a:hlink>
-      <a:folHlink>
-        <a:srgbClr val="551A8B"/>
-      </a:folHlink>
-    </a:clrScheme>
-    <a:fontScheme name="Office">
-      <a:majorFont>
-        <a:latin typeface="Arial"/>
-        <a:ea typeface=""/>
-        <a:cs typeface=""/>
-        <a:font script="Jpan" typeface="ＭＳ Ｐゴシック"/>
-        <a:font script="Hang" typeface="맑은 고딕"/>
-        <a:font script="Hans" typeface="宋体"/>
-        <a:font script="Hant" typeface="新細明體"/>
-        <a:font script="Arab" typeface="Times New Roman"/>
-        <a:font script="Hebr" typeface="Times New Roman"/>
-        <a:font script="Thai" typeface="Angsana New"/>
-        <a:font script="Ethi" typeface="Nyala"/>
-        <a:font script="Beng" typeface="Vrinda"/>
-        <a:font script="Gujr" typeface="Shruti"/>
-        <a:font script="Khmr" typeface="MoolBoran"/>
-        <a:font script="Knda" typeface="Tunga"/>
-        <a:font script="Guru" typeface="Raavi"/>
-        <a:font script="Cans" typeface="Euphemia"/>
-        <a:font script="Cher" typeface="Plantagenet Cherokee"/>
-        <a:font script="Yiii" typeface="Microsoft Yi Baiti"/>
-        <a:font script="Tibt" typeface="Microsoft Himalaya"/>
-        <a:font script="Thaa" typeface="MV Boli"/>
-        <a:font script="Deva" typeface="Mangal"/>
-        <a:font script="Telu" typeface="Gautami"/>
-        <a:font script="Taml" typeface="Latha"/>
-        <a:font script="Syrc" typeface="Estrangelo Edessa"/>
-        <a:font script="Orya" typeface="Kalinga"/>
-        <a:font script="Mlym" typeface="Kartika"/>
-        <a:font script="Laoo" typeface="DokChampa"/>
-        <a:font script="Sinh" typeface="Iskoola Pota"/>
-        <a:font script="Mong" typeface="Mongolian Baiti"/>
-        <a:font script="Viet" typeface="Times New Roman"/>
-        <a:font script="Uigh" typeface="Microsoft Uighur"/>
-        <a:font script="Geor" typeface="Sylfaen"/>
-      </a:majorFont>
-      <a:minorFont>
-        <a:latin typeface="Arial"/>
-        <a:ea typeface=""/>
-        <a:cs typeface=""/>
-        <a:font script="Jpan" typeface="ＭＳ Ｐゴシック"/>
-        <a:font script="Hang" typeface="맑은 고딕"/>
-        <a:font script="Hans" typeface="宋体"/>
-        <a:font script="Hant" typeface="新細明體"/>
-        <a:font script="Arab" typeface="Arial"/>
-        <a:font script="Hebr" typeface="Arial"/>
-        <a:font script="Thai" typeface="Cordia New"/>
-        <a:font script="Ethi" typeface="Nyala"/>
-        <a:font script="Beng" typeface="Vrinda"/>
-        <a:font script="Gujr" typeface="Shruti"/>
-        <a:font script="Khmr" typeface="DaunPenh"/>
-        <a:font script="Knda" typeface="Tunga"/>
-        <a:font script="Guru" typeface="Raavi"/>
-        <a:font script="Cans" typeface="Euphemia"/>
-        <a:font script="Cher" typeface="Plantagenet Cherokee"/>
-        <a:font script="Yiii" typeface="Microsoft Yi Baiti"/>
-        <a:font script="Tibt" typeface="Microsoft Himalaya"/>
-        <a:font script="Thaa" typeface="MV Boli"/>
-        <a:font script="Deva" typeface="Mangal"/>
-        <a:font script="Telu" typeface="Gautami"/>
-        <a:font script="Taml" typeface="Latha"/>
-        <a:font script="Syrc" typeface="Estrangelo Edessa"/>
-        <a:font script="Orya" typeface="Kalinga"/>
-        <a:font script="Mlym" typeface="Kartika"/>
-        <a:font script="Laoo" typeface="DokChampa"/>
-        <a:font script="Sinh" typeface="Iskoola Pota"/>
-        <a:font script="Mong" typeface="Mongolian Baiti"/>
-        <a:font script="Viet" typeface="Arial"/>
-        <a:font script="Uigh" typeface="Microsoft Uighur"/>
-        <a:font script="Geor" typeface="Sylfaen"/>
-      </a:minorFont>
-    </a:fontScheme>
-    <a:fmtScheme name="Office">
-      <a:fillStyleLst>
-        <a:solidFill>
-          <a:schemeClr val="phClr"/>
-        </a:solidFill>
-        <a:gradFill rotWithShape="1">
-          <a:gsLst>
-            <a:gs pos="0">
-              <a:schemeClr val="phClr">
-                <a:tint val="50000"/>
-                <a:satMod val="300000"/>
-              </a:schemeClr>
-            </a:gs>
-            <a:gs pos="35000">
-              <a:schemeClr val="phClr">
-                <a:tint val="37000"/>
-                <a:satMod val="300000"/>
-              </a:schemeClr>
-            </a:gs>
-            <a:gs pos="100000">
-              <a:schemeClr val="phClr">
-                <a:tint val="15000"/>
-                <a:satMod val="350000"/>
-              </a:schemeClr>
-            </a:gs>
-          </a:gsLst>
-          <a:lin ang="16200000" scaled="1"/>
-        </a:gradFill>
-        <a:gradFill rotWithShape="1">
-          <a:gsLst>
-            <a:gs pos="0">
-              <a:schemeClr val="phClr">
-                <a:tint val="100000"/>
-                <a:shade val="100000"/>
-                <a:satMod val="130000"/>
-              </a:schemeClr>
-            </a:gs>
-            <a:gs pos="100000">
-              <a:schemeClr val="phClr">
-                <a:tint val="50000"/>
-                <a:shade val="100000"/>
-                <a:satMod val="350000"/>
-              </a:schemeClr>
-            </a:gs>
-          </a:gsLst>
-          <a:lin ang="16200000" scaled="0"/>
-        </a:gradFill>
-      </a:fillStyleLst>
-      <a:lnStyleLst>
-        <a:ln w="9525" cap="flat" cmpd="sng" algn="ctr">
-          <a:solidFill>
-            <a:schemeClr val="phClr">
-              <a:shade val="95000"/>
-              <a:satMod val="105000"/>
-            </a:schemeClr>
-          </a:solidFill>
-          <a:prstDash val="solid"/>
-        </a:ln>
-        <a:ln w="25400" cap="flat" cmpd="sng" algn="ctr">
-          <a:solidFill>
-            <a:schemeClr val="phClr"/>
-          </a:solidFill>
-          <a:prstDash val="solid"/>
-        </a:ln>
-        <a:ln w="38100" cap="flat" cmpd="sng" algn="ctr">
-          <a:solidFill>
-            <a:schemeClr val="phClr"/>
-          </a:solidFill>
-          <a:prstDash val="solid"/>
-        </a:ln>
-      </a:lnStyleLst>
-      <a:effectStyleLst>
-        <a:effectStyle>
-          <a:effectLst>
-            <a:outerShdw blurRad="40000" dist="20000" dir="5400000" rotWithShape="0">
-              <a:srgbClr val="000000">
-                <a:alpha val="38000"/>
-              </a:srgbClr>
-            </a:outerShdw>
-          </a:effectLst>
-        </a:effectStyle>
-        <a:effectStyle>
-          <a:effectLst>
-            <a:outerShdw blurRad="40000" dist="23000" dir="5400000" rotWithShape="0">
-              <a:srgbClr val="000000">
-                <a:alpha val="35000"/>
-              </a:srgbClr>
-            </a:outerShdw>
-          </a:effectLst>
-        </a:effectStyle>
-        <a:effectStyle>
-          <a:effectLst>
-            <a:outerShdw blurRad="40000" dist="23000" dir="5400000" rotWithShape="0">
-              <a:srgbClr val="000000">
-                <a:alpha val="35000"/>
-              </a:srgbClr>
-            </a:outerShdw>
-          </a:effectLst>
-          <a:scene3d>
-            <a:camera prst="orthographicFront">
-              <a:rot lat="0" lon="0" rev="0"/>
-            </a:camera>
-            <a:lightRig rig="threePt" dir="t">
-              <a:rot lat="0" lon="0" rev="1200000"/>
-            </a:lightRig>
-          </a:scene3d>
-          <a:sp3d>
-            <a:bevelT w="63500" h="25400"/>
-          </a:sp3d>
-        </a:effectStyle>
-      </a:effectStyleLst>
-      <a:bgFillStyleLst>
-        <a:solidFill>
-          <a:schemeClr val="phClr"/>
-        </a:solidFill>
-        <a:gradFill rotWithShape="1">
-          <a:gsLst>
-            <a:gs pos="0">
-              <a:schemeClr val="phClr">
-                <a:tint val="40000"/>
-                <a:satMod val="350000"/>
-              </a:schemeClr>
-            </a:gs>
-            <a:gs pos="40000">
-              <a:schemeClr val="phClr">
-                <a:tint val="45000"/>
-                <a:shade val="99000"/>
-                <a:satMod val="350000"/>
-              </a:schemeClr>
-            </a:gs>
-            <a:gs pos="100000">
-              <a:schemeClr val="phClr">
-                <a:shade val="20000"/>
-                <a:satMod val="255000"/>
-              </a:schemeClr>
-            </a:gs>
-          </a:gsLst>
-          <a:path path="circle">
-            <a:fillToRect l="50000" t="-80000" r="50000" b="180000"/>
-          </a:path>
-        </a:gradFill>
-        <a:gradFill rotWithShape="1">
-          <a:gsLst>
-            <a:gs pos="0">
-              <a:schemeClr val="phClr">
-                <a:tint val="80000"/>
-                <a:satMod val="300000"/>
-              </a:schemeClr>
-            </a:gs>
-            <a:gs pos="100000">
-              <a:schemeClr val="phClr">
-                <a:shade val="30000"/>
-                <a:satMod val="200000"/>
-              </a:schemeClr>
-            </a:gs>
-          </a:gsLst>
-          <a:path path="circle">
-            <a:fillToRect l="50000" t="50000" r="50000" b="50000"/>
-          </a:path>
-        </a:gradFill>
-      </a:bgFillStyleLst>
-    </a:fmtScheme>
-  </a:themeElements>
-</a:theme>
 </file>
</xml_diff>

<commit_message>
Publish the single-checkpoint notebook and revised lab slides
</commit_message>
<xml_diff>
--- a/labs/lab-01-kev-pacman/slides/pacman-lab.pptx
+++ b/labs/lab-01-kev-pacman/slides/pacman-lab.pptx
@@ -794,7 +794,7 @@
             </a:pPr>
             <a:r>
               <a:rPr lang="zh-CN"/>
-              <a:t>Small-model Kev trains low-rank encoder adapters and a pointer head. Original base matrices stay fixed, but effective features change. CLM trains state/action projection heads and a similarity scale over completely fixed LLM features. Kev-27B is a separate full-fine-tuning recipe. The Pac-Man lab uses Kev-0.8B with the published decision-v7 base stage, then supervised player-domain adaptation. The comparison remains useful for understanding independent action caching and repeated training cost.</a:t>
+              <a:t>Small-model Kev trains low-rank encoder adapters and a pointer head. Original base matrices stay fixed, but effective features change. CLM trains state/action projection heads and a similarity scale over completely fixed LLM features. Kev-27B is a separate full-fine-tuning recipe. The Pac-Man lab uses Kev-4B with four separate general stages, then supervised player-domain adaptation in the single CP1. Interactive play is an ungraded activity. The comparison remains useful for understanding independent action caching and repeated training cost.</a:t>
             </a:r>
             <a:endParaRPr/>
           </a:p>
@@ -970,6 +970,21 @@
             <a:r>
               <a:rPr lang="zh-CN"/>
               <a:t>CLM article: supplied Contrastive Language Models PDF, pages 6-8; https://contrastive-lm.notion.site/</a:t>
+            </a:r>
+            <a:endParaRPr/>
+          </a:p>
+          <a:p>
+            <a:pPr indent="0" lvl="0" marL="0" rtl="0" algn="l">
+              <a:spcBef>
+                <a:spcPts val="0"/>
+              </a:spcBef>
+              <a:spcAft>
+                <a:spcPts val="0"/>
+              </a:spcAft>
+              <a:buNone/>
+            </a:pPr>
+            <a:r>
+              <a:t/>
             </a:r>
             <a:endParaRPr/>
           </a:p>
@@ -1069,7 +1084,7 @@
             </a:pPr>
             <a:r>
               <a:rPr lang="zh-CN"/>
-              <a:t>The lab uses Qwen/Qwen3.5-4B-Base@1001bb4d826a52d1f399e183466143f4da7b741b. Rank-16 LoRA (alpha 32) targets all supported projections, plus a 256-dimensional pointer head; the base matrices stay fixed. CP0 serves the completed Skills adapter. CP3 warm-starts that adapter for a separate Pac-Man task stage. The native game is masonicGIT/pacman@7407174c1d6a38be8cd230577489e39e0873145b. It retains the classic maze, assets, four ghost personalities, release rules, speed tables, phases, power pellets and fruit. It is a faithful recreation with documented differences from the arcade ROM. Calibration remains separate. Sources: https://huggingface.co/jaredpalmer/kev-4b ; https://github.com/masonicGIT/pacman/tree/7407174c1d6a38be8cd230577489e39e0873145b ; https://github.com/yxc20089/QPlusLearning/tree/main/labs/lab-01-kev-pacman</a:t>
+              <a:t>The lab uses Qwen/Qwen3.5-4B-Base@1001bb4d826a52d1f399e183466143f4da7b741b. Rank-16 LoRA (alpha 32) targets all supported projections, plus a 256-dimensional pointer head; the base matrices stay fixed. Interactive play initially serves the completed Skills adapter. CP1 is the only assessed checkpoint: review native-game planning labels, fine-tune from Skills, compare paired held-out boards and model rollouts, then explain and export the evidence. Interactive play remains a separate ungraded activity and can be rerun after evaluation with the task adapter. The native game is masonicGIT/pacman@7407174c1d6a38be8cd230577489e39e0873145b. It retains the classic maze, assets, four ghost personalities, release rules, speed tables, phases, power pellets and fruit. It is a faithful recreation with documented differences from the arcade ROM. Calibration remains separate. Sources: https://huggingface.co/jaredpalmer/kev-4b ; https://github.com/masonicGIT/pacman/tree/7407174c1d6a38be8cd230577489e39e0873145b ; https://github.com/yxc20089/QPlusLearning/tree/main/labs/lab-01-kev-pacman</a:t>
             </a:r>
             <a:endParaRPr/>
           </a:p>
@@ -1184,7 +1199,7 @@
             </a:pPr>
             <a:r>
               <a:rPr lang="zh-CN"/>
-              <a:t>Keep the 90-minute lab with a 30-minute fine-tuning block. Installation, model downloads, four general decision stages and offline label generation are prework. The Pac-Man stage now runs a full epoch over 4,096 task records and 2,000 decision-v7 replay records, giving 762 updates at effective batch eight. There is no automatic short-step cap. Time the full stage before class. At 1.5 seconds per update, optimizer work is about 19 minutes; at 3 seconds it is about 38 minutes, plus loading/compilation/saving. These are calculations, not measured GPU timings. Complete slower full runs as prework. Source: https://github.com/yxc20089/QPlusLearning/tree/main/labs/lab-01-kev-pacman/cloud_runtime.py</a:t>
+              <a:t>The lab has one assessed CP1 encompassing label review, fine-tuning, paired evaluation and submission. Interactive play is a separate ungraded activity before and after training. Keep the 90-minute lab with a 30-minute fine-tuning block. Installation, model downloads, four general decision stages and offline label generation are prework. The Pac-Man stage now runs a full epoch over 4,096 task records and 2,000 decision-v7 replay records, giving 762 updates at effective batch eight. There is no automatic short-step cap. Time the full stage before class. At 1.5 seconds per update, optimizer work is about 19 minutes; at 3 seconds it is about 38 minutes, plus loading/compilation/saving. These are calculations, not measured GPU timings. Complete slower full runs as prework. Source: https://github.com/yxc20089/QPlusLearning/tree/main/labs/lab-01-kev-pacman/cloud_runtime.py</a:t>
             </a:r>
             <a:endParaRPr/>
           </a:p>
@@ -1414,7 +1429,7 @@
             </a:pPr>
             <a:r>
               <a:rPr lang="zh-CN"/>
-              <a:t>Blinky targets Pac-Man; Pinky targets four tiles ahead with the native upward overflow quirk; Inky reflects the two-tile-ahead point around Blinky, also preserving the upward quirk; Clyde targets Pac-Man when far away and its scatter corner when close. Chase/scatter turns use deterministic native targeting and tie-breaking. Frightened turns use the native RNG. Ghost-house release uses native pellet counters and inactivity timeouts: at level 1 Pinky releases first, Inky has a personal threshold of 30, Clyde 60, and a four-second no-pellet timeout can release the next waiting ghost. These are personal counters, not total board pellets. Game time pauses while the model decides, so wall-clock minutes can represent only a few simulation seconds. The UI shows simulated seconds and each ghost mode; do not force every ghost outside at the start. Sources: https://github.com/masonicGIT/pacman/blob/7407174c1d6a38be8cd230577489e39e0873145b/src/targets.js ; https://github.com/masonicGIT/pacman/blob/7407174c1d6a38be8cd230577489e39e0873145b/src/ghostReleaser.js ; https://github.com/yxc20089/QPlusLearning/tree/main/labs/lab-01-kev-pacman/games/arcade-engine.js</a:t>
+              <a:t>This is an ungraded activity, not an assessment checkpoint. Initially the badge identifies the completed Skills LoRA/head. CP1 evaluation leaves the task adapter serving; rerun the same play cell afterward and before export to try it. Blinky targets Pac-Man; Pinky targets four tiles ahead with the native upward overflow quirk; Inky reflects the two-tile-ahead point around Blinky, also preserving the upward quirk; Clyde targets Pac-Man when far away and its scatter corner when close. Chase/scatter turns use deterministic native targeting and tie-breaking. Frightened turns use the native RNG. Ghost-house release uses native pellet counters and inactivity timeouts: at level 1 Pinky releases first, Inky has a personal threshold of 30, Clyde 60, and a four-second no-pellet timeout can release the next waiting ghost. These are personal counters, not total board pellets. Game time pauses while the model decides, so wall-clock minutes can represent only a few simulation seconds. The UI shows simulated seconds and each ghost mode; do not force every ghost outside at the start. Sources: https://github.com/masonicGIT/pacman/blob/7407174c1d6a38be8cd230577489e39e0873145b/src/targets.js ; https://github.com/masonicGIT/pacman/blob/7407174c1d6a38be8cd230577489e39e0873145b/src/ghostReleaser.js ; https://github.com/yxc20089/QPlusLearning/tree/main/labs/lab-01-kev-pacman/games/arcade-engine.js</a:t>
             </a:r>
             <a:endParaRPr/>
           </a:p>
@@ -1529,7 +1544,7 @@
             </a:pPr>
             <a:r>
               <a:rPr lang="zh-CN"/>
-              <a:t>The game constructs caller-supplied criteria containing legal directions and their destination tiles. Kev jointly encodes state, question and options. Its head has query/key Linear projections from hidden_size to 256 and computes scaled dot products, then softmax over options. Hybrid Qwen3.5 handles each question as a causal row continuing from the shared state. This is contextual option scoring, unlike CLM's independent action encodings. Legal directions come from the maze rules. Probability reflects the offered options and is not a maze-clearing probability. The notebook serves the learner's initial checkpoint through /v1/systemone and connects the game via a Colab callback.</a:t>
+              <a:t>The game constructs caller-supplied criteria containing legal directions and their destination tiles. Kev jointly encodes state, question and options. Its head has query/key Linear projections from hidden_size to 256 and computes scaled dot products, then softmax over options. Hybrid Qwen3.5 handles each question as a causal row continuing from the shared state. This is contextual option scoring, unlike CLM's independent action encodings. Legal directions come from the maze rules. Probability reflects the offered options and is not a maze-clearing probability. The notebook serves the active Skills or Pac-Man checkpoint through /v1/systemone and connects the game via a Colab callback.</a:t>
             </a:r>
             <a:endParaRPr/>
           </a:p>
@@ -1705,6 +1720,21 @@
             <a:r>
               <a:rPr lang="zh-CN"/>
               <a:t>CLM article: supplied Contrastive Language Models PDF, pages 6-8; https://contrastive-lm.notion.site/</a:t>
+            </a:r>
+            <a:endParaRPr/>
+          </a:p>
+          <a:p>
+            <a:pPr indent="0" lvl="0" marL="0" rtl="0" algn="l">
+              <a:spcBef>
+                <a:spcPts val="0"/>
+              </a:spcBef>
+              <a:spcAft>
+                <a:spcPts val="0"/>
+              </a:spcAft>
+              <a:buNone/>
+            </a:pPr>
+            <a:r>
+              <a:t/>
             </a:r>
             <a:endParaRPr/>
           </a:p>
@@ -2309,7 +2339,7 @@
             </a:pPr>
             <a:r>
               <a:rPr lang="zh-CN"/>
-              <a:t>CP3 trains one full task epoch from the learner completed Skills checkpoint, using reviewed training labels while preserving development/evaluation splits. The exact command is printed. Output kev-4b-pacman-planner-v1 is separate from the earlier small heuristic experiment. Effective batch eight, rank-16 alpha-32 all-module LoRA, 256-dimensional head, lr 2e-5, BF16 autocast over FP32 weights, checkpointing, max_state 4096. Add 2,000 decision-v7 train replay records. Verify 6,096 accepted/seen records, no dropped/truncated records and 762 optimizer updates. Stop the serving process before training and reload afterward. Recovery saves after step 1, every 100 steps or five minutes, and at the final step. If SAVE_TO_DRIVE is enabled and mounted, each complete recovery/final checkpoint triggers a verified Drive backup. Source: https://github.com/yxc20089/QPlusLearning/tree/main/labs/lab-01-kev-pacman/cloud_runtime.py ; https://github.com/yxc20089/QPlusLearning/tree/main/labs/lab-01-kev-pacman/checkpoint_backup.py</a:t>
+              <a:t>CP1 includes data review, one full task training epoch, paired evaluation and evidence submission. It trains one full task epoch from the learner completed Skills checkpoint, using reviewed training labels while preserving development/evaluation splits. The exact command is printed. Output kev-4b-pacman-planner-v1 is separate from the earlier small heuristic experiment. Effective batch eight, rank-16 alpha-32 all-module LoRA, 256-dimensional head, lr 2e-5, BF16 autocast over FP32 weights, checkpointing, max_state 4096. Add 2,000 decision-v7 train replay records. Verify 6,096 accepted/seen records, no dropped/truncated records and 762 optimizer updates. Stop the serving process before training and reload afterward. Recovery saves after step 1, every 100 steps or five minutes, and at the final step. If SAVE_TO_DRIVE is enabled and mounted, each complete recovery/final checkpoint triggers a verified Drive backup. Source: https://github.com/yxc20089/QPlusLearning/tree/main/labs/lab-01-kev-pacman/cloud_runtime.py ; https://github.com/yxc20089/QPlusLearning/tree/main/labs/lab-01-kev-pacman/checkpoint_backup.py Evaluate the same 256 held-out boards and native model rollouts with the same seed and 128-decision cap. Record both measured results even if the task adapter does not improve. Explain a changed move or a remaining mistake, the relevant ghost behaviour, LoRA/head gradients and finite-search limitations.</a:t>
             </a:r>
             <a:endParaRPr/>
           </a:p>
@@ -2929,7 +2959,7 @@
             </a:pPr>
             <a:r>
               <a:rPr lang="zh-CN"/>
-              <a:t>Compare native 128-action Skills/fine-tuned rollouts with the same level/seed and verified active adapter. A separate native planner rollout is a rules-controller reference; it never replaces a requested model controller. The five-seed CPU planning audit uses level 1 and up to 512 actions, stopping at first life loss or clear. Mean pellets: planner 225, old heuristic 199.4; mean score: 3,590 versus 2,594; losses one versus four; clears zero versus one, with four planner turn limits. This is a small deterministic controller comparison, not a trained-Kev result or proof of optimality. It exposes remaining endgame limitations. Record measured GPU step time/utilization and Colab compute units. Sources: https://github.com/yxc20089/QPlusLearning/tree/main/labs/lab-01-kev-pacman/data/pacman-planner-v1-quality.json ; https://github.com/yxc20089/QPlusLearning/tree/main/labs/lab-01-kev-pacman/planner_data.py</a:t>
+              <a:t>Compare native 128-action Skills/fine-tuned rollouts with the same level/seed and verified active adapter. The committed five-seed teacher quality report is a rules-controller reference; it never replaces a requested model controller. The five-seed CPU planning audit uses level 1 and up to 512 actions, stopping at first life loss or clear. Mean pellets: planner 225, old heuristic 199.4; mean score: 3,590 versus 2,594; losses one versus four; clears zero versus one, with four planner turn limits. This is a small deterministic controller comparison, not a trained-Kev result or proof of optimality. It exposes remaining endgame limitations. Record measured GPU step time/utilization and Colab compute units. Sources: https://github.com/yxc20089/QPlusLearning/tree/main/labs/lab-01-kev-pacman/data/pacman-planner-v1-quality.json ; https://github.com/yxc20089/QPlusLearning/tree/main/labs/lab-01-kev-pacman/planner_data.py</a:t>
             </a:r>
             <a:endParaRPr/>
           </a:p>
@@ -3044,7 +3074,22 @@
             </a:pPr>
             <a:r>
               <a:rPr lang="zh-CN"/>
-              <a:t>Submit executed notebook, reviewed training JSONL, all five adapter/head checkpoints, every configuration/metrics file, paired predictions, raw logs and TensorBoard events, trainable-parameters.json, runtime-preflight.json and optimized-training-preflight.json. Package adapters/heads rather than foundation weights or dependencies. Record compute units and elapsed GPU time. Checkpoint ownership must identify learner versus instructor. Source: course notebook submission cell.</a:t>
+              <a:t>This is the submission component of the single CP1. Submit the executed notebook, reviewed training JSONL, Pac-Man adapter/head, all available earlier stage checkpoints, configurations/metrics, paired predictions, raw logs and TensorBoard events, trainable-parameters.json, runtime-preflight.json and optimized-training-preflight.json. Explain one changed move or remaining mistake, the relevant ghost behaviour, which parameters received gradients, and the approximate search limitations. A full fresh run has five adapter/head checkpoints; a Skills-only continuation reports missing earlier archives rather than requiring retraining. Package adapters/heads rather than foundation weights or dependencies. Record compute units and elapsed GPU time. Checkpoint ownership identifies learner versus instructor. Source: course notebook submission cell.</a:t>
+            </a:r>
+            <a:endParaRPr/>
+          </a:p>
+          <a:p>
+            <a:pPr indent="0" lvl="0" marL="0" rtl="0" algn="l">
+              <a:spcBef>
+                <a:spcPts val="0"/>
+              </a:spcBef>
+              <a:spcAft>
+                <a:spcPts val="0"/>
+              </a:spcAft>
+              <a:buNone/>
+            </a:pPr>
+            <a:r>
+              <a:t/>
             </a:r>
             <a:endParaRPr/>
           </a:p>
@@ -9819,7 +9864,7 @@
             <a:tbl>
               <a:tblPr>
                 <a:noFill/>
-                <a:tableStyleId>{7655EB68-0E38-4612-8FD0-F1ACDE5AE169}</a:tableStyleId>
+                <a:tableStyleId>{DEED6AD8-1233-4805-ACC7-B9A81D23648E}</a:tableStyleId>
               </a:tblPr>
               <a:tblGrid>
                 <a:gridCol w="1549400"/>
@@ -10987,7 +11032,7 @@
                   <a:srgbClr val="1A2433"/>
                 </a:solidFill>
               </a:rPr>
-              <a:t>Skills checkpoint controls Pac-Man at CP0</a:t>
+              <a:t>Try interactive play with the Skills adapter</a:t>
             </a:r>
             <a:endParaRPr sz="2300">
               <a:solidFill>
@@ -11041,7 +11086,7 @@
                   <a:srgbClr val="1A2433"/>
                 </a:solidFill>
               </a:rPr>
-              <a:t>Fine-tune the same LoRA and pointer head</a:t>
+              <a:t>CP1: fine-tune, evaluate and submit evidence</a:t>
             </a:r>
             <a:endParaRPr sz="2300">
               <a:solidFill>
@@ -11068,7 +11113,29 @@
                   <a:srgbClr val="1A2433"/>
                 </a:solidFill>
               </a:rPr>
-              <a:t>Compare the model with its planning teacher</a:t>
+              <a:t>Keep interactive play as a separate activity</a:t>
+            </a:r>
+            <a:endParaRPr sz="2300">
+              <a:solidFill>
+                <a:srgbClr val="1A2433"/>
+              </a:solidFill>
+            </a:endParaRPr>
+          </a:p>
+          <a:p>
+            <a:pPr indent="0" lvl="0" marL="0" marR="0" rtl="0" algn="l">
+              <a:lnSpc>
+                <a:spcPct val="112000"/>
+              </a:lnSpc>
+              <a:spcBef>
+                <a:spcPts val="800"/>
+              </a:spcBef>
+              <a:spcAft>
+                <a:spcPts val="0"/>
+              </a:spcAft>
+              <a:buNone/>
+            </a:pPr>
+            <a:r>
+              <a:t/>
             </a:r>
             <a:endParaRPr sz="2300">
               <a:solidFill>
@@ -11354,7 +11421,7 @@
                   <a:srgbClr val="1A2433"/>
                 </a:solidFill>
               </a:rPr>
-              <a:t>0-10    Compare architectures and play</a:t>
+              <a:t>0-20    Compare models and try interactive play</a:t>
             </a:r>
             <a:endParaRPr sz="2300">
               <a:solidFill>
@@ -11381,34 +11448,7 @@
                   <a:srgbClr val="1A2433"/>
                 </a:solidFill>
               </a:rPr>
-              <a:t>10-20  Inspect the four general training stages</a:t>
-            </a:r>
-            <a:endParaRPr sz="2300">
-              <a:solidFill>
-                <a:srgbClr val="1A2433"/>
-              </a:solidFill>
-            </a:endParaRPr>
-          </a:p>
-          <a:p>
-            <a:pPr indent="0" lvl="0" marL="0" marR="0" rtl="0" algn="l">
-              <a:lnSpc>
-                <a:spcPct val="112000"/>
-              </a:lnSpc>
-              <a:spcBef>
-                <a:spcPts val="800"/>
-              </a:spcBef>
-              <a:spcAft>
-                <a:spcPts val="0"/>
-              </a:spcAft>
-              <a:buNone/>
-            </a:pPr>
-            <a:r>
-              <a:rPr lang="zh-CN" sz="2300">
-                <a:solidFill>
-                  <a:srgbClr val="1A2433"/>
-                </a:solidFill>
-              </a:rPr>
-              <a:t>20-30  Review Pac-Man player labels</a:t>
+              <a:t>20-30  Review Pac-Man planning labels</a:t>
             </a:r>
             <a:endParaRPr sz="2300">
               <a:solidFill>
@@ -11462,7 +11502,7 @@
                   <a:srgbClr val="1A2433"/>
                 </a:solidFill>
               </a:rPr>
-              <a:t>60-80  Compare cost and player decisions</a:t>
+              <a:t>60-80  Evaluate the same boards and seed</a:t>
             </a:r>
             <a:endParaRPr sz="2300">
               <a:solidFill>
@@ -11479,7 +11519,7 @@
                 <a:spcPts val="800"/>
               </a:spcBef>
               <a:spcAft>
-                <a:spcPts val="800"/>
+                <a:spcPts val="0"/>
               </a:spcAft>
               <a:buNone/>
             </a:pPr>
@@ -11489,7 +11529,29 @@
                   <a:srgbClr val="1A2433"/>
                 </a:solidFill>
               </a:rPr>
-              <a:t>80-90  Explain and submit</a:t>
+              <a:t>80-90  Explain and submit the checkpoint</a:t>
+            </a:r>
+            <a:endParaRPr sz="2300">
+              <a:solidFill>
+                <a:srgbClr val="1A2433"/>
+              </a:solidFill>
+            </a:endParaRPr>
+          </a:p>
+          <a:p>
+            <a:pPr indent="0" lvl="0" marL="0" marR="0" rtl="0" algn="l">
+              <a:lnSpc>
+                <a:spcPct val="112000"/>
+              </a:lnSpc>
+              <a:spcBef>
+                <a:spcPts val="800"/>
+              </a:spcBef>
+              <a:spcAft>
+                <a:spcPts val="800"/>
+              </a:spcAft>
+              <a:buNone/>
+            </a:pPr>
+            <a:r>
+              <a:t/>
             </a:r>
             <a:endParaRPr sz="2300">
               <a:solidFill>
@@ -11542,7 +11604,29 @@
                   <a:srgbClr val="5E6E80"/>
                 </a:solidFill>
               </a:rPr>
-              <a:t>General training and labels are prework; time the full task stage before class.</a:t>
+              <a:t>One assessed CP1; interactive play is ungraded. General training and labels are prework.</a:t>
+            </a:r>
+            <a:endParaRPr sz="900">
+              <a:solidFill>
+                <a:srgbClr val="5E6E80"/>
+              </a:solidFill>
+            </a:endParaRPr>
+          </a:p>
+          <a:p>
+            <a:pPr indent="0" lvl="0" marL="0" marR="0" rtl="0" algn="l">
+              <a:lnSpc>
+                <a:spcPct val="112000"/>
+              </a:lnSpc>
+              <a:spcBef>
+                <a:spcPts val="800"/>
+              </a:spcBef>
+              <a:spcAft>
+                <a:spcPts val="0"/>
+              </a:spcAft>
+              <a:buNone/>
+            </a:pPr>
+            <a:r>
+              <a:t/>
             </a:r>
             <a:endParaRPr sz="900">
               <a:solidFill>
@@ -12094,7 +12178,29 @@
                   <a:srgbClr val="111829"/>
                 </a:solidFill>
               </a:rPr>
-              <a:t>CP0: Pac-Man and four ghost personalities</a:t>
+              <a:t>Interactive play with trained Kev</a:t>
+            </a:r>
+            <a:endParaRPr b="1" sz="3000">
+              <a:solidFill>
+                <a:srgbClr val="111829"/>
+              </a:solidFill>
+            </a:endParaRPr>
+          </a:p>
+          <a:p>
+            <a:pPr indent="0" lvl="0" marL="0" rtl="0" algn="l">
+              <a:lnSpc>
+                <a:spcPct val="112000"/>
+              </a:lnSpc>
+              <a:spcBef>
+                <a:spcPts val="800"/>
+              </a:spcBef>
+              <a:spcAft>
+                <a:spcPts val="0"/>
+              </a:spcAft>
+              <a:buNone/>
+            </a:pPr>
+            <a:r>
+              <a:t/>
             </a:r>
             <a:endParaRPr b="1" sz="3000">
               <a:solidFill>
@@ -12277,7 +12383,29 @@
                   <a:srgbClr val="1A2433"/>
                 </a:solidFill>
               </a:rPr>
-              <a:t>Verify the active Skills adapter in the badge</a:t>
+              <a:t>Verify the active adapter in the badge</a:t>
+            </a:r>
+            <a:endParaRPr sz="2300">
+              <a:solidFill>
+                <a:srgbClr val="1A2433"/>
+              </a:solidFill>
+            </a:endParaRPr>
+          </a:p>
+          <a:p>
+            <a:pPr indent="0" lvl="0" marL="0" rtl="0" algn="l">
+              <a:lnSpc>
+                <a:spcPct val="112000"/>
+              </a:lnSpc>
+              <a:spcBef>
+                <a:spcPts val="800"/>
+              </a:spcBef>
+              <a:spcAft>
+                <a:spcPts val="0"/>
+              </a:spcAft>
+              <a:buNone/>
+            </a:pPr>
+            <a:r>
+              <a:t/>
             </a:r>
             <a:endParaRPr sz="2300">
               <a:solidFill>
@@ -12352,7 +12480,29 @@
                   <a:srgbClr val="5E6E80"/>
                 </a:solidFill>
               </a:rPr>
-              <a:t>Chase/scatter is deterministic. Kev pauses simulation while deciding.</a:t>
+              <a:t>Separate, ungraded activity before or after CP1. Kev pauses simulation while deciding.</a:t>
+            </a:r>
+            <a:endParaRPr sz="900">
+              <a:solidFill>
+                <a:srgbClr val="5E6E80"/>
+              </a:solidFill>
+            </a:endParaRPr>
+          </a:p>
+          <a:p>
+            <a:pPr indent="0" lvl="0" marL="0" rtl="0" algn="l">
+              <a:lnSpc>
+                <a:spcPct val="112000"/>
+              </a:lnSpc>
+              <a:spcBef>
+                <a:spcPts val="800"/>
+              </a:spcBef>
+              <a:spcAft>
+                <a:spcPts val="0"/>
+              </a:spcAft>
+              <a:buNone/>
+            </a:pPr>
+            <a:r>
+              <a:t/>
             </a:r>
             <a:endParaRPr sz="900">
               <a:solidFill>
@@ -12500,7 +12650,7 @@
                 <a:spcPts val="0"/>
               </a:spcBef>
               <a:spcAft>
-                <a:spcPts val="800"/>
+                <a:spcPts val="0"/>
               </a:spcAft>
               <a:buNone/>
             </a:pPr>
@@ -12510,7 +12660,29 @@
                   <a:srgbClr val="111829"/>
                 </a:solidFill>
               </a:rPr>
-              <a:t>CP1: score a legal player move</a:t>
+              <a:t>How Kev scores a legal move</a:t>
+            </a:r>
+            <a:endParaRPr b="1" sz="3000">
+              <a:solidFill>
+                <a:srgbClr val="111829"/>
+              </a:solidFill>
+            </a:endParaRPr>
+          </a:p>
+          <a:p>
+            <a:pPr indent="0" lvl="0" marL="0" rtl="0" algn="l">
+              <a:lnSpc>
+                <a:spcPct val="112000"/>
+              </a:lnSpc>
+              <a:spcBef>
+                <a:spcPts val="800"/>
+              </a:spcBef>
+              <a:spcAft>
+                <a:spcPts val="800"/>
+              </a:spcAft>
+              <a:buNone/>
+            </a:pPr>
+            <a:r>
+              <a:t/>
             </a:r>
             <a:endParaRPr b="1" sz="3000">
               <a:solidFill>
@@ -13210,7 +13382,29 @@
                   <a:srgbClr val="111829"/>
                 </a:solidFill>
               </a:rPr>
-              <a:t>CP2: inspect planning labels</a:t>
+              <a:t>Pac-Man planning data</a:t>
+            </a:r>
+            <a:endParaRPr b="1" sz="3000">
+              <a:solidFill>
+                <a:srgbClr val="111829"/>
+              </a:solidFill>
+            </a:endParaRPr>
+          </a:p>
+          <a:p>
+            <a:pPr indent="0" lvl="0" marL="0" rtl="0" algn="l">
+              <a:lnSpc>
+                <a:spcPct val="112000"/>
+              </a:lnSpc>
+              <a:spcBef>
+                <a:spcPts val="800"/>
+              </a:spcBef>
+              <a:spcAft>
+                <a:spcPts val="0"/>
+              </a:spcAft>
+              <a:buNone/>
+            </a:pPr>
+            <a:r>
+              <a:t/>
             </a:r>
             <a:endParaRPr b="1" sz="3000">
               <a:solidFill>
@@ -14010,7 +14204,7 @@
                 <a:spcPts val="0"/>
               </a:spcBef>
               <a:spcAft>
-                <a:spcPts val="800"/>
+                <a:spcPts val="0"/>
               </a:spcAft>
               <a:buNone/>
             </a:pPr>
@@ -14020,7 +14214,29 @@
                   <a:srgbClr val="111829"/>
                 </a:solidFill>
               </a:rPr>
-              <a:t>CP3: 30 minutes of fine-tuning</a:t>
+              <a:t>CP1: fine-tune and evaluate Pac-Man</a:t>
+            </a:r>
+            <a:endParaRPr b="1" sz="3000">
+              <a:solidFill>
+                <a:srgbClr val="111829"/>
+              </a:solidFill>
+            </a:endParaRPr>
+          </a:p>
+          <a:p>
+            <a:pPr indent="0" lvl="0" marL="0" rtl="0" algn="l">
+              <a:lnSpc>
+                <a:spcPct val="112000"/>
+              </a:lnSpc>
+              <a:spcBef>
+                <a:spcPts val="800"/>
+              </a:spcBef>
+              <a:spcAft>
+                <a:spcPts val="800"/>
+              </a:spcAft>
+              <a:buNone/>
+            </a:pPr>
+            <a:r>
+              <a:t/>
             </a:r>
             <a:endParaRPr b="1" sz="3000">
               <a:solidFill>
@@ -14073,7 +14289,7 @@
                   <a:srgbClr val="1A2433"/>
                 </a:solidFill>
               </a:rPr>
-              <a:t>Warm-start your completed Skills checkpoint</a:t>
+              <a:t>Review 4,096 planning-labelled game states</a:t>
             </a:r>
             <a:endParaRPr sz="2300">
               <a:solidFill>
@@ -14100,7 +14316,7 @@
                   <a:srgbClr val="1A2433"/>
                 </a:solidFill>
               </a:rPr>
-              <a:t>One epoch; lr 2e-5; effective batch eight</a:t>
+              <a:t>Warm-start Skills; one epoch, 762 updates</a:t>
             </a:r>
             <a:endParaRPr sz="2300">
               <a:solidFill>
@@ -14154,7 +14370,7 @@
                   <a:srgbClr val="1A2433"/>
                 </a:solidFill>
               </a:rPr>
-              <a:t>Keep none/distractor augmentation disabled</a:t>
+              <a:t>Compare the same 256 held-out boards</a:t>
             </a:r>
             <a:endParaRPr sz="2300">
               <a:solidFill>
@@ -14181,7 +14397,29 @@
                   <a:srgbClr val="1A2433"/>
                 </a:solidFill>
               </a:rPr>
-              <a:t>Save recovery and enabled Drive backups</a:t>
+              <a:t>Submit labels, adapter, curves and comparison</a:t>
+            </a:r>
+            <a:endParaRPr sz="2300">
+              <a:solidFill>
+                <a:srgbClr val="1A2433"/>
+              </a:solidFill>
+            </a:endParaRPr>
+          </a:p>
+          <a:p>
+            <a:pPr indent="0" lvl="0" marL="0" marR="0" rtl="0" algn="l">
+              <a:lnSpc>
+                <a:spcPct val="112000"/>
+              </a:lnSpc>
+              <a:spcBef>
+                <a:spcPts val="800"/>
+              </a:spcBef>
+              <a:spcAft>
+                <a:spcPts val="0"/>
+              </a:spcAft>
+              <a:buNone/>
+            </a:pPr>
+            <a:r>
+              <a:t/>
             </a:r>
             <a:endParaRPr sz="2300">
               <a:solidFill>
@@ -14970,7 +15208,7 @@
             <a:tbl>
               <a:tblPr>
                 <a:noFill/>
-                <a:tableStyleId>{7655EB68-0E38-4612-8FD0-F1ACDE5AE169}</a:tableStyleId>
+                <a:tableStyleId>{DEED6AD8-1233-4805-ACC7-B9A81D23648E}</a:tableStyleId>
               </a:tblPr>
               <a:tblGrid>
                 <a:gridCol w="1346200"/>
@@ -16102,7 +16340,7 @@
                 <a:spcPts val="0"/>
               </a:spcBef>
               <a:spcAft>
-                <a:spcPts val="800"/>
+                <a:spcPts val="0"/>
               </a:spcAft>
               <a:buNone/>
             </a:pPr>
@@ -16112,7 +16350,29 @@
                   <a:srgbClr val="111829"/>
                 </a:solidFill>
               </a:rPr>
-              <a:t>CP4: compare the same boards</a:t>
+              <a:t>Evaluate the fine-tuned adapter</a:t>
+            </a:r>
+            <a:endParaRPr b="1" sz="3000">
+              <a:solidFill>
+                <a:srgbClr val="111829"/>
+              </a:solidFill>
+            </a:endParaRPr>
+          </a:p>
+          <a:p>
+            <a:pPr indent="0" lvl="0" marL="0" rtl="0" algn="l">
+              <a:lnSpc>
+                <a:spcPct val="112000"/>
+              </a:lnSpc>
+              <a:spcBef>
+                <a:spcPts val="800"/>
+              </a:spcBef>
+              <a:spcAft>
+                <a:spcPts val="800"/>
+              </a:spcAft>
+              <a:buNone/>
+            </a:pPr>
+            <a:r>
+              <a:t/>
             </a:r>
             <a:endParaRPr b="1" sz="3000">
               <a:solidFill>
@@ -16496,7 +16756,7 @@
                 <a:spcPts val="0"/>
               </a:spcBef>
               <a:spcAft>
-                <a:spcPts val="800"/>
+                <a:spcPts val="0"/>
               </a:spcAft>
               <a:buNone/>
             </a:pPr>
@@ -16506,7 +16766,29 @@
                   <a:srgbClr val="111829"/>
                 </a:solidFill>
               </a:rPr>
-              <a:t>CP4: compare cost and gameplay</a:t>
+              <a:t>Gameplay and compute measurements</a:t>
+            </a:r>
+            <a:endParaRPr b="1" sz="3000">
+              <a:solidFill>
+                <a:srgbClr val="111829"/>
+              </a:solidFill>
+            </a:endParaRPr>
+          </a:p>
+          <a:p>
+            <a:pPr indent="0" lvl="0" marL="0" rtl="0" algn="l">
+              <a:lnSpc>
+                <a:spcPct val="112000"/>
+              </a:lnSpc>
+              <a:spcBef>
+                <a:spcPts val="800"/>
+              </a:spcBef>
+              <a:spcAft>
+                <a:spcPts val="800"/>
+              </a:spcAft>
+              <a:buNone/>
+            </a:pPr>
+            <a:r>
+              <a:t/>
             </a:r>
             <a:endParaRPr b="1" sz="3000">
               <a:solidFill>
@@ -16890,7 +17172,7 @@
                 <a:spcPts val="0"/>
               </a:spcBef>
               <a:spcAft>
-                <a:spcPts val="800"/>
+                <a:spcPts val="0"/>
               </a:spcAft>
               <a:buNone/>
             </a:pPr>
@@ -16900,7 +17182,29 @@
                   <a:srgbClr val="111829"/>
                 </a:solidFill>
               </a:rPr>
-              <a:t>CP5: explain and submit</a:t>
+              <a:t>Checkpoint evidence and submission</a:t>
+            </a:r>
+            <a:endParaRPr b="1" sz="3000">
+              <a:solidFill>
+                <a:srgbClr val="111829"/>
+              </a:solidFill>
+            </a:endParaRPr>
+          </a:p>
+          <a:p>
+            <a:pPr indent="0" lvl="0" marL="0" rtl="0" algn="l">
+              <a:lnSpc>
+                <a:spcPct val="112000"/>
+              </a:lnSpc>
+              <a:spcBef>
+                <a:spcPts val="800"/>
+              </a:spcBef>
+              <a:spcAft>
+                <a:spcPts val="800"/>
+              </a:spcAft>
+              <a:buNone/>
+            </a:pPr>
+            <a:r>
+              <a:t/>
             </a:r>
             <a:endParaRPr b="1" sz="3000">
               <a:solidFill>
@@ -16953,7 +17257,7 @@
                   <a:srgbClr val="1A2433"/>
                 </a:solidFill>
               </a:rPr>
-              <a:t>Explain one changed move and one mistake</a:t>
+              <a:t>Explain one changed move or remaining mistake</a:t>
             </a:r>
             <a:endParaRPr sz="2300">
               <a:solidFill>
@@ -17007,7 +17311,7 @@
                   <a:srgbClr val="1A2433"/>
                 </a:solidFill>
               </a:rPr>
-              <a:t>Save all five adapters and pointer heads</a:t>
+              <a:t>Save the task adapter and available prior stages</a:t>
             </a:r>
             <a:endParaRPr sz="2300">
               <a:solidFill>
@@ -17051,7 +17355,7 @@
                 <a:spcPts val="800"/>
               </a:spcBef>
               <a:spcAft>
-                <a:spcPts val="800"/>
+                <a:spcPts val="0"/>
               </a:spcAft>
               <a:buNone/>
             </a:pPr>
@@ -17062,6 +17366,28 @@
                 </a:solidFill>
               </a:rPr>
               <a:t>Record runtime and actual compute-unit use</a:t>
+            </a:r>
+            <a:endParaRPr sz="2300">
+              <a:solidFill>
+                <a:srgbClr val="1A2433"/>
+              </a:solidFill>
+            </a:endParaRPr>
+          </a:p>
+          <a:p>
+            <a:pPr indent="0" lvl="0" marL="0" marR="0" rtl="0" algn="l">
+              <a:lnSpc>
+                <a:spcPct val="112000"/>
+              </a:lnSpc>
+              <a:spcBef>
+                <a:spcPts val="800"/>
+              </a:spcBef>
+              <a:spcAft>
+                <a:spcPts val="800"/>
+              </a:spcAft>
+              <a:buNone/>
+            </a:pPr>
+            <a:r>
+              <a:t/>
             </a:r>
             <a:endParaRPr sz="2300">
               <a:solidFill>
@@ -17104,7 +17430,7 @@
                 <a:spcPts val="0"/>
               </a:spcBef>
               <a:spcAft>
-                <a:spcPts val="800"/>
+                <a:spcPts val="0"/>
               </a:spcAft>
               <a:buNone/>
             </a:pPr>
@@ -17114,7 +17440,29 @@
                   <a:srgbClr val="5E6E80"/>
                 </a:solidFill>
               </a:rPr>
-              <a:t>Evidence: four general stages, Pac-Man adaptation, paired evaluation</a:t>
+              <a:t>CP1 evidence: reviewed labels, Pac-Man adaptation and paired evaluation.</a:t>
+            </a:r>
+            <a:endParaRPr sz="900">
+              <a:solidFill>
+                <a:srgbClr val="5E6E80"/>
+              </a:solidFill>
+            </a:endParaRPr>
+          </a:p>
+          <a:p>
+            <a:pPr indent="0" lvl="0" marL="0" marR="0" rtl="0" algn="l">
+              <a:lnSpc>
+                <a:spcPct val="112000"/>
+              </a:lnSpc>
+              <a:spcBef>
+                <a:spcPts val="800"/>
+              </a:spcBef>
+              <a:spcAft>
+                <a:spcPts val="800"/>
+              </a:spcAft>
+              <a:buNone/>
+            </a:pPr>
+            <a:r>
+              <a:t/>
             </a:r>
             <a:endParaRPr sz="900">
               <a:solidFill>
@@ -17850,7 +18198,7 @@
             <a:tbl>
               <a:tblPr>
                 <a:noFill/>
-                <a:tableStyleId>{7655EB68-0E38-4612-8FD0-F1ACDE5AE169}</a:tableStyleId>
+                <a:tableStyleId>{DEED6AD8-1233-4805-ACC7-B9A81D23648E}</a:tableStyleId>
               </a:tblPr>
               <a:tblGrid>
                 <a:gridCol w="1346200"/>
@@ -19176,7 +19524,7 @@
             <a:tbl>
               <a:tblPr>
                 <a:noFill/>
-                <a:tableStyleId>{7655EB68-0E38-4612-8FD0-F1ACDE5AE169}</a:tableStyleId>
+                <a:tableStyleId>{DEED6AD8-1233-4805-ACC7-B9A81D23648E}</a:tableStyleId>
               </a:tblPr>
               <a:tblGrid>
                 <a:gridCol w="1346200"/>
@@ -20502,7 +20850,7 @@
             <a:tbl>
               <a:tblPr>
                 <a:noFill/>
-                <a:tableStyleId>{7655EB68-0E38-4612-8FD0-F1ACDE5AE169}</a:tableStyleId>
+                <a:tableStyleId>{DEED6AD8-1233-4805-ACC7-B9A81D23648E}</a:tableStyleId>
               </a:tblPr>
               <a:tblGrid>
                 <a:gridCol w="2146300"/>
@@ -21828,7 +22176,7 @@
             <a:tbl>
               <a:tblPr>
                 <a:noFill/>
-                <a:tableStyleId>{7655EB68-0E38-4612-8FD0-F1ACDE5AE169}</a:tableStyleId>
+                <a:tableStyleId>{DEED6AD8-1233-4805-ACC7-B9A81D23648E}</a:tableStyleId>
               </a:tblPr>
               <a:tblGrid>
                 <a:gridCol w="1041400"/>
@@ -25200,6 +25548,285 @@
 </file>
 
 <file path=ppt/theme/theme1.xml><?xml version="1.0" encoding="utf-8"?>
+<a:theme xmlns:a="http://schemas.openxmlformats.org/drawingml/2006/main" xmlns:r="http://schemas.openxmlformats.org/officeDocument/2006/relationships" name="Simple Light">
+  <a:themeElements>
+    <a:clrScheme name="Simple Light">
+      <a:dk1>
+        <a:srgbClr val="000000"/>
+      </a:dk1>
+      <a:lt1>
+        <a:srgbClr val="FFFFFF"/>
+      </a:lt1>
+      <a:dk2>
+        <a:srgbClr val="595959"/>
+      </a:dk2>
+      <a:lt2>
+        <a:srgbClr val="EEEEEE"/>
+      </a:lt2>
+      <a:accent1>
+        <a:srgbClr val="4285F4"/>
+      </a:accent1>
+      <a:accent2>
+        <a:srgbClr val="212121"/>
+      </a:accent2>
+      <a:accent3>
+        <a:srgbClr val="78909C"/>
+      </a:accent3>
+      <a:accent4>
+        <a:srgbClr val="FFAB40"/>
+      </a:accent4>
+      <a:accent5>
+        <a:srgbClr val="0097A7"/>
+      </a:accent5>
+      <a:accent6>
+        <a:srgbClr val="EEFF41"/>
+      </a:accent6>
+      <a:hlink>
+        <a:srgbClr val="0097A7"/>
+      </a:hlink>
+      <a:folHlink>
+        <a:srgbClr val="0097A7"/>
+      </a:folHlink>
+    </a:clrScheme>
+    <a:fontScheme name="Office">
+      <a:majorFont>
+        <a:latin typeface="Arial"/>
+        <a:ea typeface=""/>
+        <a:cs typeface=""/>
+        <a:font script="Jpan" typeface="ＭＳ Ｐゴシック"/>
+        <a:font script="Hang" typeface="맑은 고딕"/>
+        <a:font script="Hans" typeface="宋体"/>
+        <a:font script="Hant" typeface="新細明體"/>
+        <a:font script="Arab" typeface="Times New Roman"/>
+        <a:font script="Hebr" typeface="Times New Roman"/>
+        <a:font script="Thai" typeface="Angsana New"/>
+        <a:font script="Ethi" typeface="Nyala"/>
+        <a:font script="Beng" typeface="Vrinda"/>
+        <a:font script="Gujr" typeface="Shruti"/>
+        <a:font script="Khmr" typeface="MoolBoran"/>
+        <a:font script="Knda" typeface="Tunga"/>
+        <a:font script="Guru" typeface="Raavi"/>
+        <a:font script="Cans" typeface="Euphemia"/>
+        <a:font script="Cher" typeface="Plantagenet Cherokee"/>
+        <a:font script="Yiii" typeface="Microsoft Yi Baiti"/>
+        <a:font script="Tibt" typeface="Microsoft Himalaya"/>
+        <a:font script="Thaa" typeface="MV Boli"/>
+        <a:font script="Deva" typeface="Mangal"/>
+        <a:font script="Telu" typeface="Gautami"/>
+        <a:font script="Taml" typeface="Latha"/>
+        <a:font script="Syrc" typeface="Estrangelo Edessa"/>
+        <a:font script="Orya" typeface="Kalinga"/>
+        <a:font script="Mlym" typeface="Kartika"/>
+        <a:font script="Laoo" typeface="DokChampa"/>
+        <a:font script="Sinh" typeface="Iskoola Pota"/>
+        <a:font script="Mong" typeface="Mongolian Baiti"/>
+        <a:font script="Viet" typeface="Times New Roman"/>
+        <a:font script="Uigh" typeface="Microsoft Uighur"/>
+        <a:font script="Geor" typeface="Sylfaen"/>
+      </a:majorFont>
+      <a:minorFont>
+        <a:latin typeface="Arial"/>
+        <a:ea typeface=""/>
+        <a:cs typeface=""/>
+        <a:font script="Jpan" typeface="ＭＳ Ｐゴシック"/>
+        <a:font script="Hang" typeface="맑은 고딕"/>
+        <a:font script="Hans" typeface="宋体"/>
+        <a:font script="Hant" typeface="新細明體"/>
+        <a:font script="Arab" typeface="Arial"/>
+        <a:font script="Hebr" typeface="Arial"/>
+        <a:font script="Thai" typeface="Cordia New"/>
+        <a:font script="Ethi" typeface="Nyala"/>
+        <a:font script="Beng" typeface="Vrinda"/>
+        <a:font script="Gujr" typeface="Shruti"/>
+        <a:font script="Khmr" typeface="DaunPenh"/>
+        <a:font script="Knda" typeface="Tunga"/>
+        <a:font script="Guru" typeface="Raavi"/>
+        <a:font script="Cans" typeface="Euphemia"/>
+        <a:font script="Cher" typeface="Plantagenet Cherokee"/>
+        <a:font script="Yiii" typeface="Microsoft Yi Baiti"/>
+        <a:font script="Tibt" typeface="Microsoft Himalaya"/>
+        <a:font script="Thaa" typeface="MV Boli"/>
+        <a:font script="Deva" typeface="Mangal"/>
+        <a:font script="Telu" typeface="Gautami"/>
+        <a:font script="Taml" typeface="Latha"/>
+        <a:font script="Syrc" typeface="Estrangelo Edessa"/>
+        <a:font script="Orya" typeface="Kalinga"/>
+        <a:font script="Mlym" typeface="Kartika"/>
+        <a:font script="Laoo" typeface="DokChampa"/>
+        <a:font script="Sinh" typeface="Iskoola Pota"/>
+        <a:font script="Mong" typeface="Mongolian Baiti"/>
+        <a:font script="Viet" typeface="Arial"/>
+        <a:font script="Uigh" typeface="Microsoft Uighur"/>
+        <a:font script="Geor" typeface="Sylfaen"/>
+      </a:minorFont>
+    </a:fontScheme>
+    <a:fmtScheme name="Office">
+      <a:fillStyleLst>
+        <a:solidFill>
+          <a:schemeClr val="phClr"/>
+        </a:solidFill>
+        <a:gradFill rotWithShape="1">
+          <a:gsLst>
+            <a:gs pos="0">
+              <a:schemeClr val="phClr">
+                <a:tint val="50000"/>
+                <a:satMod val="300000"/>
+              </a:schemeClr>
+            </a:gs>
+            <a:gs pos="35000">
+              <a:schemeClr val="phClr">
+                <a:tint val="37000"/>
+                <a:satMod val="300000"/>
+              </a:schemeClr>
+            </a:gs>
+            <a:gs pos="100000">
+              <a:schemeClr val="phClr">
+                <a:tint val="15000"/>
+                <a:satMod val="350000"/>
+              </a:schemeClr>
+            </a:gs>
+          </a:gsLst>
+          <a:lin ang="16200000" scaled="1"/>
+        </a:gradFill>
+        <a:gradFill rotWithShape="1">
+          <a:gsLst>
+            <a:gs pos="0">
+              <a:schemeClr val="phClr">
+                <a:tint val="100000"/>
+                <a:shade val="100000"/>
+                <a:satMod val="130000"/>
+              </a:schemeClr>
+            </a:gs>
+            <a:gs pos="100000">
+              <a:schemeClr val="phClr">
+                <a:tint val="50000"/>
+                <a:shade val="100000"/>
+                <a:satMod val="350000"/>
+              </a:schemeClr>
+            </a:gs>
+          </a:gsLst>
+          <a:lin ang="16200000" scaled="0"/>
+        </a:gradFill>
+      </a:fillStyleLst>
+      <a:lnStyleLst>
+        <a:ln w="9525" cap="flat" cmpd="sng" algn="ctr">
+          <a:solidFill>
+            <a:schemeClr val="phClr">
+              <a:shade val="95000"/>
+              <a:satMod val="105000"/>
+            </a:schemeClr>
+          </a:solidFill>
+          <a:prstDash val="solid"/>
+        </a:ln>
+        <a:ln w="25400" cap="flat" cmpd="sng" algn="ctr">
+          <a:solidFill>
+            <a:schemeClr val="phClr"/>
+          </a:solidFill>
+          <a:prstDash val="solid"/>
+        </a:ln>
+        <a:ln w="38100" cap="flat" cmpd="sng" algn="ctr">
+          <a:solidFill>
+            <a:schemeClr val="phClr"/>
+          </a:solidFill>
+          <a:prstDash val="solid"/>
+        </a:ln>
+      </a:lnStyleLst>
+      <a:effectStyleLst>
+        <a:effectStyle>
+          <a:effectLst>
+            <a:outerShdw blurRad="40000" dist="20000" dir="5400000" rotWithShape="0">
+              <a:srgbClr val="000000">
+                <a:alpha val="38000"/>
+              </a:srgbClr>
+            </a:outerShdw>
+          </a:effectLst>
+        </a:effectStyle>
+        <a:effectStyle>
+          <a:effectLst>
+            <a:outerShdw blurRad="40000" dist="23000" dir="5400000" rotWithShape="0">
+              <a:srgbClr val="000000">
+                <a:alpha val="35000"/>
+              </a:srgbClr>
+            </a:outerShdw>
+          </a:effectLst>
+        </a:effectStyle>
+        <a:effectStyle>
+          <a:effectLst>
+            <a:outerShdw blurRad="40000" dist="23000" dir="5400000" rotWithShape="0">
+              <a:srgbClr val="000000">
+                <a:alpha val="35000"/>
+              </a:srgbClr>
+            </a:outerShdw>
+          </a:effectLst>
+          <a:scene3d>
+            <a:camera prst="orthographicFront">
+              <a:rot lat="0" lon="0" rev="0"/>
+            </a:camera>
+            <a:lightRig rig="threePt" dir="t">
+              <a:rot lat="0" lon="0" rev="1200000"/>
+            </a:lightRig>
+          </a:scene3d>
+          <a:sp3d>
+            <a:bevelT w="63500" h="25400"/>
+          </a:sp3d>
+        </a:effectStyle>
+      </a:effectStyleLst>
+      <a:bgFillStyleLst>
+        <a:solidFill>
+          <a:schemeClr val="phClr"/>
+        </a:solidFill>
+        <a:gradFill rotWithShape="1">
+          <a:gsLst>
+            <a:gs pos="0">
+              <a:schemeClr val="phClr">
+                <a:tint val="40000"/>
+                <a:satMod val="350000"/>
+              </a:schemeClr>
+            </a:gs>
+            <a:gs pos="40000">
+              <a:schemeClr val="phClr">
+                <a:tint val="45000"/>
+                <a:shade val="99000"/>
+                <a:satMod val="350000"/>
+              </a:schemeClr>
+            </a:gs>
+            <a:gs pos="100000">
+              <a:schemeClr val="phClr">
+                <a:shade val="20000"/>
+                <a:satMod val="255000"/>
+              </a:schemeClr>
+            </a:gs>
+          </a:gsLst>
+          <a:path path="circle">
+            <a:fillToRect l="50000" t="-80000" r="50000" b="180000"/>
+          </a:path>
+        </a:gradFill>
+        <a:gradFill rotWithShape="1">
+          <a:gsLst>
+            <a:gs pos="0">
+              <a:schemeClr val="phClr">
+                <a:tint val="80000"/>
+                <a:satMod val="300000"/>
+              </a:schemeClr>
+            </a:gs>
+            <a:gs pos="100000">
+              <a:schemeClr val="phClr">
+                <a:shade val="30000"/>
+                <a:satMod val="200000"/>
+              </a:schemeClr>
+            </a:gs>
+          </a:gsLst>
+          <a:path path="circle">
+            <a:fillToRect l="50000" t="50000" r="50000" b="50000"/>
+          </a:path>
+        </a:gradFill>
+      </a:bgFillStyleLst>
+    </a:fmtScheme>
+  </a:themeElements>
+</a:theme>
+</file>
+
+<file path=ppt/theme/theme2.xml><?xml version="1.0" encoding="utf-8"?>
 <a:theme xmlns:a="http://schemas.openxmlformats.org/drawingml/2006/main" xmlns:r="http://schemas.openxmlformats.org/officeDocument/2006/relationships">
   <a:themeElements>
     <a:clrScheme name="Default">
@@ -25476,283 +26103,4 @@
     </a:fmtScheme>
   </a:themeElements>
 </a:theme>
-</file>
-
-<file path=ppt/theme/theme2.xml><?xml version="1.0" encoding="utf-8"?>
-<a:theme xmlns:a="http://schemas.openxmlformats.org/drawingml/2006/main" xmlns:r="http://schemas.openxmlformats.org/officeDocument/2006/relationships" name="Simple Light">
-  <a:themeElements>
-    <a:clrScheme name="Simple Light">
-      <a:dk1>
-        <a:srgbClr val="000000"/>
-      </a:dk1>
-      <a:lt1>
-        <a:srgbClr val="FFFFFF"/>
-      </a:lt1>
-      <a:dk2>
-        <a:srgbClr val="595959"/>
-      </a:dk2>
-      <a:lt2>
-        <a:srgbClr val="EEEEEE"/>
-      </a:lt2>
-      <a:accent1>
-        <a:srgbClr val="4285F4"/>
-      </a:accent1>
-      <a:accent2>
-        <a:srgbClr val="212121"/>
-      </a:accent2>
-      <a:accent3>
-        <a:srgbClr val="78909C"/>
-      </a:accent3>
-      <a:accent4>
-        <a:srgbClr val="FFAB40"/>
-      </a:accent4>
-      <a:accent5>
-        <a:srgbClr val="0097A7"/>
-      </a:accent5>
-      <a:accent6>
-        <a:srgbClr val="EEFF41"/>
-      </a:accent6>
-      <a:hlink>
-        <a:srgbClr val="0097A7"/>
-      </a:hlink>
-      <a:folHlink>
-        <a:srgbClr val="0097A7"/>
-      </a:folHlink>
-    </a:clrScheme>
-    <a:fontScheme name="Office">
-      <a:majorFont>
-        <a:latin typeface="Arial"/>
-        <a:ea typeface=""/>
-        <a:cs typeface=""/>
-        <a:font script="Jpan" typeface="ＭＳ Ｐゴシック"/>
-        <a:font script="Hang" typeface="맑은 고딕"/>
-        <a:font script="Hans" typeface="宋体"/>
-        <a:font script="Hant" typeface="新細明體"/>
-        <a:font script="Arab" typeface="Times New Roman"/>
-        <a:font script="Hebr" typeface="Times New Roman"/>
-        <a:font script="Thai" typeface="Angsana New"/>
-        <a:font script="Ethi" typeface="Nyala"/>
-        <a:font script="Beng" typeface="Vrinda"/>
-        <a:font script="Gujr" typeface="Shruti"/>
-        <a:font script="Khmr" typeface="MoolBoran"/>
-        <a:font script="Knda" typeface="Tunga"/>
-        <a:font script="Guru" typeface="Raavi"/>
-        <a:font script="Cans" typeface="Euphemia"/>
-        <a:font script="Cher" typeface="Plantagenet Cherokee"/>
-        <a:font script="Yiii" typeface="Microsoft Yi Baiti"/>
-        <a:font script="Tibt" typeface="Microsoft Himalaya"/>
-        <a:font script="Thaa" typeface="MV Boli"/>
-        <a:font script="Deva" typeface="Mangal"/>
-        <a:font script="Telu" typeface="Gautami"/>
-        <a:font script="Taml" typeface="Latha"/>
-        <a:font script="Syrc" typeface="Estrangelo Edessa"/>
-        <a:font script="Orya" typeface="Kalinga"/>
-        <a:font script="Mlym" typeface="Kartika"/>
-        <a:font script="Laoo" typeface="DokChampa"/>
-        <a:font script="Sinh" typeface="Iskoola Pota"/>
-        <a:font script="Mong" typeface="Mongolian Baiti"/>
-        <a:font script="Viet" typeface="Times New Roman"/>
-        <a:font script="Uigh" typeface="Microsoft Uighur"/>
-        <a:font script="Geor" typeface="Sylfaen"/>
-      </a:majorFont>
-      <a:minorFont>
-        <a:latin typeface="Arial"/>
-        <a:ea typeface=""/>
-        <a:cs typeface=""/>
-        <a:font script="Jpan" typeface="ＭＳ Ｐゴシック"/>
-        <a:font script="Hang" typeface="맑은 고딕"/>
-        <a:font script="Hans" typeface="宋体"/>
-        <a:font script="Hant" typeface="新細明體"/>
-        <a:font script="Arab" typeface="Arial"/>
-        <a:font script="Hebr" typeface="Arial"/>
-        <a:font script="Thai" typeface="Cordia New"/>
-        <a:font script="Ethi" typeface="Nyala"/>
-        <a:font script="Beng" typeface="Vrinda"/>
-        <a:font script="Gujr" typeface="Shruti"/>
-        <a:font script="Khmr" typeface="DaunPenh"/>
-        <a:font script="Knda" typeface="Tunga"/>
-        <a:font script="Guru" typeface="Raavi"/>
-        <a:font script="Cans" typeface="Euphemia"/>
-        <a:font script="Cher" typeface="Plantagenet Cherokee"/>
-        <a:font script="Yiii" typeface="Microsoft Yi Baiti"/>
-        <a:font script="Tibt" typeface="Microsoft Himalaya"/>
-        <a:font script="Thaa" typeface="MV Boli"/>
-        <a:font script="Deva" typeface="Mangal"/>
-        <a:font script="Telu" typeface="Gautami"/>
-        <a:font script="Taml" typeface="Latha"/>
-        <a:font script="Syrc" typeface="Estrangelo Edessa"/>
-        <a:font script="Orya" typeface="Kalinga"/>
-        <a:font script="Mlym" typeface="Kartika"/>
-        <a:font script="Laoo" typeface="DokChampa"/>
-        <a:font script="Sinh" typeface="Iskoola Pota"/>
-        <a:font script="Mong" typeface="Mongolian Baiti"/>
-        <a:font script="Viet" typeface="Arial"/>
-        <a:font script="Uigh" typeface="Microsoft Uighur"/>
-        <a:font script="Geor" typeface="Sylfaen"/>
-      </a:minorFont>
-    </a:fontScheme>
-    <a:fmtScheme name="Office">
-      <a:fillStyleLst>
-        <a:solidFill>
-          <a:schemeClr val="phClr"/>
-        </a:solidFill>
-        <a:gradFill rotWithShape="1">
-          <a:gsLst>
-            <a:gs pos="0">
-              <a:schemeClr val="phClr">
-                <a:tint val="50000"/>
-                <a:satMod val="300000"/>
-              </a:schemeClr>
-            </a:gs>
-            <a:gs pos="35000">
-              <a:schemeClr val="phClr">
-                <a:tint val="37000"/>
-                <a:satMod val="300000"/>
-              </a:schemeClr>
-            </a:gs>
-            <a:gs pos="100000">
-              <a:schemeClr val="phClr">
-                <a:tint val="15000"/>
-                <a:satMod val="350000"/>
-              </a:schemeClr>
-            </a:gs>
-          </a:gsLst>
-          <a:lin ang="16200000" scaled="1"/>
-        </a:gradFill>
-        <a:gradFill rotWithShape="1">
-          <a:gsLst>
-            <a:gs pos="0">
-              <a:schemeClr val="phClr">
-                <a:tint val="100000"/>
-                <a:shade val="100000"/>
-                <a:satMod val="130000"/>
-              </a:schemeClr>
-            </a:gs>
-            <a:gs pos="100000">
-              <a:schemeClr val="phClr">
-                <a:tint val="50000"/>
-                <a:shade val="100000"/>
-                <a:satMod val="350000"/>
-              </a:schemeClr>
-            </a:gs>
-          </a:gsLst>
-          <a:lin ang="16200000" scaled="0"/>
-        </a:gradFill>
-      </a:fillStyleLst>
-      <a:lnStyleLst>
-        <a:ln w="9525" cap="flat" cmpd="sng" algn="ctr">
-          <a:solidFill>
-            <a:schemeClr val="phClr">
-              <a:shade val="95000"/>
-              <a:satMod val="105000"/>
-            </a:schemeClr>
-          </a:solidFill>
-          <a:prstDash val="solid"/>
-        </a:ln>
-        <a:ln w="25400" cap="flat" cmpd="sng" algn="ctr">
-          <a:solidFill>
-            <a:schemeClr val="phClr"/>
-          </a:solidFill>
-          <a:prstDash val="solid"/>
-        </a:ln>
-        <a:ln w="38100" cap="flat" cmpd="sng" algn="ctr">
-          <a:solidFill>
-            <a:schemeClr val="phClr"/>
-          </a:solidFill>
-          <a:prstDash val="solid"/>
-        </a:ln>
-      </a:lnStyleLst>
-      <a:effectStyleLst>
-        <a:effectStyle>
-          <a:effectLst>
-            <a:outerShdw blurRad="40000" dist="20000" dir="5400000" rotWithShape="0">
-              <a:srgbClr val="000000">
-                <a:alpha val="38000"/>
-              </a:srgbClr>
-            </a:outerShdw>
-          </a:effectLst>
-        </a:effectStyle>
-        <a:effectStyle>
-          <a:effectLst>
-            <a:outerShdw blurRad="40000" dist="23000" dir="5400000" rotWithShape="0">
-              <a:srgbClr val="000000">
-                <a:alpha val="35000"/>
-              </a:srgbClr>
-            </a:outerShdw>
-          </a:effectLst>
-        </a:effectStyle>
-        <a:effectStyle>
-          <a:effectLst>
-            <a:outerShdw blurRad="40000" dist="23000" dir="5400000" rotWithShape="0">
-              <a:srgbClr val="000000">
-                <a:alpha val="35000"/>
-              </a:srgbClr>
-            </a:outerShdw>
-          </a:effectLst>
-          <a:scene3d>
-            <a:camera prst="orthographicFront">
-              <a:rot lat="0" lon="0" rev="0"/>
-            </a:camera>
-            <a:lightRig rig="threePt" dir="t">
-              <a:rot lat="0" lon="0" rev="1200000"/>
-            </a:lightRig>
-          </a:scene3d>
-          <a:sp3d>
-            <a:bevelT w="63500" h="25400"/>
-          </a:sp3d>
-        </a:effectStyle>
-      </a:effectStyleLst>
-      <a:bgFillStyleLst>
-        <a:solidFill>
-          <a:schemeClr val="phClr"/>
-        </a:solidFill>
-        <a:gradFill rotWithShape="1">
-          <a:gsLst>
-            <a:gs pos="0">
-              <a:schemeClr val="phClr">
-                <a:tint val="40000"/>
-                <a:satMod val="350000"/>
-              </a:schemeClr>
-            </a:gs>
-            <a:gs pos="40000">
-              <a:schemeClr val="phClr">
-                <a:tint val="45000"/>
-                <a:shade val="99000"/>
-                <a:satMod val="350000"/>
-              </a:schemeClr>
-            </a:gs>
-            <a:gs pos="100000">
-              <a:schemeClr val="phClr">
-                <a:shade val="20000"/>
-                <a:satMod val="255000"/>
-              </a:schemeClr>
-            </a:gs>
-          </a:gsLst>
-          <a:path path="circle">
-            <a:fillToRect l="50000" t="-80000" r="50000" b="180000"/>
-          </a:path>
-        </a:gradFill>
-        <a:gradFill rotWithShape="1">
-          <a:gsLst>
-            <a:gs pos="0">
-              <a:schemeClr val="phClr">
-                <a:tint val="80000"/>
-                <a:satMod val="300000"/>
-              </a:schemeClr>
-            </a:gs>
-            <a:gs pos="100000">
-              <a:schemeClr val="phClr">
-                <a:shade val="30000"/>
-                <a:satMod val="200000"/>
-              </a:schemeClr>
-            </a:gs>
-          </a:gsLst>
-          <a:path path="circle">
-            <a:fillToRect l="50000" t="50000" r="50000" b="50000"/>
-          </a:path>
-        </a:gradFill>
-      </a:bgFillStyleLst>
-    </a:fmtScheme>
-  </a:themeElements>
-</a:theme>
 </file>
</xml_diff>